<commit_message>
Use dark blue CocoRobo logos throughout the education-purpose lecture
Update all 36 PowerPoint slides and synchronized web assets to #003B70.
</commit_message>
<xml_diff>
--- a/education-purpose-ai-2026/downloads/AI_Education_Purpose_36slides.pptx
+++ b/education-purpose-ai-2026/downloads/AI_Education_Purpose_36slides.pptx
@@ -2,48 +2,48 @@
 <file path=ppt/presentation.xml><?xml version="1.0" encoding="utf-8"?>
 <p:presentation xmlns:p="http://schemas.openxmlformats.org/presentationml/2006/main">
   <p:sldMasterIdLst>
-    <p:sldMasterId xmlns:r="http://schemas.openxmlformats.org/officeDocument/2006/relationships" id="2147483648" r:id="Re1eda1e7e4754ec6"/>
+    <p:sldMasterId xmlns:r="http://schemas.openxmlformats.org/officeDocument/2006/relationships" id="2147483648" r:id="Rd6f5bcc8bba54f9b"/>
   </p:sldMasterIdLst>
   <p:notesMasterIdLst>
-    <p:notesMasterId xmlns:r="http://schemas.openxmlformats.org/officeDocument/2006/relationships" r:id="Rdf98ad3fe2434ee9"/>
+    <p:notesMasterId xmlns:r="http://schemas.openxmlformats.org/officeDocument/2006/relationships" r:id="Rc9729e2bc1af4b32"/>
   </p:notesMasterIdLst>
   <p:sldIdLst>
-    <p:sldId xmlns:r="http://schemas.openxmlformats.org/officeDocument/2006/relationships" id="256" r:id="Re80606e70ac74714"/>
-    <p:sldId xmlns:r="http://schemas.openxmlformats.org/officeDocument/2006/relationships" id="257" r:id="R4e76520f3ed842a1"/>
-    <p:sldId xmlns:r="http://schemas.openxmlformats.org/officeDocument/2006/relationships" id="258" r:id="R20f92a34d244467a"/>
-    <p:sldId xmlns:r="http://schemas.openxmlformats.org/officeDocument/2006/relationships" id="259" r:id="R077f1fbdc2604b37"/>
-    <p:sldId xmlns:r="http://schemas.openxmlformats.org/officeDocument/2006/relationships" id="260" r:id="R2091f62892fd4aba"/>
-    <p:sldId xmlns:r="http://schemas.openxmlformats.org/officeDocument/2006/relationships" id="261" r:id="R9316a71345914302"/>
-    <p:sldId xmlns:r="http://schemas.openxmlformats.org/officeDocument/2006/relationships" id="262" r:id="Rd71908f781904816"/>
-    <p:sldId xmlns:r="http://schemas.openxmlformats.org/officeDocument/2006/relationships" id="263" r:id="R5f9c37e89d0a46b8"/>
-    <p:sldId xmlns:r="http://schemas.openxmlformats.org/officeDocument/2006/relationships" id="264" r:id="R490951cde9cc4705"/>
-    <p:sldId xmlns:r="http://schemas.openxmlformats.org/officeDocument/2006/relationships" id="265" r:id="Rc853470967814c88"/>
-    <p:sldId xmlns:r="http://schemas.openxmlformats.org/officeDocument/2006/relationships" id="266" r:id="Rbdfbf47468564e4c"/>
-    <p:sldId xmlns:r="http://schemas.openxmlformats.org/officeDocument/2006/relationships" id="267" r:id="R7dc43e684b5f4915"/>
-    <p:sldId xmlns:r="http://schemas.openxmlformats.org/officeDocument/2006/relationships" id="268" r:id="R664bef5a169f410c"/>
-    <p:sldId xmlns:r="http://schemas.openxmlformats.org/officeDocument/2006/relationships" id="269" r:id="R80a46c35b10f4c41"/>
-    <p:sldId xmlns:r="http://schemas.openxmlformats.org/officeDocument/2006/relationships" id="270" r:id="Reac767f7c0cc41f1"/>
-    <p:sldId xmlns:r="http://schemas.openxmlformats.org/officeDocument/2006/relationships" id="271" r:id="R91cc4830f4da43f1"/>
-    <p:sldId xmlns:r="http://schemas.openxmlformats.org/officeDocument/2006/relationships" id="272" r:id="R0e6b94e327004658"/>
-    <p:sldId xmlns:r="http://schemas.openxmlformats.org/officeDocument/2006/relationships" id="273" r:id="R9fc7c25c9743411c"/>
-    <p:sldId xmlns:r="http://schemas.openxmlformats.org/officeDocument/2006/relationships" id="274" r:id="Re94ec7e39d4e4ec2"/>
-    <p:sldId xmlns:r="http://schemas.openxmlformats.org/officeDocument/2006/relationships" id="275" r:id="R2718e1be400244de"/>
-    <p:sldId xmlns:r="http://schemas.openxmlformats.org/officeDocument/2006/relationships" id="276" r:id="R4782c475acaa47ff"/>
-    <p:sldId xmlns:r="http://schemas.openxmlformats.org/officeDocument/2006/relationships" id="277" r:id="R6a91ca65e1fa458a"/>
-    <p:sldId xmlns:r="http://schemas.openxmlformats.org/officeDocument/2006/relationships" id="278" r:id="R21170df054b7464f"/>
-    <p:sldId xmlns:r="http://schemas.openxmlformats.org/officeDocument/2006/relationships" id="279" r:id="R59c1cdfb70b84128"/>
-    <p:sldId xmlns:r="http://schemas.openxmlformats.org/officeDocument/2006/relationships" id="280" r:id="R0e7039ccf25f4e1d"/>
-    <p:sldId xmlns:r="http://schemas.openxmlformats.org/officeDocument/2006/relationships" id="281" r:id="Rcf735e91075f4d9f"/>
-    <p:sldId xmlns:r="http://schemas.openxmlformats.org/officeDocument/2006/relationships" id="282" r:id="Ra31a46bb7890484b"/>
-    <p:sldId xmlns:r="http://schemas.openxmlformats.org/officeDocument/2006/relationships" id="283" r:id="R557cce0ddc944cb0"/>
-    <p:sldId xmlns:r="http://schemas.openxmlformats.org/officeDocument/2006/relationships" id="284" r:id="Rdc8ecbfd95da4e84"/>
-    <p:sldId xmlns:r="http://schemas.openxmlformats.org/officeDocument/2006/relationships" id="285" r:id="R64c9fc93cc824055"/>
-    <p:sldId xmlns:r="http://schemas.openxmlformats.org/officeDocument/2006/relationships" id="286" r:id="R24242ff246f44a3a"/>
-    <p:sldId xmlns:r="http://schemas.openxmlformats.org/officeDocument/2006/relationships" id="287" r:id="R3aea4f657a8b4231"/>
-    <p:sldId xmlns:r="http://schemas.openxmlformats.org/officeDocument/2006/relationships" id="288" r:id="R6990d679ac424229"/>
-    <p:sldId xmlns:r="http://schemas.openxmlformats.org/officeDocument/2006/relationships" id="289" r:id="R3a74bb856a174ce2"/>
-    <p:sldId xmlns:r="http://schemas.openxmlformats.org/officeDocument/2006/relationships" id="290" r:id="Rabced33c0d164432"/>
-    <p:sldId xmlns:r="http://schemas.openxmlformats.org/officeDocument/2006/relationships" id="291" r:id="Rd851311bfc884646"/>
+    <p:sldId xmlns:r="http://schemas.openxmlformats.org/officeDocument/2006/relationships" id="256" r:id="Rfdfa91275e984157"/>
+    <p:sldId xmlns:r="http://schemas.openxmlformats.org/officeDocument/2006/relationships" id="257" r:id="R05ed22eb62d341b4"/>
+    <p:sldId xmlns:r="http://schemas.openxmlformats.org/officeDocument/2006/relationships" id="258" r:id="Rd26ef5dad59946c4"/>
+    <p:sldId xmlns:r="http://schemas.openxmlformats.org/officeDocument/2006/relationships" id="259" r:id="Re519fcf5a5a24df2"/>
+    <p:sldId xmlns:r="http://schemas.openxmlformats.org/officeDocument/2006/relationships" id="260" r:id="Rbc51e1821c74460d"/>
+    <p:sldId xmlns:r="http://schemas.openxmlformats.org/officeDocument/2006/relationships" id="261" r:id="R2f0c6adbd29347fe"/>
+    <p:sldId xmlns:r="http://schemas.openxmlformats.org/officeDocument/2006/relationships" id="262" r:id="Rb6faca7f0a5c483b"/>
+    <p:sldId xmlns:r="http://schemas.openxmlformats.org/officeDocument/2006/relationships" id="263" r:id="Rba90cfd2644448f7"/>
+    <p:sldId xmlns:r="http://schemas.openxmlformats.org/officeDocument/2006/relationships" id="264" r:id="Rea70722c85364f8e"/>
+    <p:sldId xmlns:r="http://schemas.openxmlformats.org/officeDocument/2006/relationships" id="265" r:id="R77d4fec2fa56450c"/>
+    <p:sldId xmlns:r="http://schemas.openxmlformats.org/officeDocument/2006/relationships" id="266" r:id="R545f041c0e904e37"/>
+    <p:sldId xmlns:r="http://schemas.openxmlformats.org/officeDocument/2006/relationships" id="267" r:id="R57b70f7dd3dd40be"/>
+    <p:sldId xmlns:r="http://schemas.openxmlformats.org/officeDocument/2006/relationships" id="268" r:id="R979c3e0632ca491d"/>
+    <p:sldId xmlns:r="http://schemas.openxmlformats.org/officeDocument/2006/relationships" id="269" r:id="R2bc1b52b198b41e4"/>
+    <p:sldId xmlns:r="http://schemas.openxmlformats.org/officeDocument/2006/relationships" id="270" r:id="R630cdeaba0f6485c"/>
+    <p:sldId xmlns:r="http://schemas.openxmlformats.org/officeDocument/2006/relationships" id="271" r:id="Rb502cce6f565418f"/>
+    <p:sldId xmlns:r="http://schemas.openxmlformats.org/officeDocument/2006/relationships" id="272" r:id="Re9dd9172bd4e4951"/>
+    <p:sldId xmlns:r="http://schemas.openxmlformats.org/officeDocument/2006/relationships" id="273" r:id="Ra2f9c0a570704806"/>
+    <p:sldId xmlns:r="http://schemas.openxmlformats.org/officeDocument/2006/relationships" id="274" r:id="R0343c78dcbba46b0"/>
+    <p:sldId xmlns:r="http://schemas.openxmlformats.org/officeDocument/2006/relationships" id="275" r:id="Ra4e8bee4af1644f7"/>
+    <p:sldId xmlns:r="http://schemas.openxmlformats.org/officeDocument/2006/relationships" id="276" r:id="R0d346bf990514632"/>
+    <p:sldId xmlns:r="http://schemas.openxmlformats.org/officeDocument/2006/relationships" id="277" r:id="Rc2a670a00f244830"/>
+    <p:sldId xmlns:r="http://schemas.openxmlformats.org/officeDocument/2006/relationships" id="278" r:id="R3bc03204853245e9"/>
+    <p:sldId xmlns:r="http://schemas.openxmlformats.org/officeDocument/2006/relationships" id="279" r:id="Rc77e435ad5c840f8"/>
+    <p:sldId xmlns:r="http://schemas.openxmlformats.org/officeDocument/2006/relationships" id="280" r:id="R361495277a4e49e6"/>
+    <p:sldId xmlns:r="http://schemas.openxmlformats.org/officeDocument/2006/relationships" id="281" r:id="Rb02b6016b8b2452e"/>
+    <p:sldId xmlns:r="http://schemas.openxmlformats.org/officeDocument/2006/relationships" id="282" r:id="R2e34a8fb34984fe9"/>
+    <p:sldId xmlns:r="http://schemas.openxmlformats.org/officeDocument/2006/relationships" id="283" r:id="R4288199df81d4a68"/>
+    <p:sldId xmlns:r="http://schemas.openxmlformats.org/officeDocument/2006/relationships" id="284" r:id="R99c83f51dbdb4df0"/>
+    <p:sldId xmlns:r="http://schemas.openxmlformats.org/officeDocument/2006/relationships" id="285" r:id="Rce0eba6dc63d46a9"/>
+    <p:sldId xmlns:r="http://schemas.openxmlformats.org/officeDocument/2006/relationships" id="286" r:id="R6352afb7f12a477e"/>
+    <p:sldId xmlns:r="http://schemas.openxmlformats.org/officeDocument/2006/relationships" id="287" r:id="R7c508f8fa20d447b"/>
+    <p:sldId xmlns:r="http://schemas.openxmlformats.org/officeDocument/2006/relationships" id="288" r:id="R9b45078fe54e4997"/>
+    <p:sldId xmlns:r="http://schemas.openxmlformats.org/officeDocument/2006/relationships" id="289" r:id="Rc44b4edee29b49eb"/>
+    <p:sldId xmlns:r="http://schemas.openxmlformats.org/officeDocument/2006/relationships" id="290" r:id="R7b58c0e58a224939"/>
+    <p:sldId xmlns:r="http://schemas.openxmlformats.org/officeDocument/2006/relationships" id="291" r:id="R6f2d8d6eca7c4608"/>
   </p:sldIdLst>
   <p:sldSz cx="12192000" cy="6858000"/>
   <p:notesSz cx="6858000" cy="9144000"/>
@@ -4340,7 +4340,7 @@
   </p:cSld>
   <p:clrMap bg1="lt1" tx1="dk1" bg2="lt2" tx2="dk2" accent1="accent1" accent2="accent2" accent3="accent3" accent4="accent4" accent5="accent5" accent6="accent6" hlink="hlink" folHlink="folHlink"/>
   <p:sldLayoutIdLst>
-    <p:sldLayoutId xmlns:r="http://schemas.openxmlformats.org/officeDocument/2006/relationships" id="2147483649" r:id="R4e88fe4adacf416a"/>
+    <p:sldLayoutId xmlns:r="http://schemas.openxmlformats.org/officeDocument/2006/relationships" id="2147483649" r:id="Rb1c47985622e4949"/>
   </p:sldLayoutIdLst>
   <p:txStyles>
     <p:titleStyle>
@@ -4895,8 +4895,11 @@
           <p:nvPr/>
         </p:nvPicPr>
         <p:blipFill>
-          <a:blip xmlns:r="http://schemas.openxmlformats.org/officeDocument/2006/relationships" xmlns:a="http://schemas.openxmlformats.org/drawingml/2006/main" r:embed="Rf506af124bf34e88"/>
-          <a:stretch xmlns:a="http://schemas.openxmlformats.org/drawingml/2006/main"/>
+          <a:blip xmlns:r="http://schemas.openxmlformats.org/officeDocument/2006/relationships" xmlns:a="http://schemas.openxmlformats.org/drawingml/2006/main" r:embed="R6435e457b05a4f14"/>
+          <a:srcRect xmlns:a="http://schemas.openxmlformats.org/drawingml/2006/main" l="0" t="0" r="0" b="0"/>
+          <a:stretch xmlns:a="http://schemas.openxmlformats.org/drawingml/2006/main">
+            <a:fillRect l="0" t="0" r="0" b="0"/>
+          </a:stretch>
         </p:blipFill>
         <p:spPr>
           <a:xfrm xmlns:a="http://schemas.openxmlformats.org/drawingml/2006/main">
@@ -5369,8 +5372,11 @@
           <p:nvPr/>
         </p:nvPicPr>
         <p:blipFill>
-          <a:blip xmlns:r="http://schemas.openxmlformats.org/officeDocument/2006/relationships" xmlns:a="http://schemas.openxmlformats.org/drawingml/2006/main" r:embed="R4f4a41073bad490f"/>
-          <a:stretch xmlns:a="http://schemas.openxmlformats.org/drawingml/2006/main"/>
+          <a:blip xmlns:r="http://schemas.openxmlformats.org/officeDocument/2006/relationships" xmlns:a="http://schemas.openxmlformats.org/drawingml/2006/main" r:embed="R2d29d5f5dccd4411"/>
+          <a:srcRect xmlns:a="http://schemas.openxmlformats.org/drawingml/2006/main" l="0" t="0" r="0" b="0"/>
+          <a:stretch xmlns:a="http://schemas.openxmlformats.org/drawingml/2006/main">
+            <a:fillRect l="0" t="0" r="0" b="0"/>
+          </a:stretch>
         </p:blipFill>
         <p:spPr>
           <a:xfrm xmlns:a="http://schemas.openxmlformats.org/drawingml/2006/main">
@@ -5870,8 +5876,11 @@
           <p:nvPr/>
         </p:nvPicPr>
         <p:blipFill>
-          <a:blip xmlns:r="http://schemas.openxmlformats.org/officeDocument/2006/relationships" xmlns:a="http://schemas.openxmlformats.org/drawingml/2006/main" r:embed="R266918af35e44551"/>
-          <a:stretch xmlns:a="http://schemas.openxmlformats.org/drawingml/2006/main"/>
+          <a:blip xmlns:r="http://schemas.openxmlformats.org/officeDocument/2006/relationships" xmlns:a="http://schemas.openxmlformats.org/drawingml/2006/main" r:embed="Rf5677011befd48b9"/>
+          <a:srcRect xmlns:a="http://schemas.openxmlformats.org/drawingml/2006/main" l="0" t="0" r="0" b="0"/>
+          <a:stretch xmlns:a="http://schemas.openxmlformats.org/drawingml/2006/main">
+            <a:fillRect l="0" t="0" r="0" b="0"/>
+          </a:stretch>
         </p:blipFill>
         <p:spPr>
           <a:xfrm xmlns:a="http://schemas.openxmlformats.org/drawingml/2006/main">
@@ -6854,8 +6863,11 @@
           <p:nvPr/>
         </p:nvPicPr>
         <p:blipFill>
-          <a:blip xmlns:r="http://schemas.openxmlformats.org/officeDocument/2006/relationships" xmlns:a="http://schemas.openxmlformats.org/drawingml/2006/main" r:embed="R739c501ebac04b1b"/>
-          <a:stretch xmlns:a="http://schemas.openxmlformats.org/drawingml/2006/main"/>
+          <a:blip xmlns:r="http://schemas.openxmlformats.org/officeDocument/2006/relationships" xmlns:a="http://schemas.openxmlformats.org/drawingml/2006/main" r:embed="R5cbbfeb694f648e7"/>
+          <a:srcRect xmlns:a="http://schemas.openxmlformats.org/drawingml/2006/main" l="0" t="0" r="0" b="0"/>
+          <a:stretch xmlns:a="http://schemas.openxmlformats.org/drawingml/2006/main">
+            <a:fillRect l="0" t="0" r="0" b="0"/>
+          </a:stretch>
         </p:blipFill>
         <p:spPr>
           <a:xfrm xmlns:a="http://schemas.openxmlformats.org/drawingml/2006/main">
@@ -7652,8 +7664,11 @@
           <p:nvPr/>
         </p:nvPicPr>
         <p:blipFill>
-          <a:blip xmlns:r="http://schemas.openxmlformats.org/officeDocument/2006/relationships" xmlns:a="http://schemas.openxmlformats.org/drawingml/2006/main" r:embed="R9fa2438ade784a28"/>
-          <a:stretch xmlns:a="http://schemas.openxmlformats.org/drawingml/2006/main"/>
+          <a:blip xmlns:r="http://schemas.openxmlformats.org/officeDocument/2006/relationships" xmlns:a="http://schemas.openxmlformats.org/drawingml/2006/main" r:embed="Rd9fdfc19ee2c420b"/>
+          <a:srcRect xmlns:a="http://schemas.openxmlformats.org/drawingml/2006/main" l="0" t="0" r="0" b="0"/>
+          <a:stretch xmlns:a="http://schemas.openxmlformats.org/drawingml/2006/main">
+            <a:fillRect l="0" t="0" r="0" b="0"/>
+          </a:stretch>
         </p:blipFill>
         <p:spPr>
           <a:xfrm xmlns:a="http://schemas.openxmlformats.org/drawingml/2006/main">
@@ -8153,8 +8168,11 @@
           <p:nvPr/>
         </p:nvPicPr>
         <p:blipFill>
-          <a:blip xmlns:r="http://schemas.openxmlformats.org/officeDocument/2006/relationships" xmlns:a="http://schemas.openxmlformats.org/drawingml/2006/main" r:embed="Rd45a991052b94d93"/>
-          <a:stretch xmlns:a="http://schemas.openxmlformats.org/drawingml/2006/main"/>
+          <a:blip xmlns:r="http://schemas.openxmlformats.org/officeDocument/2006/relationships" xmlns:a="http://schemas.openxmlformats.org/drawingml/2006/main" r:embed="R884bbbd713c647fc"/>
+          <a:srcRect xmlns:a="http://schemas.openxmlformats.org/drawingml/2006/main" l="0" t="0" r="0" b="0"/>
+          <a:stretch xmlns:a="http://schemas.openxmlformats.org/drawingml/2006/main">
+            <a:fillRect l="0" t="0" r="0" b="0"/>
+          </a:stretch>
         </p:blipFill>
         <p:spPr>
           <a:xfrm xmlns:a="http://schemas.openxmlformats.org/drawingml/2006/main">
@@ -9787,8 +9805,11 @@
           <p:nvPr/>
         </p:nvPicPr>
         <p:blipFill>
-          <a:blip xmlns:r="http://schemas.openxmlformats.org/officeDocument/2006/relationships" xmlns:a="http://schemas.openxmlformats.org/drawingml/2006/main" r:embed="R4af2a47fa96d48b2"/>
-          <a:stretch xmlns:a="http://schemas.openxmlformats.org/drawingml/2006/main"/>
+          <a:blip xmlns:r="http://schemas.openxmlformats.org/officeDocument/2006/relationships" xmlns:a="http://schemas.openxmlformats.org/drawingml/2006/main" r:embed="R70cb6648ed81431e"/>
+          <a:srcRect xmlns:a="http://schemas.openxmlformats.org/drawingml/2006/main" l="0" t="0" r="0" b="0"/>
+          <a:stretch xmlns:a="http://schemas.openxmlformats.org/drawingml/2006/main">
+            <a:fillRect l="0" t="0" r="0" b="0"/>
+          </a:stretch>
         </p:blipFill>
         <p:spPr>
           <a:xfrm xmlns:a="http://schemas.openxmlformats.org/drawingml/2006/main">
@@ -10690,8 +10711,11 @@
           <p:nvPr/>
         </p:nvPicPr>
         <p:blipFill>
-          <a:blip xmlns:r="http://schemas.openxmlformats.org/officeDocument/2006/relationships" xmlns:a="http://schemas.openxmlformats.org/drawingml/2006/main" r:embed="R1bf2ea39c5d24954"/>
-          <a:stretch xmlns:a="http://schemas.openxmlformats.org/drawingml/2006/main"/>
+          <a:blip xmlns:r="http://schemas.openxmlformats.org/officeDocument/2006/relationships" xmlns:a="http://schemas.openxmlformats.org/drawingml/2006/main" r:embed="R2e3902c301714916"/>
+          <a:srcRect xmlns:a="http://schemas.openxmlformats.org/drawingml/2006/main" l="0" t="0" r="0" b="0"/>
+          <a:stretch xmlns:a="http://schemas.openxmlformats.org/drawingml/2006/main">
+            <a:fillRect l="0" t="0" r="0" b="0"/>
+          </a:stretch>
         </p:blipFill>
         <p:spPr>
           <a:xfrm xmlns:a="http://schemas.openxmlformats.org/drawingml/2006/main">
@@ -11674,8 +11698,11 @@
           <p:nvPr/>
         </p:nvPicPr>
         <p:blipFill>
-          <a:blip xmlns:r="http://schemas.openxmlformats.org/officeDocument/2006/relationships" xmlns:a="http://schemas.openxmlformats.org/drawingml/2006/main" r:embed="R60db4c1884624be3"/>
-          <a:stretch xmlns:a="http://schemas.openxmlformats.org/drawingml/2006/main"/>
+          <a:blip xmlns:r="http://schemas.openxmlformats.org/officeDocument/2006/relationships" xmlns:a="http://schemas.openxmlformats.org/drawingml/2006/main" r:embed="R62590751887e4ec7"/>
+          <a:srcRect xmlns:a="http://schemas.openxmlformats.org/drawingml/2006/main" l="0" t="0" r="0" b="0"/>
+          <a:stretch xmlns:a="http://schemas.openxmlformats.org/drawingml/2006/main">
+            <a:fillRect l="0" t="0" r="0" b="0"/>
+          </a:stretch>
         </p:blipFill>
         <p:spPr>
           <a:xfrm xmlns:a="http://schemas.openxmlformats.org/drawingml/2006/main">
@@ -12365,8 +12392,11 @@
           <p:nvPr/>
         </p:nvPicPr>
         <p:blipFill>
-          <a:blip xmlns:r="http://schemas.openxmlformats.org/officeDocument/2006/relationships" xmlns:a="http://schemas.openxmlformats.org/drawingml/2006/main" r:embed="R7f195e0b3a6e4c0e"/>
-          <a:stretch xmlns:a="http://schemas.openxmlformats.org/drawingml/2006/main"/>
+          <a:blip xmlns:r="http://schemas.openxmlformats.org/officeDocument/2006/relationships" xmlns:a="http://schemas.openxmlformats.org/drawingml/2006/main" r:embed="Rda26a5a9f3f94d58"/>
+          <a:srcRect xmlns:a="http://schemas.openxmlformats.org/drawingml/2006/main" l="0" t="0" r="0" b="0"/>
+          <a:stretch xmlns:a="http://schemas.openxmlformats.org/drawingml/2006/main">
+            <a:fillRect l="0" t="0" r="0" b="0"/>
+          </a:stretch>
         </p:blipFill>
         <p:spPr>
           <a:xfrm xmlns:a="http://schemas.openxmlformats.org/drawingml/2006/main">
@@ -13349,8 +13379,11 @@
           <p:nvPr/>
         </p:nvPicPr>
         <p:blipFill>
-          <a:blip xmlns:r="http://schemas.openxmlformats.org/officeDocument/2006/relationships" xmlns:a="http://schemas.openxmlformats.org/drawingml/2006/main" r:embed="R1a4a9ad19b654672"/>
-          <a:stretch xmlns:a="http://schemas.openxmlformats.org/drawingml/2006/main"/>
+          <a:blip xmlns:r="http://schemas.openxmlformats.org/officeDocument/2006/relationships" xmlns:a="http://schemas.openxmlformats.org/drawingml/2006/main" r:embed="R3e03c9e7434c4e04"/>
+          <a:srcRect xmlns:a="http://schemas.openxmlformats.org/drawingml/2006/main" l="0" t="0" r="0" b="0"/>
+          <a:stretch xmlns:a="http://schemas.openxmlformats.org/drawingml/2006/main">
+            <a:fillRect l="0" t="0" r="0" b="0"/>
+          </a:stretch>
         </p:blipFill>
         <p:spPr>
           <a:xfrm xmlns:a="http://schemas.openxmlformats.org/drawingml/2006/main">
@@ -14648,8 +14681,11 @@
           <p:nvPr/>
         </p:nvPicPr>
         <p:blipFill>
-          <a:blip xmlns:r="http://schemas.openxmlformats.org/officeDocument/2006/relationships" xmlns:a="http://schemas.openxmlformats.org/drawingml/2006/main" r:embed="R05714b7fb6174b7b"/>
-          <a:stretch xmlns:a="http://schemas.openxmlformats.org/drawingml/2006/main"/>
+          <a:blip xmlns:r="http://schemas.openxmlformats.org/officeDocument/2006/relationships" xmlns:a="http://schemas.openxmlformats.org/drawingml/2006/main" r:embed="R4bfa3e4836c9417c"/>
+          <a:srcRect xmlns:a="http://schemas.openxmlformats.org/drawingml/2006/main" l="0" t="0" r="0" b="0"/>
+          <a:stretch xmlns:a="http://schemas.openxmlformats.org/drawingml/2006/main">
+            <a:fillRect l="0" t="0" r="0" b="0"/>
+          </a:stretch>
         </p:blipFill>
         <p:spPr>
           <a:xfrm xmlns:a="http://schemas.openxmlformats.org/drawingml/2006/main">
@@ -15339,8 +15375,11 @@
           <p:nvPr/>
         </p:nvPicPr>
         <p:blipFill>
-          <a:blip xmlns:r="http://schemas.openxmlformats.org/officeDocument/2006/relationships" xmlns:a="http://schemas.openxmlformats.org/drawingml/2006/main" r:embed="R6d6d24c092e447e1"/>
-          <a:stretch xmlns:a="http://schemas.openxmlformats.org/drawingml/2006/main"/>
+          <a:blip xmlns:r="http://schemas.openxmlformats.org/officeDocument/2006/relationships" xmlns:a="http://schemas.openxmlformats.org/drawingml/2006/main" r:embed="Rff4a8b9cf1ba43ca"/>
+          <a:srcRect xmlns:a="http://schemas.openxmlformats.org/drawingml/2006/main" l="0" t="0" r="0" b="0"/>
+          <a:stretch xmlns:a="http://schemas.openxmlformats.org/drawingml/2006/main">
+            <a:fillRect l="0" t="0" r="0" b="0"/>
+          </a:stretch>
         </p:blipFill>
         <p:spPr>
           <a:xfrm xmlns:a="http://schemas.openxmlformats.org/drawingml/2006/main">
@@ -15840,8 +15879,11 @@
           <p:nvPr/>
         </p:nvPicPr>
         <p:blipFill>
-          <a:blip xmlns:r="http://schemas.openxmlformats.org/officeDocument/2006/relationships" xmlns:a="http://schemas.openxmlformats.org/drawingml/2006/main" r:embed="Rea4f8d753a0a430f"/>
-          <a:stretch xmlns:a="http://schemas.openxmlformats.org/drawingml/2006/main"/>
+          <a:blip xmlns:r="http://schemas.openxmlformats.org/officeDocument/2006/relationships" xmlns:a="http://schemas.openxmlformats.org/drawingml/2006/main" r:embed="R08dc472935a043f5"/>
+          <a:srcRect xmlns:a="http://schemas.openxmlformats.org/drawingml/2006/main" l="0" t="0" r="0" b="0"/>
+          <a:stretch xmlns:a="http://schemas.openxmlformats.org/drawingml/2006/main">
+            <a:fillRect l="0" t="0" r="0" b="0"/>
+          </a:stretch>
         </p:blipFill>
         <p:spPr>
           <a:xfrm xmlns:a="http://schemas.openxmlformats.org/drawingml/2006/main">
@@ -16699,8 +16741,11 @@
           <p:nvPr/>
         </p:nvPicPr>
         <p:blipFill>
-          <a:blip xmlns:r="http://schemas.openxmlformats.org/officeDocument/2006/relationships" xmlns:a="http://schemas.openxmlformats.org/drawingml/2006/main" r:embed="Rccf7c967c18845ea"/>
-          <a:stretch xmlns:a="http://schemas.openxmlformats.org/drawingml/2006/main"/>
+          <a:blip xmlns:r="http://schemas.openxmlformats.org/officeDocument/2006/relationships" xmlns:a="http://schemas.openxmlformats.org/drawingml/2006/main" r:embed="Rdc268b93c07148a7"/>
+          <a:srcRect xmlns:a="http://schemas.openxmlformats.org/drawingml/2006/main" l="0" t="0" r="0" b="0"/>
+          <a:stretch xmlns:a="http://schemas.openxmlformats.org/drawingml/2006/main">
+            <a:fillRect l="0" t="0" r="0" b="0"/>
+          </a:stretch>
         </p:blipFill>
         <p:spPr>
           <a:xfrm xmlns:a="http://schemas.openxmlformats.org/drawingml/2006/main">
@@ -17531,8 +17576,11 @@
           <p:nvPr/>
         </p:nvPicPr>
         <p:blipFill>
-          <a:blip xmlns:r="http://schemas.openxmlformats.org/officeDocument/2006/relationships" xmlns:a="http://schemas.openxmlformats.org/drawingml/2006/main" r:embed="Rd4dced44cdf24249"/>
-          <a:stretch xmlns:a="http://schemas.openxmlformats.org/drawingml/2006/main"/>
+          <a:blip xmlns:r="http://schemas.openxmlformats.org/officeDocument/2006/relationships" xmlns:a="http://schemas.openxmlformats.org/drawingml/2006/main" r:embed="R1076bf1937ed45e7"/>
+          <a:srcRect xmlns:a="http://schemas.openxmlformats.org/drawingml/2006/main" l="0" t="0" r="0" b="0"/>
+          <a:stretch xmlns:a="http://schemas.openxmlformats.org/drawingml/2006/main">
+            <a:fillRect l="0" t="0" r="0" b="0"/>
+          </a:stretch>
         </p:blipFill>
         <p:spPr>
           <a:xfrm xmlns:a="http://schemas.openxmlformats.org/drawingml/2006/main">
@@ -18451,8 +18499,11 @@
           <p:nvPr/>
         </p:nvPicPr>
         <p:blipFill>
-          <a:blip xmlns:r="http://schemas.openxmlformats.org/officeDocument/2006/relationships" xmlns:a="http://schemas.openxmlformats.org/drawingml/2006/main" r:embed="Rb6e3c0f3546e483d"/>
-          <a:stretch xmlns:a="http://schemas.openxmlformats.org/drawingml/2006/main"/>
+          <a:blip xmlns:r="http://schemas.openxmlformats.org/officeDocument/2006/relationships" xmlns:a="http://schemas.openxmlformats.org/drawingml/2006/main" r:embed="R4a5ae649fe534ff4"/>
+          <a:srcRect xmlns:a="http://schemas.openxmlformats.org/drawingml/2006/main" l="0" t="0" r="0" b="0"/>
+          <a:stretch xmlns:a="http://schemas.openxmlformats.org/drawingml/2006/main">
+            <a:fillRect l="0" t="0" r="0" b="0"/>
+          </a:stretch>
         </p:blipFill>
         <p:spPr>
           <a:xfrm xmlns:a="http://schemas.openxmlformats.org/drawingml/2006/main">
@@ -19811,8 +19862,11 @@
           <p:nvPr/>
         </p:nvPicPr>
         <p:blipFill>
-          <a:blip xmlns:r="http://schemas.openxmlformats.org/officeDocument/2006/relationships" xmlns:a="http://schemas.openxmlformats.org/drawingml/2006/main" r:embed="Rad198fc52d674093"/>
-          <a:stretch xmlns:a="http://schemas.openxmlformats.org/drawingml/2006/main"/>
+          <a:blip xmlns:r="http://schemas.openxmlformats.org/officeDocument/2006/relationships" xmlns:a="http://schemas.openxmlformats.org/drawingml/2006/main" r:embed="Rf381ddeb138f4234"/>
+          <a:srcRect xmlns:a="http://schemas.openxmlformats.org/drawingml/2006/main" l="0" t="0" r="0" b="0"/>
+          <a:stretch xmlns:a="http://schemas.openxmlformats.org/drawingml/2006/main">
+            <a:fillRect l="0" t="0" r="0" b="0"/>
+          </a:stretch>
         </p:blipFill>
         <p:spPr>
           <a:xfrm xmlns:a="http://schemas.openxmlformats.org/drawingml/2006/main">
@@ -20562,8 +20616,11 @@
           <p:nvPr/>
         </p:nvPicPr>
         <p:blipFill>
-          <a:blip xmlns:r="http://schemas.openxmlformats.org/officeDocument/2006/relationships" xmlns:a="http://schemas.openxmlformats.org/drawingml/2006/main" r:embed="Rc9e9710cf96a4e8f"/>
-          <a:stretch xmlns:a="http://schemas.openxmlformats.org/drawingml/2006/main"/>
+          <a:blip xmlns:r="http://schemas.openxmlformats.org/officeDocument/2006/relationships" xmlns:a="http://schemas.openxmlformats.org/drawingml/2006/main" r:embed="R09d193b8120b4ce6"/>
+          <a:srcRect xmlns:a="http://schemas.openxmlformats.org/drawingml/2006/main" l="0" t="0" r="0" b="0"/>
+          <a:stretch xmlns:a="http://schemas.openxmlformats.org/drawingml/2006/main">
+            <a:fillRect l="0" t="0" r="0" b="0"/>
+          </a:stretch>
         </p:blipFill>
         <p:spPr>
           <a:xfrm xmlns:a="http://schemas.openxmlformats.org/drawingml/2006/main">
@@ -21536,8 +21593,11 @@
           <p:nvPr/>
         </p:nvPicPr>
         <p:blipFill>
-          <a:blip xmlns:r="http://schemas.openxmlformats.org/officeDocument/2006/relationships" xmlns:a="http://schemas.openxmlformats.org/drawingml/2006/main" r:embed="Rb7a6aaeb38f24220"/>
-          <a:stretch xmlns:a="http://schemas.openxmlformats.org/drawingml/2006/main"/>
+          <a:blip xmlns:r="http://schemas.openxmlformats.org/officeDocument/2006/relationships" xmlns:a="http://schemas.openxmlformats.org/drawingml/2006/main" r:embed="R615281ca422246ee"/>
+          <a:srcRect xmlns:a="http://schemas.openxmlformats.org/drawingml/2006/main" l="0" t="0" r="0" b="0"/>
+          <a:stretch xmlns:a="http://schemas.openxmlformats.org/drawingml/2006/main">
+            <a:fillRect l="0" t="0" r="0" b="0"/>
+          </a:stretch>
         </p:blipFill>
         <p:spPr>
           <a:xfrm xmlns:a="http://schemas.openxmlformats.org/drawingml/2006/main">
@@ -22288,8 +22348,11 @@
           <p:nvPr/>
         </p:nvPicPr>
         <p:blipFill>
-          <a:blip xmlns:r="http://schemas.openxmlformats.org/officeDocument/2006/relationships" xmlns:a="http://schemas.openxmlformats.org/drawingml/2006/main" r:embed="R8e3d12eadf4a44bb"/>
-          <a:stretch xmlns:a="http://schemas.openxmlformats.org/drawingml/2006/main"/>
+          <a:blip xmlns:r="http://schemas.openxmlformats.org/officeDocument/2006/relationships" xmlns:a="http://schemas.openxmlformats.org/drawingml/2006/main" r:embed="R17dcb1aa7103471d"/>
+          <a:srcRect xmlns:a="http://schemas.openxmlformats.org/drawingml/2006/main" l="0" t="0" r="0" b="0"/>
+          <a:stretch xmlns:a="http://schemas.openxmlformats.org/drawingml/2006/main">
+            <a:fillRect l="0" t="0" r="0" b="0"/>
+          </a:stretch>
         </p:blipFill>
         <p:spPr>
           <a:xfrm xmlns:a="http://schemas.openxmlformats.org/drawingml/2006/main">
@@ -23208,8 +23271,11 @@
           <p:nvPr/>
         </p:nvPicPr>
         <p:blipFill>
-          <a:blip xmlns:r="http://schemas.openxmlformats.org/officeDocument/2006/relationships" xmlns:a="http://schemas.openxmlformats.org/drawingml/2006/main" r:embed="Rf22460f1110e4f49"/>
-          <a:stretch xmlns:a="http://schemas.openxmlformats.org/drawingml/2006/main"/>
+          <a:blip xmlns:r="http://schemas.openxmlformats.org/officeDocument/2006/relationships" xmlns:a="http://schemas.openxmlformats.org/drawingml/2006/main" r:embed="Rc64d419209664d66"/>
+          <a:srcRect xmlns:a="http://schemas.openxmlformats.org/drawingml/2006/main" l="0" t="0" r="0" b="0"/>
+          <a:stretch xmlns:a="http://schemas.openxmlformats.org/drawingml/2006/main">
+            <a:fillRect l="0" t="0" r="0" b="0"/>
+          </a:stretch>
         </p:blipFill>
         <p:spPr>
           <a:xfrm xmlns:a="http://schemas.openxmlformats.org/drawingml/2006/main">
@@ -23922,8 +23988,11 @@
           <p:nvPr/>
         </p:nvPicPr>
         <p:blipFill>
-          <a:blip xmlns:r="http://schemas.openxmlformats.org/officeDocument/2006/relationships" xmlns:a="http://schemas.openxmlformats.org/drawingml/2006/main" r:embed="R56d3e5562eb44724"/>
-          <a:stretch xmlns:a="http://schemas.openxmlformats.org/drawingml/2006/main"/>
+          <a:blip xmlns:r="http://schemas.openxmlformats.org/officeDocument/2006/relationships" xmlns:a="http://schemas.openxmlformats.org/drawingml/2006/main" r:embed="R6d7375447d3e4283"/>
+          <a:srcRect xmlns:a="http://schemas.openxmlformats.org/drawingml/2006/main" l="0" t="0" r="0" b="0"/>
+          <a:stretch xmlns:a="http://schemas.openxmlformats.org/drawingml/2006/main">
+            <a:fillRect l="0" t="0" r="0" b="0"/>
+          </a:stretch>
         </p:blipFill>
         <p:spPr>
           <a:xfrm xmlns:a="http://schemas.openxmlformats.org/drawingml/2006/main">
@@ -24396,8 +24465,11 @@
           <p:nvPr/>
         </p:nvPicPr>
         <p:blipFill>
-          <a:blip xmlns:r="http://schemas.openxmlformats.org/officeDocument/2006/relationships" xmlns:a="http://schemas.openxmlformats.org/drawingml/2006/main" r:embed="R9e433350c1674278"/>
-          <a:stretch xmlns:a="http://schemas.openxmlformats.org/drawingml/2006/main"/>
+          <a:blip xmlns:r="http://schemas.openxmlformats.org/officeDocument/2006/relationships" xmlns:a="http://schemas.openxmlformats.org/drawingml/2006/main" r:embed="R0ee110b6397b465c"/>
+          <a:srcRect xmlns:a="http://schemas.openxmlformats.org/drawingml/2006/main" l="0" t="0" r="0" b="0"/>
+          <a:stretch xmlns:a="http://schemas.openxmlformats.org/drawingml/2006/main">
+            <a:fillRect l="0" t="0" r="0" b="0"/>
+          </a:stretch>
         </p:blipFill>
         <p:spPr>
           <a:xfrm xmlns:a="http://schemas.openxmlformats.org/drawingml/2006/main">
@@ -25228,8 +25300,11 @@
           <p:nvPr/>
         </p:nvPicPr>
         <p:blipFill>
-          <a:blip xmlns:r="http://schemas.openxmlformats.org/officeDocument/2006/relationships" xmlns:a="http://schemas.openxmlformats.org/drawingml/2006/main" r:embed="Re7952ef1989a48e0"/>
-          <a:stretch xmlns:a="http://schemas.openxmlformats.org/drawingml/2006/main"/>
+          <a:blip xmlns:r="http://schemas.openxmlformats.org/officeDocument/2006/relationships" xmlns:a="http://schemas.openxmlformats.org/drawingml/2006/main" r:embed="R0b5c51af1af74937"/>
+          <a:srcRect xmlns:a="http://schemas.openxmlformats.org/drawingml/2006/main" l="0" t="0" r="0" b="0"/>
+          <a:stretch xmlns:a="http://schemas.openxmlformats.org/drawingml/2006/main">
+            <a:fillRect l="0" t="0" r="0" b="0"/>
+          </a:stretch>
         </p:blipFill>
         <p:spPr>
           <a:xfrm xmlns:a="http://schemas.openxmlformats.org/drawingml/2006/main">
@@ -26141,8 +26216,11 @@
           <p:nvPr/>
         </p:nvPicPr>
         <p:blipFill>
-          <a:blip xmlns:r="http://schemas.openxmlformats.org/officeDocument/2006/relationships" xmlns:a="http://schemas.openxmlformats.org/drawingml/2006/main" r:embed="R35abea8cf44a4bea"/>
-          <a:stretch xmlns:a="http://schemas.openxmlformats.org/drawingml/2006/main"/>
+          <a:blip xmlns:r="http://schemas.openxmlformats.org/officeDocument/2006/relationships" xmlns:a="http://schemas.openxmlformats.org/drawingml/2006/main" r:embed="Re9f4463f887543a3"/>
+          <a:srcRect xmlns:a="http://schemas.openxmlformats.org/drawingml/2006/main" l="0" t="0" r="0" b="0"/>
+          <a:stretch xmlns:a="http://schemas.openxmlformats.org/drawingml/2006/main">
+            <a:fillRect l="0" t="0" r="0" b="0"/>
+          </a:stretch>
         </p:blipFill>
         <p:spPr>
           <a:xfrm xmlns:a="http://schemas.openxmlformats.org/drawingml/2006/main">
@@ -26825,8 +26903,11 @@
           <p:nvPr/>
         </p:nvPicPr>
         <p:blipFill>
-          <a:blip xmlns:r="http://schemas.openxmlformats.org/officeDocument/2006/relationships" xmlns:a="http://schemas.openxmlformats.org/drawingml/2006/main" r:embed="Ra2cd3149c76947e2"/>
-          <a:stretch xmlns:a="http://schemas.openxmlformats.org/drawingml/2006/main"/>
+          <a:blip xmlns:r="http://schemas.openxmlformats.org/officeDocument/2006/relationships" xmlns:a="http://schemas.openxmlformats.org/drawingml/2006/main" r:embed="R8b6b585e7d884f76"/>
+          <a:srcRect xmlns:a="http://schemas.openxmlformats.org/drawingml/2006/main" l="0" t="0" r="0" b="0"/>
+          <a:stretch xmlns:a="http://schemas.openxmlformats.org/drawingml/2006/main">
+            <a:fillRect l="0" t="0" r="0" b="0"/>
+          </a:stretch>
         </p:blipFill>
         <p:spPr>
           <a:xfrm xmlns:a="http://schemas.openxmlformats.org/drawingml/2006/main">
@@ -27809,8 +27890,11 @@
           <p:nvPr/>
         </p:nvPicPr>
         <p:blipFill>
-          <a:blip xmlns:r="http://schemas.openxmlformats.org/officeDocument/2006/relationships" xmlns:a="http://schemas.openxmlformats.org/drawingml/2006/main" r:embed="R9628b2a826164fd3"/>
-          <a:stretch xmlns:a="http://schemas.openxmlformats.org/drawingml/2006/main"/>
+          <a:blip xmlns:r="http://schemas.openxmlformats.org/officeDocument/2006/relationships" xmlns:a="http://schemas.openxmlformats.org/drawingml/2006/main" r:embed="Rb0e1b5644ab242ad"/>
+          <a:srcRect xmlns:a="http://schemas.openxmlformats.org/drawingml/2006/main" l="0" t="0" r="0" b="0"/>
+          <a:stretch xmlns:a="http://schemas.openxmlformats.org/drawingml/2006/main">
+            <a:fillRect l="0" t="0" r="0" b="0"/>
+          </a:stretch>
         </p:blipFill>
         <p:spPr>
           <a:xfrm xmlns:a="http://schemas.openxmlformats.org/drawingml/2006/main">
@@ -28864,8 +28948,11 @@
           <p:nvPr/>
         </p:nvPicPr>
         <p:blipFill>
-          <a:blip xmlns:r="http://schemas.openxmlformats.org/officeDocument/2006/relationships" xmlns:a="http://schemas.openxmlformats.org/drawingml/2006/main" r:embed="Rc93cb5d55187416d"/>
-          <a:stretch xmlns:a="http://schemas.openxmlformats.org/drawingml/2006/main"/>
+          <a:blip xmlns:r="http://schemas.openxmlformats.org/officeDocument/2006/relationships" xmlns:a="http://schemas.openxmlformats.org/drawingml/2006/main" r:embed="R8d708ef885ac42f1"/>
+          <a:srcRect xmlns:a="http://schemas.openxmlformats.org/drawingml/2006/main" l="0" t="0" r="0" b="0"/>
+          <a:stretch xmlns:a="http://schemas.openxmlformats.org/drawingml/2006/main">
+            <a:fillRect l="0" t="0" r="0" b="0"/>
+          </a:stretch>
         </p:blipFill>
         <p:spPr>
           <a:xfrm xmlns:a="http://schemas.openxmlformats.org/drawingml/2006/main">
@@ -29555,8 +29642,11 @@
           <p:nvPr/>
         </p:nvPicPr>
         <p:blipFill>
-          <a:blip xmlns:r="http://schemas.openxmlformats.org/officeDocument/2006/relationships" xmlns:a="http://schemas.openxmlformats.org/drawingml/2006/main" r:embed="R84c0843fe9504187"/>
-          <a:stretch xmlns:a="http://schemas.openxmlformats.org/drawingml/2006/main"/>
+          <a:blip xmlns:r="http://schemas.openxmlformats.org/officeDocument/2006/relationships" xmlns:a="http://schemas.openxmlformats.org/drawingml/2006/main" r:embed="Rc44c969915ae414f"/>
+          <a:srcRect xmlns:a="http://schemas.openxmlformats.org/drawingml/2006/main" l="0" t="0" r="0" b="0"/>
+          <a:stretch xmlns:a="http://schemas.openxmlformats.org/drawingml/2006/main">
+            <a:fillRect l="0" t="0" r="0" b="0"/>
+          </a:stretch>
         </p:blipFill>
         <p:spPr>
           <a:xfrm xmlns:a="http://schemas.openxmlformats.org/drawingml/2006/main">
@@ -30063,8 +30153,11 @@
           <p:nvPr/>
         </p:nvPicPr>
         <p:blipFill>
-          <a:blip xmlns:r="http://schemas.openxmlformats.org/officeDocument/2006/relationships" xmlns:a="http://schemas.openxmlformats.org/drawingml/2006/main" r:embed="R9642522ae5d54081"/>
-          <a:stretch xmlns:a="http://schemas.openxmlformats.org/drawingml/2006/main"/>
+          <a:blip xmlns:r="http://schemas.openxmlformats.org/officeDocument/2006/relationships" xmlns:a="http://schemas.openxmlformats.org/drawingml/2006/main" r:embed="Red67761e1c964a6e"/>
+          <a:srcRect xmlns:a="http://schemas.openxmlformats.org/drawingml/2006/main" l="0" t="0" r="0" b="0"/>
+          <a:stretch xmlns:a="http://schemas.openxmlformats.org/drawingml/2006/main">
+            <a:fillRect l="0" t="0" r="0" b="0"/>
+          </a:stretch>
         </p:blipFill>
         <p:spPr>
           <a:xfrm xmlns:a="http://schemas.openxmlformats.org/drawingml/2006/main">
@@ -31047,8 +31140,11 @@
           <p:nvPr/>
         </p:nvPicPr>
         <p:blipFill>
-          <a:blip xmlns:r="http://schemas.openxmlformats.org/officeDocument/2006/relationships" xmlns:a="http://schemas.openxmlformats.org/drawingml/2006/main" r:embed="Rdd9726ce3f994cf6"/>
-          <a:stretch xmlns:a="http://schemas.openxmlformats.org/drawingml/2006/main"/>
+          <a:blip xmlns:r="http://schemas.openxmlformats.org/officeDocument/2006/relationships" xmlns:a="http://schemas.openxmlformats.org/drawingml/2006/main" r:embed="R04158cc3d524437a"/>
+          <a:srcRect xmlns:a="http://schemas.openxmlformats.org/drawingml/2006/main" l="0" t="0" r="0" b="0"/>
+          <a:stretch xmlns:a="http://schemas.openxmlformats.org/drawingml/2006/main">
+            <a:fillRect l="0" t="0" r="0" b="0"/>
+          </a:stretch>
         </p:blipFill>
         <p:spPr>
           <a:xfrm xmlns:a="http://schemas.openxmlformats.org/drawingml/2006/main">
@@ -31548,8 +31644,11 @@
           <p:nvPr/>
         </p:nvPicPr>
         <p:blipFill>
-          <a:blip xmlns:r="http://schemas.openxmlformats.org/officeDocument/2006/relationships" xmlns:a="http://schemas.openxmlformats.org/drawingml/2006/main" r:embed="R275be6bd17e94f89"/>
-          <a:stretch xmlns:a="http://schemas.openxmlformats.org/drawingml/2006/main"/>
+          <a:blip xmlns:r="http://schemas.openxmlformats.org/officeDocument/2006/relationships" xmlns:a="http://schemas.openxmlformats.org/drawingml/2006/main" r:embed="R5ed6461dc6704e3c"/>
+          <a:srcRect xmlns:a="http://schemas.openxmlformats.org/drawingml/2006/main" l="0" t="0" r="0" b="0"/>
+          <a:stretch xmlns:a="http://schemas.openxmlformats.org/drawingml/2006/main">
+            <a:fillRect l="0" t="0" r="0" b="0"/>
+          </a:stretch>
         </p:blipFill>
         <p:spPr>
           <a:xfrm xmlns:a="http://schemas.openxmlformats.org/drawingml/2006/main">
@@ -32532,8 +32631,11 @@
           <p:nvPr/>
         </p:nvPicPr>
         <p:blipFill>
-          <a:blip xmlns:r="http://schemas.openxmlformats.org/officeDocument/2006/relationships" xmlns:a="http://schemas.openxmlformats.org/drawingml/2006/main" r:embed="R53664f7406ee406d"/>
-          <a:stretch xmlns:a="http://schemas.openxmlformats.org/drawingml/2006/main"/>
+          <a:blip xmlns:r="http://schemas.openxmlformats.org/officeDocument/2006/relationships" xmlns:a="http://schemas.openxmlformats.org/drawingml/2006/main" r:embed="Rae399868b1b64864"/>
+          <a:srcRect xmlns:a="http://schemas.openxmlformats.org/drawingml/2006/main" l="0" t="0" r="0" b="0"/>
+          <a:stretch xmlns:a="http://schemas.openxmlformats.org/drawingml/2006/main">
+            <a:fillRect l="0" t="0" r="0" b="0"/>
+          </a:stretch>
         </p:blipFill>
         <p:spPr>
           <a:xfrm xmlns:a="http://schemas.openxmlformats.org/drawingml/2006/main">
@@ -33557,8 +33659,11 @@
           <p:nvPr/>
         </p:nvPicPr>
         <p:blipFill>
-          <a:blip xmlns:r="http://schemas.openxmlformats.org/officeDocument/2006/relationships" xmlns:a="http://schemas.openxmlformats.org/drawingml/2006/main" r:embed="R84eba04ab99a44f4"/>
-          <a:stretch xmlns:a="http://schemas.openxmlformats.org/drawingml/2006/main"/>
+          <a:blip xmlns:r="http://schemas.openxmlformats.org/officeDocument/2006/relationships" xmlns:a="http://schemas.openxmlformats.org/drawingml/2006/main" r:embed="R6202162da6804e5e"/>
+          <a:srcRect xmlns:a="http://schemas.openxmlformats.org/drawingml/2006/main" l="0" t="0" r="0" b="0"/>
+          <a:stretch xmlns:a="http://schemas.openxmlformats.org/drawingml/2006/main">
+            <a:fillRect l="0" t="0" r="0" b="0"/>
+          </a:stretch>
         </p:blipFill>
         <p:spPr>
           <a:xfrm xmlns:a="http://schemas.openxmlformats.org/drawingml/2006/main">
@@ -34248,8 +34353,11 @@
           <p:nvPr/>
         </p:nvPicPr>
         <p:blipFill>
-          <a:blip xmlns:r="http://schemas.openxmlformats.org/officeDocument/2006/relationships" xmlns:a="http://schemas.openxmlformats.org/drawingml/2006/main" r:embed="R1396cbc259484285"/>
-          <a:stretch xmlns:a="http://schemas.openxmlformats.org/drawingml/2006/main"/>
+          <a:blip xmlns:r="http://schemas.openxmlformats.org/officeDocument/2006/relationships" xmlns:a="http://schemas.openxmlformats.org/drawingml/2006/main" r:embed="R1ab3358c3eae405f"/>
+          <a:srcRect xmlns:a="http://schemas.openxmlformats.org/drawingml/2006/main" l="0" t="0" r="0" b="0"/>
+          <a:stretch xmlns:a="http://schemas.openxmlformats.org/drawingml/2006/main">
+            <a:fillRect l="0" t="0" r="0" b="0"/>
+          </a:stretch>
         </p:blipFill>
         <p:spPr>
           <a:xfrm xmlns:a="http://schemas.openxmlformats.org/drawingml/2006/main">

</xml_diff>

<commit_message>
Sharpen education lecture copy and classroom reasoning
Rewrite slide titles, body text and speaker notes for direct spoken Chinese. Make classroom judgments concrete, retain source limitations and 36-slide pacing, and synchronize PowerPoint and web.
</commit_message>
<xml_diff>
--- a/education-purpose-ai-2026/downloads/AI_Education_Purpose_36slides.pptx
+++ b/education-purpose-ai-2026/downloads/AI_Education_Purpose_36slides.pptx
@@ -2,48 +2,48 @@
 <file path=ppt/presentation.xml><?xml version="1.0" encoding="utf-8"?>
 <p:presentation xmlns:p="http://schemas.openxmlformats.org/presentationml/2006/main">
   <p:sldMasterIdLst>
-    <p:sldMasterId xmlns:r="http://schemas.openxmlformats.org/officeDocument/2006/relationships" id="2147483648" r:id="Rd6f5bcc8bba54f9b"/>
+    <p:sldMasterId xmlns:r="http://schemas.openxmlformats.org/officeDocument/2006/relationships" id="2147483648" r:id="R880b544316cc47df"/>
   </p:sldMasterIdLst>
   <p:notesMasterIdLst>
-    <p:notesMasterId xmlns:r="http://schemas.openxmlformats.org/officeDocument/2006/relationships" r:id="Rc9729e2bc1af4b32"/>
+    <p:notesMasterId xmlns:r="http://schemas.openxmlformats.org/officeDocument/2006/relationships" r:id="R5c1b5ab62b244c8f"/>
   </p:notesMasterIdLst>
   <p:sldIdLst>
-    <p:sldId xmlns:r="http://schemas.openxmlformats.org/officeDocument/2006/relationships" id="256" r:id="Rfdfa91275e984157"/>
-    <p:sldId xmlns:r="http://schemas.openxmlformats.org/officeDocument/2006/relationships" id="257" r:id="R05ed22eb62d341b4"/>
-    <p:sldId xmlns:r="http://schemas.openxmlformats.org/officeDocument/2006/relationships" id="258" r:id="Rd26ef5dad59946c4"/>
-    <p:sldId xmlns:r="http://schemas.openxmlformats.org/officeDocument/2006/relationships" id="259" r:id="Re519fcf5a5a24df2"/>
-    <p:sldId xmlns:r="http://schemas.openxmlformats.org/officeDocument/2006/relationships" id="260" r:id="Rbc51e1821c74460d"/>
-    <p:sldId xmlns:r="http://schemas.openxmlformats.org/officeDocument/2006/relationships" id="261" r:id="R2f0c6adbd29347fe"/>
-    <p:sldId xmlns:r="http://schemas.openxmlformats.org/officeDocument/2006/relationships" id="262" r:id="Rb6faca7f0a5c483b"/>
-    <p:sldId xmlns:r="http://schemas.openxmlformats.org/officeDocument/2006/relationships" id="263" r:id="Rba90cfd2644448f7"/>
-    <p:sldId xmlns:r="http://schemas.openxmlformats.org/officeDocument/2006/relationships" id="264" r:id="Rea70722c85364f8e"/>
-    <p:sldId xmlns:r="http://schemas.openxmlformats.org/officeDocument/2006/relationships" id="265" r:id="R77d4fec2fa56450c"/>
-    <p:sldId xmlns:r="http://schemas.openxmlformats.org/officeDocument/2006/relationships" id="266" r:id="R545f041c0e904e37"/>
-    <p:sldId xmlns:r="http://schemas.openxmlformats.org/officeDocument/2006/relationships" id="267" r:id="R57b70f7dd3dd40be"/>
-    <p:sldId xmlns:r="http://schemas.openxmlformats.org/officeDocument/2006/relationships" id="268" r:id="R979c3e0632ca491d"/>
-    <p:sldId xmlns:r="http://schemas.openxmlformats.org/officeDocument/2006/relationships" id="269" r:id="R2bc1b52b198b41e4"/>
-    <p:sldId xmlns:r="http://schemas.openxmlformats.org/officeDocument/2006/relationships" id="270" r:id="R630cdeaba0f6485c"/>
-    <p:sldId xmlns:r="http://schemas.openxmlformats.org/officeDocument/2006/relationships" id="271" r:id="Rb502cce6f565418f"/>
-    <p:sldId xmlns:r="http://schemas.openxmlformats.org/officeDocument/2006/relationships" id="272" r:id="Re9dd9172bd4e4951"/>
-    <p:sldId xmlns:r="http://schemas.openxmlformats.org/officeDocument/2006/relationships" id="273" r:id="Ra2f9c0a570704806"/>
-    <p:sldId xmlns:r="http://schemas.openxmlformats.org/officeDocument/2006/relationships" id="274" r:id="R0343c78dcbba46b0"/>
-    <p:sldId xmlns:r="http://schemas.openxmlformats.org/officeDocument/2006/relationships" id="275" r:id="Ra4e8bee4af1644f7"/>
-    <p:sldId xmlns:r="http://schemas.openxmlformats.org/officeDocument/2006/relationships" id="276" r:id="R0d346bf990514632"/>
-    <p:sldId xmlns:r="http://schemas.openxmlformats.org/officeDocument/2006/relationships" id="277" r:id="Rc2a670a00f244830"/>
-    <p:sldId xmlns:r="http://schemas.openxmlformats.org/officeDocument/2006/relationships" id="278" r:id="R3bc03204853245e9"/>
-    <p:sldId xmlns:r="http://schemas.openxmlformats.org/officeDocument/2006/relationships" id="279" r:id="Rc77e435ad5c840f8"/>
-    <p:sldId xmlns:r="http://schemas.openxmlformats.org/officeDocument/2006/relationships" id="280" r:id="R361495277a4e49e6"/>
-    <p:sldId xmlns:r="http://schemas.openxmlformats.org/officeDocument/2006/relationships" id="281" r:id="Rb02b6016b8b2452e"/>
-    <p:sldId xmlns:r="http://schemas.openxmlformats.org/officeDocument/2006/relationships" id="282" r:id="R2e34a8fb34984fe9"/>
-    <p:sldId xmlns:r="http://schemas.openxmlformats.org/officeDocument/2006/relationships" id="283" r:id="R4288199df81d4a68"/>
-    <p:sldId xmlns:r="http://schemas.openxmlformats.org/officeDocument/2006/relationships" id="284" r:id="R99c83f51dbdb4df0"/>
-    <p:sldId xmlns:r="http://schemas.openxmlformats.org/officeDocument/2006/relationships" id="285" r:id="Rce0eba6dc63d46a9"/>
-    <p:sldId xmlns:r="http://schemas.openxmlformats.org/officeDocument/2006/relationships" id="286" r:id="R6352afb7f12a477e"/>
-    <p:sldId xmlns:r="http://schemas.openxmlformats.org/officeDocument/2006/relationships" id="287" r:id="R7c508f8fa20d447b"/>
-    <p:sldId xmlns:r="http://schemas.openxmlformats.org/officeDocument/2006/relationships" id="288" r:id="R9b45078fe54e4997"/>
-    <p:sldId xmlns:r="http://schemas.openxmlformats.org/officeDocument/2006/relationships" id="289" r:id="Rc44b4edee29b49eb"/>
-    <p:sldId xmlns:r="http://schemas.openxmlformats.org/officeDocument/2006/relationships" id="290" r:id="R7b58c0e58a224939"/>
-    <p:sldId xmlns:r="http://schemas.openxmlformats.org/officeDocument/2006/relationships" id="291" r:id="R6f2d8d6eca7c4608"/>
+    <p:sldId xmlns:r="http://schemas.openxmlformats.org/officeDocument/2006/relationships" id="256" r:id="R8f195bfc49984c04"/>
+    <p:sldId xmlns:r="http://schemas.openxmlformats.org/officeDocument/2006/relationships" id="257" r:id="R26f4faaca8c7453c"/>
+    <p:sldId xmlns:r="http://schemas.openxmlformats.org/officeDocument/2006/relationships" id="258" r:id="Rd9c7af75ed414eab"/>
+    <p:sldId xmlns:r="http://schemas.openxmlformats.org/officeDocument/2006/relationships" id="259" r:id="Rb6be78acf5d74d9e"/>
+    <p:sldId xmlns:r="http://schemas.openxmlformats.org/officeDocument/2006/relationships" id="260" r:id="R2bc7f358c8074e29"/>
+    <p:sldId xmlns:r="http://schemas.openxmlformats.org/officeDocument/2006/relationships" id="261" r:id="Rd5e953dd352049f0"/>
+    <p:sldId xmlns:r="http://schemas.openxmlformats.org/officeDocument/2006/relationships" id="262" r:id="R55bec6a9235d47d5"/>
+    <p:sldId xmlns:r="http://schemas.openxmlformats.org/officeDocument/2006/relationships" id="263" r:id="R80ae8391ac1b4000"/>
+    <p:sldId xmlns:r="http://schemas.openxmlformats.org/officeDocument/2006/relationships" id="264" r:id="R02a06c3964f7494b"/>
+    <p:sldId xmlns:r="http://schemas.openxmlformats.org/officeDocument/2006/relationships" id="265" r:id="Rd9527b58368b4d7a"/>
+    <p:sldId xmlns:r="http://schemas.openxmlformats.org/officeDocument/2006/relationships" id="266" r:id="R30a516abe43a4cbd"/>
+    <p:sldId xmlns:r="http://schemas.openxmlformats.org/officeDocument/2006/relationships" id="267" r:id="R6abe15989d1242fb"/>
+    <p:sldId xmlns:r="http://schemas.openxmlformats.org/officeDocument/2006/relationships" id="268" r:id="Ra03470447ad64162"/>
+    <p:sldId xmlns:r="http://schemas.openxmlformats.org/officeDocument/2006/relationships" id="269" r:id="R228155759fe54d03"/>
+    <p:sldId xmlns:r="http://schemas.openxmlformats.org/officeDocument/2006/relationships" id="270" r:id="R69037bf579c741ad"/>
+    <p:sldId xmlns:r="http://schemas.openxmlformats.org/officeDocument/2006/relationships" id="271" r:id="Rf76a89a254434ec5"/>
+    <p:sldId xmlns:r="http://schemas.openxmlformats.org/officeDocument/2006/relationships" id="272" r:id="R9cce822bf9bd4bf3"/>
+    <p:sldId xmlns:r="http://schemas.openxmlformats.org/officeDocument/2006/relationships" id="273" r:id="R1f1db0d822c246b9"/>
+    <p:sldId xmlns:r="http://schemas.openxmlformats.org/officeDocument/2006/relationships" id="274" r:id="Rdf6b365b9a82485a"/>
+    <p:sldId xmlns:r="http://schemas.openxmlformats.org/officeDocument/2006/relationships" id="275" r:id="R8a5a2482dd124ec1"/>
+    <p:sldId xmlns:r="http://schemas.openxmlformats.org/officeDocument/2006/relationships" id="276" r:id="R46c3f8c0f5cd4402"/>
+    <p:sldId xmlns:r="http://schemas.openxmlformats.org/officeDocument/2006/relationships" id="277" r:id="R5b3b0620a3444afa"/>
+    <p:sldId xmlns:r="http://schemas.openxmlformats.org/officeDocument/2006/relationships" id="278" r:id="R5468fcd2389b4130"/>
+    <p:sldId xmlns:r="http://schemas.openxmlformats.org/officeDocument/2006/relationships" id="279" r:id="R2e1663ac257f41fb"/>
+    <p:sldId xmlns:r="http://schemas.openxmlformats.org/officeDocument/2006/relationships" id="280" r:id="R4ed63827ba9b4c21"/>
+    <p:sldId xmlns:r="http://schemas.openxmlformats.org/officeDocument/2006/relationships" id="281" r:id="R4d878f526a154538"/>
+    <p:sldId xmlns:r="http://schemas.openxmlformats.org/officeDocument/2006/relationships" id="282" r:id="R63d51e13d2644ae8"/>
+    <p:sldId xmlns:r="http://schemas.openxmlformats.org/officeDocument/2006/relationships" id="283" r:id="R550fc64fc3f34b05"/>
+    <p:sldId xmlns:r="http://schemas.openxmlformats.org/officeDocument/2006/relationships" id="284" r:id="R513af8d0e81e4c06"/>
+    <p:sldId xmlns:r="http://schemas.openxmlformats.org/officeDocument/2006/relationships" id="285" r:id="Reeb17867310f46fe"/>
+    <p:sldId xmlns:r="http://schemas.openxmlformats.org/officeDocument/2006/relationships" id="286" r:id="Rf6871520959047d1"/>
+    <p:sldId xmlns:r="http://schemas.openxmlformats.org/officeDocument/2006/relationships" id="287" r:id="Rf2c244f93ba642e3"/>
+    <p:sldId xmlns:r="http://schemas.openxmlformats.org/officeDocument/2006/relationships" id="288" r:id="R07a43578d2cf472b"/>
+    <p:sldId xmlns:r="http://schemas.openxmlformats.org/officeDocument/2006/relationships" id="289" r:id="R6a4c27aa0e3c495c"/>
+    <p:sldId xmlns:r="http://schemas.openxmlformats.org/officeDocument/2006/relationships" id="290" r:id="R1c351c68fabe40fe"/>
+    <p:sldId xmlns:r="http://schemas.openxmlformats.org/officeDocument/2006/relationships" id="291" r:id="Rcdcef5d5c5c34166"/>
   </p:sldIdLst>
   <p:sldSz cx="12192000" cy="6858000"/>
   <p:notesSz cx="6858000" cy="9144000"/>
@@ -487,7 +487,7 @@
           </a:p>
           <a:p xmlns:a="http://schemas.openxmlformats.org/drawingml/2006/main">
             <a:r>
-              <a:t>今天我们讨论一个教育问题：当AI能够参与越来越多认知工作，教师如何判断一种安排对学生有什么价值。请大家带着自己最近的一节课来听，尤其是一项学生用了AI、作品也完成得不错，但你仍不确定他们学到了什么的任务。我们会围绕同一个科学探究情境，三次补充信息、三次重新判断。讲座中的情境是为了讨论而构造的，不是某位教师课堂的实证结果。我们的目标，是带走一套能用于下一次备课和教研的追问方式。</a:t>
+              <a:t>AI能写方案、给反馈、带学生一步步解题。交上来的作品越来越完整，教师反而可能更难回答：学生到底学到了什么？今天就从这个困惑出发。请大家带着最近的一节课来听：哪一项任务完成得不错，却让你对学生的理解拿不准？我们用一个虚构的生态瓶课堂反复讨论，逐次加入新信息，看看自己的判断怎样变化。最后，每人选一个下周能改的教学环节。</a:t>
             </a:r>
           </a:p>
           <a:p xmlns:a="http://schemas.openxmlformats.org/drawingml/2006/main">
@@ -592,7 +592,7 @@
           </a:p>
           <a:p xmlns:a="http://schemas.openxmlformats.org/drawingml/2006/main">
             <a:r>
-              <a:t>这里把目光从原有任务转向新的活动。AI能够帮助生成备选解释、转换表达形式、模拟不同立场。这样的条件可能使学生提出以前难以处理的问题。比如生态瓶研究不再止于完成一份方案，而可以讨论为什么不同方案得到不同证据、哪些解释还需要更多观察。我们不把可能性当成已经实现的学习结果，也不要求所有课堂都采用最复杂的任务。教师的作用是把技术提供的可能组织成学生能够进入、有意义且可持续的活动。</a:t>
+              <a:t>AI提供几个解释，数量本身没有多少教学意义。学生可以先找出解释之间的分歧，再讨论需要什么观察来区分它们。这样，任务就从读懂一个解释，扩展到检验不同解释。生态瓶的变化可能涉及多个条件，哪些已经有记录，哪些还得观察？学生需要参与决定。否则，屏幕上只是多出了几段文字。</a:t>
             </a:r>
           </a:p>
           <a:p xmlns:a="http://schemas.openxmlformats.org/drawingml/2006/main">
@@ -697,7 +697,7 @@
           </a:p>
           <a:p xmlns:a="http://schemas.openxmlformats.org/drawingml/2006/main">
             <a:r>
-              <a:t>这三个例子是需要留意的可能情境，不是对学生的固定分类。某个学生在一个环节得到帮助，也可能在另一个环节失去发言空间。请资深教师回想小组合作中常见的分工：有人操作、有人记录、有人解释，参与方式未必相同。AI加入后还可能改变这种分工。我们需要观察机会怎样分布，并考虑是否允许不同的进入方式。学生主动改变任务方向也值得询问理由，不能仅因没有按预设路线走就判断学习失败。</a:t>
+              <a:t>小组报告掩盖差异，是合作课堂里熟悉的问题。AI加入后，有人借它终于说清了观察，有人的想法被过早定下的方案盖住，也有人只负责搭建。教师可以在一个关键决定上请不同成员分别解释。不是给学生贴固定标签，而是查清这一环节谁有机会想、谁没有。下一次分工据此调整，也要允许学生用口述、画图或操作来表达。</a:t>
             </a:r>
           </a:p>
           <a:p xmlns:a="http://schemas.openxmlformats.org/drawingml/2006/main">
@@ -802,7 +802,7 @@
           </a:p>
           <a:p xmlns:a="http://schemas.openxmlformats.org/drawingml/2006/main">
             <a:r>
-              <a:t>已有框架已经关注教学、人的能动性和教师专业学习。UNESCO提供规范性发展方向；Sun等的框架聚焦大学教师，通过文献综合和专家咨询形成，不能直接视作中小学成效验证。我们尊重这些基础，接着追问能力怎样在具体情境里被运用。教师能够配置复杂AI协作，并不意味着每节课都应采用相同的形式。专业判断需要说明此时为什么这样安排，期待学生经历什么，怎样知道实际发生了什么。</a:t>
+              <a:t>UNESCO框架已包含AI教学法、人的能动性和教师专业学习。Sun等也把GenAI素养与课程设计、教学和评价放在一起，面向的是大学教师，框架来自文献与专家咨询。这些工作帮助界定教师需要什么能力。真正备课时，还要作具体取舍：为什么这里先示范，那里先让学生试？会配置复杂合作的教师，也可能选择直接讲解。专业性体现在选择是否适合眼前的学生，以及能否根据课堂表现调整。</a:t>
             </a:r>
           </a:p>
           <a:p xmlns:a="http://schemas.openxmlformats.org/drawingml/2006/main">
@@ -927,7 +927,7 @@
           </a:p>
           <a:p xmlns:a="http://schemas.openxmlformats.org/drawingml/2006/main">
             <a:r>
-              <a:t>从能力框架进入课堂安排。我们通常用工具、助教、伙伴描述AI，但角色名称不能告诉我们每一个决定是谁作出的。教师、学生、同伴、AI以及平台设置，都可能影响问题、标准和行动顺序。这里不要求把所有决定都交给学生，而是看这些安排是否与当前目标相称。可以请一位听众举一个具体例子：学生选择了按钮，但真正的备选项是谁规定的？这个例子能帮助大家看见自由操作和有意义的选择之间的联系。</a:t>
+              <a:t>称AI为工具、助教或伙伴，还没有说清谁作决定。学生能点击不同按钮，备选项却可能早已规定好；学生能自由提问，问题也可能总被拉回预设路线。请选一节课，看谁提出问题、判断证据、决定结束。教师当然需要承担很多决定。重点是：与本课目标有关的判断，学生有没有机会练习？当他们提出合理异议时，活动能不能改变？</a:t>
             </a:r>
           </a:p>
           <a:p xmlns:a="http://schemas.openxmlformats.org/drawingml/2006/main">
@@ -1032,7 +1032,7 @@
           </a:p>
           <a:p xmlns:a="http://schemas.openxmlformats.org/drawingml/2006/main">
             <a:r>
-              <a:t>这张表是一种可讨论的教学安排，并非最优模板。请先沿着一项工作看：谁提出了想法，谁提供判断依据，谁作出决定，谁实际执行。不要仅依据最后是谁打字来归属全部工作。某些阶段教师直接规定标准很有必要，另一些阶段让学生形成和讨论标准更贴近目标。表格的第三列提醒我们检验安排是否真实产生了学习后果。教师也可以在备课时只选一项关键工作，减少记录负担。</a:t>
+              <a:t>沿着表格看一项具体工作。AI生成备选方案后，比较依据谁来提出？学生决定修改时，能不能说出理由？最后谁打字，不能代表此前全部思考。表中只列了一种可讨论的安排。教师也可以直接示范标准，再让学生尝试运用。备课不妨只选最关键的一行，写清分工；课后就回看这一行实际上怎么发生。</a:t>
             </a:r>
           </a:p>
           <a:p xmlns:a="http://schemas.openxmlformats.org/drawingml/2006/main">
@@ -1137,7 +1137,7 @@
           </a:p>
           <a:p xmlns:a="http://schemas.openxmlformats.org/drawingml/2006/main">
             <a:r>
-              <a:t>模型、提示词、角色、流程、界面和课堂关系并不是同一类事物，但它们共同影响学生的经历。比如提示词要求AI先追问，界面却允许一键生成最终报告；或者流程要求同伴讨论，课堂时间却不足以完成。这些配置可能产生不同方向的作用。讲座不需要展开技术术语，只需让教师看见：一次教学选择通常要跨几个环节才能落实。我们可以把这理解为课堂的整体安排，再通过实际互动检查它的后果。</a:t>
+              <a:t>提示词要求AI先追问，界面却允许一键生成报告；任务单要求同伴讨论，课堂却没留讨论时间。这些情况都可能让设计落空。模型影响回答能力，提示规定回应要求，流程安排先后，界面影响哪些操作容易做，教师和同伴又会临场改变互动。改一条提示后，要看学生有没有因此多做一步解释、比较或选择。</a:t>
             </a:r>
           </a:p>
           <a:p xmlns:a="http://schemas.openxmlformats.org/drawingml/2006/main">
@@ -1242,7 +1242,7 @@
           </a:p>
           <a:p xmlns:a="http://schemas.openxmlformats.org/drawingml/2006/main">
             <a:r>
-              <a:t>请把完整示范理解为一种可选择的支持。它可能帮助初学者看见结构，也可能成为有经验学生批判比较的对象。我们不预设示范之后一定发生学习：学生可能机械复述比较结果，也可能真正用它来改动方案。教师可以观察解释是否有依据、迁移时是否能够调整。与其给所有课堂设定一个永远不能直接回答的规则，更有意义的是说明示范在此处的功能，并为后续活动留下清楚的安排。</a:t>
+              <a:t>完整示范的用途，要连着下一项任务看。可以让学生比较两份方案的假设，解释为什么要控制某个条件，或者在新条件下重新设计。学生也可能把比较结果一起交给AI，再照着读，所以教师仍要追问具体理由。关键是示范给学生提供了什么材料，后面的任务让他怎样使用这些材料。</a:t>
             </a:r>
           </a:p>
           <a:p xmlns:a="http://schemas.openxmlformats.org/drawingml/2006/main">
@@ -1347,7 +1347,7 @@
           </a:p>
           <a:p xmlns:a="http://schemas.openxmlformats.org/drawingml/2006/main">
             <a:r>
-              <a:t>这页不批评提问法，而是提醒我们观察提问与实际思考之间的关系。结构化追问对一些学生可能非常有帮助；问题在于，我们不能仅凭对话轮数推断推理质量。假如AI已经规定所有步骤，学生只需要填出很小的答案，教师需要检验学生是否理解整体关系。相反，学生也可能主动改写问题、指出矛盾、选择另一条路线。我们要识别这些具体活动，并根据学生当前需要决定下一阶段是否改变支持。</a:t>
+              <a:t>设想AI问了十轮，每一轮都把答案缩小到几个词。学生回答得很顺，课后却说不清为什么要这样设计实验。这样的情境提醒我们：频繁回应仍可能缺少对整体思路的理解。连续追问当然可以帮助学生，尤其在他不知道从哪里开始时。教师要听的是，学生能否把各步联系起来，能否发现某个问题问得不合适，条件变了会怎样处理。检查这些表现，才知道下一步该继续提示，还是给学生更大的尝试空间。</a:t>
             </a:r>
           </a:p>
           <a:p xmlns:a="http://schemas.openxmlformats.org/drawingml/2006/main">
@@ -1452,7 +1452,7 @@
           </a:p>
           <a:p xmlns:a="http://schemas.openxmlformats.org/drawingml/2006/main">
             <a:r>
-              <a:t>这三个阶段只是帮助讨论的一种安排，不能当作所有学生都要按同一节奏走的能力等级。有些学生需要回到示范，有些学生能较早进入开放任务，某些复杂工作则可能长期保留协作支持。逐步改变支持的目的，是让学生以更有理解、更有根据的方式参与。独立完成是一类可能目标，能够判断何时和怎样借助AI也是一类目标。下一页把这些思考放回生态瓶案例，比较不同组织方式的适用条件。</a:t>
+              <a:t>初次接触实验设计，可以先看示范并解释关键步骤；已有经验后，再起草方案、接受反馈；换了情境，则尝试自己选择方法和需要的帮助。这只是一个可调整的教学顺序。某位学生遇到困难可能需要回到示范，复杂任务也可能长期需要合作。支持增减要跟着表现走：哪一步已经理解，哪一步仍离不开提示？</a:t>
             </a:r>
           </a:p>
           <a:p xmlns:a="http://schemas.openxmlformats.org/drawingml/2006/main">
@@ -1557,7 +1557,7 @@
           </a:p>
           <a:p xmlns:a="http://schemas.openxmlformats.org/drawingml/2006/main">
             <a:r>
-              <a:t>请听众选一条路径，并说出自己的条件。鼓励他们提出第四种安排，例如教师示范一部分、同伴先比较、AI最后补充。每条路径都要说明预期活动与可观察证据之间的关系。不要把表中的证据要求变成机械打勾：学生说出解释之后，还需要关注解释质量与是否进入实践。这个表格也提示，比较两个课堂时要了解目标、起点、时间和支持条件，避免将所有差异归到AI角色名称上。</a:t>
+              <a:t>请选一条你会采用的路径，并说出适合哪种学生。先示范，可以观察学生能否解释和改动关键步骤；先尝试，可以看反馈之后改了什么、为什么改；比较多个方案，则要看取舍依据有没有进入决定。也可以提出第四种安排。我们在教研里比较的，应该包括学生起点与预期活动，而不仅是工具名称。</a:t>
             </a:r>
           </a:p>
           <a:p xmlns:a="http://schemas.openxmlformats.org/drawingml/2006/main">
@@ -1662,7 +1662,7 @@
           </a:p>
           <a:p xmlns:a="http://schemas.openxmlformats.org/drawingml/2006/main">
             <a:r>
-              <a:t>请设想一个课堂，学生围绕光照条件与生态瓶变化开展探究。AI给出一份看起来完整的方案，小组直接采用，完成搭建和后续观察，报告也很整齐。这里没有提供真正的实验数据，我们暂时只知道作品和活动的外观。教师很容易迅速作出两种判断：有人觉得效率提高了，有人觉得学生被替代了。先保留这种直觉，下一页请大家说出还想知道的信息。生态瓶只是贯穿案例，各学科教师可以把它换成作文、数学解题或项目方案。</a:t>
+              <a:t>设想学生研究光照与生态瓶变化的关系。AI给出研究问题、对照安排和记录表，小组照着搭建、观察，最后交出整齐的报告。你会怎样评价？有人会说省下时间了，也有人会担心学生没有自己设计。先把判断记下来。这是一个虚构情境，目前只告诉了大家任务怎么完成，还没有告诉大家教学目标、学生起点和讨论经过。其他学科可以把它换成一篇作文或一道数学题。</a:t>
             </a:r>
           </a:p>
           <a:p xmlns:a="http://schemas.openxmlformats.org/drawingml/2006/main">
@@ -1767,7 +1767,7 @@
           </a:p>
           <a:p xmlns:a="http://schemas.openxmlformats.org/drawingml/2006/main">
             <a:r>
-              <a:t>这是为教学讨论补充的两种假设过程，不是实测组间结果。请给听众40秒与邻座交流：新信息让你改变了什么判断？我们可以更有根据地说第二组发生了某些比较与修改活动，但还不能证明所有组员都形成了持久理解。第一组的复述也需要结合学生起点判断，它可能处于某种初步学习阶段。请追问后续会安排什么任务、观察什么表现。这样把判断推进一步，又保留尚不清楚的部分，进入教师专业判断的讨论。</a:t>
+              <a:t>再补两组课堂经过：一组主要复述，另一组发现条件不一致，修改并解释原因。请与邻座交流40秒，新信息怎样改变了判断？第二组已有比较和修订的线索，但小组表现还不能代表每个人都懂。第一组复述到了哪一步，也要结合此前经验看。现在最值得补问谁？下节课安排什么，才能进一步了解他们？</a:t>
             </a:r>
           </a:p>
           <a:p xmlns:a="http://schemas.openxmlformats.org/drawingml/2006/main">
@@ -1872,7 +1872,7 @@
           </a:p>
           <a:p xmlns:a="http://schemas.openxmlformats.org/drawingml/2006/main">
             <a:r>
-              <a:t>前面我们比较了几种人机安排。现在请大家把注意力移到选择背后的理由。同样让AI提供完整方案，对于刚接触实验设计的学生，教师可能希望先帮助他们读懂方案；对于正在练习控制变量的学生，教师则需要判断方案是否让他们绕过了关键决定。两种判断都必须联系具体目标和学生起点。第三项尤其容易被忽略：我预计学生会因此做什么？是解释方案、比较备选，还是主要照着执行？我们可以在备课时写下一个能够观察的预期，再在课后回看。专业判断允许不确定，但需要说清依据，也愿意接受课堂证据的修正。接下来，我们看哪些学生表现值得促使教师改变安排。</a:t>
+              <a:t>作一次教学选择，至少要知道教什么、教谁、怎样看效果。让AI给完整方案，是想帮助学生认识结构，还是想让他们比较多个设计？学生的困难是没想法、不会表达，还是不理解对照？把这些理由写具体，再预想一个学生表现。例如，希望学生能解释为什么两瓶植物数量要一致。课堂里听到解释后，还可以给一个变化条件，看看理解是否稳固。</a:t>
             </a:r>
           </a:p>
           <a:p xmlns:a="http://schemas.openxmlformats.org/drawingml/2006/main">
@@ -1977,7 +1977,7 @@
           </a:p>
           <a:p xmlns:a="http://schemas.openxmlformats.org/drawingml/2006/main">
             <a:r>
-              <a:t>这页仍然是我们设定的讨论情境，并非实际研究结果。假设教师听到学生正确说出“控制变量”，但在方案里没有发现两组条件的差异。我们第一反应可能是学生没有理解，不过还需要考虑其他解释：他们看到了却没有被问到，或者小组内只有一个人负责检查。面对这种情况，调整之前可以先增加一次有针对性的观察，例如请不同成员指出某一处差异，并解释它为什么重要。这能帮助我们决定接下来应补充示范、重新分配回应机会，还是让学生比较方案。请大家想一想，你通常依据什么判断“需要介入了”？完成速度、学生表情和作品正确率都可能有用，但各自只能支持一部分判断。</a:t>
+              <a:t>在这个假设课堂里，两瓶的植物数量不同，学生却说其他条件相同。先别急着重复讲控制变量。可以指着两瓶问不同成员：你看到什么差异？它会不会影响我们对光照的判断？如果学生能解释，只是检查时漏掉了，下一步可以改进检查方法。如果说不清为什么数量重要，就需要补充比较或示范。若始终只有一个组员答得出，则要安排其他成员也来解释。一次短追问，能帮助教师区分几种需要不同处理的问题。</a:t>
             </a:r>
           </a:p>
           <a:p xmlns:a="http://schemas.openxmlformats.org/drawingml/2006/main">
@@ -2082,7 +2082,7 @@
           </a:p>
           <a:p xmlns:a="http://schemas.openxmlformats.org/drawingml/2006/main">
             <a:r>
-              <a:t>请大家先读一下这条句式。它本身可以很有帮助，尤其当学生已经形成一些想法，却不知道如何表达时。问题在于，同一句式也可能被学生或AI填得十分漂亮，而其中的因果关系仍然不清楚。我们不能根据文字更完整就断定推理提高，也不能因此否定句式支架。可以进一步请学生指出这句话来自哪一次观察，说明为什么这条观察支持结论，再提供一条不同的观察，让他解释判断是否需要改变。这样的检查仍然需要考虑语言能力，允许学生通过口述、指认、画图或操作表达。这里要辨认的是支架具体帮助了哪一步。下一页我们把这些零散线索放回一个完整的证据关系中。</a:t>
+              <a:t>“我们认为……因为观察到……”可以帮助学生把想法说完整。但“因为”后面填了文字，不一定讲清了观察与结论的关系。请学生指出具体哪一次观察，再解释它为什么支持判断。换一条记录，原结论还成立吗？允许口述、画图或操作，避免把语言表达的困难误当成推理困难。这样才能知道句式帮助了表达，还是连理解也推进了。</a:t>
             </a:r>
           </a:p>
           <a:p xmlns:a="http://schemas.openxmlformats.org/drawingml/2006/main">
@@ -2187,7 +2187,7 @@
           </a:p>
           <a:p xmlns:a="http://schemas.openxmlformats.org/drawingml/2006/main">
             <a:r>
-              <a:t>教师每天都在接触证据，只是这些材料经常被混在一起使用。一个配置得很好的智能体，可以说明我们的设计意图；它不能单独说明学生经历了预期活动。课堂记录帮助我们看到互动，但学生也可能在纸上讨论、私下思考或接受了教师口头支持。作品版本能够显示发生了哪些修改，却未必说明是谁理解了修改的理由。后续任务又提供了另一种信息，但仍需要交代是否使用AI、间隔多久、任务改变了什么。我们不需要每节课都收集完整研究材料，可以围绕一个最关心的判断，选择两三种互相补充的线索。关键是让材料回答它能够回答的问题，避免从一张漂亮作品直接跳到每个人都掌握了。</a:t>
+              <a:t>任务单告诉我们原本怎样设计，互动记录告诉我们部分经过，作品版本显示改了什么，后续任务帮助判断能否再用。几种材料不能互相代替。比如日志没有理由，不妨看看纸上是否画过，听听组员怎样解释；作品修改很大，也要问修改依据来自谁。日常教研可以只围绕一个疑问，补两种材料，不必把每节课变成大型数据采集。</a:t>
             </a:r>
           </a:p>
           <a:p xmlns:a="http://schemas.openxmlformats.org/drawingml/2006/main">
@@ -2292,7 +2292,7 @@
           </a:p>
           <a:p xmlns:a="http://schemas.openxmlformats.org/drawingml/2006/main">
             <a:r>
-              <a:t>这一页描述的是一种探索思路，三个步骤仍是示例，不代表我们已经完成了这样的研究。课堂尝试的价值，有时在于让原来的问题变得更准确。最初我们可能问，怎样让AI给出更好的提示；观察之后发现，提示质量只解释了一部分，学生是否有回应机会、回应能否影响小组决定，也很关键。于是下一次改动会同时涉及教学安排与我们观察学习的方法。做教研时，可以简单留下四项记录：当时为什么这样做，预期发生什么，实际看到什么，下一次准备改变什么。也记录那些改变了安排却没有出现预期活动的情况。这些材料能让探索逐渐形成有条件的经验，并帮助同事判断哪些做法值得在自己的班级尝试。</a:t>
+              <a:t>设想我们把提示词改得更细，让AI不断追问“为什么”。回看课堂才发现，学生赶着进入下一步，有人随手答了一句，小组方案照旧。问题就变了：原来只问提示够不够好，现在还要问学生有没有时间回应，同伴有没有听，回答有没有影响决定。下一次可以选一处关键分歧，让两名成员各说依据，再共同决定方案怎么改。回看时追踪这一处就够了。如果讨论变多、方案仍未改变，也要查清是原方案本来就合理，还是讨论没有触及关键。教研经验来自这样逐次查明原因，失败的尝试也要留下。</a:t>
             </a:r>
           </a:p>
           <a:p xmlns:a="http://schemas.openxmlformats.org/drawingml/2006/main">
@@ -2397,7 +2397,7 @@
           </a:p>
           <a:p xmlns:a="http://schemas.openxmlformats.org/drawingml/2006/main">
             <a:r>
-              <a:t>我们刚才一直讨论学生，其实同样的问题也适用于教师。AI帮助我们更快形成教案，可能腾出时间分析学生，也可能让我们少经历一次认真推敲教学难点的过程。具体作用取决于后续怎样使用。例如，可以请AI为同一个目标提出不同安排，再由教师结合班级实际解释取舍；也可以回到几份学生原始作品，检查AI归纳的困难有没有遗漏。这里不要求教师记录所有操作，只需留下一个重要判断及其依据。下一次遇到新班级或新单元时，再看自己能否据此作出更合适的调整。教案写得更快、自信提高，都是有意义的信息；教师专业理解怎样变化，还需要通过判断理由与后续实践来观察。</a:t>
+              <a:t>同样问问自己：AI写完教案后，我对学生的困难更清楚了吗？可以让AI提出几种教法，再结合班级里的具体表现解释取舍。也要回看学生原话和原始作品，检查摘要有没有漏掉细节。留下一条最重要的采纳理由：它针对什么困难，上课时怎样检查。过一段时间换班级或单元，再看自己能否运用这条经验。这样才有依据讨论教师理解怎样发展。</a:t>
             </a:r>
           </a:p>
           <a:p xmlns:a="http://schemas.openxmlformats.org/drawingml/2006/main">
@@ -2502,7 +2502,7 @@
           </a:p>
           <a:p xmlns:a="http://schemas.openxmlformats.org/drawingml/2006/main">
             <a:r>
-              <a:t>请大家回想一项自己经常坚持让学生亲自完成的工作。我们保留它，是因为其中包含重要的理解过程，还是主要因为过去一直这样做？以生态瓶任务为例，如果重点是比较证据，AI帮助整理记录格式可能让学生更容易进入讨论；如果重点是理解怎样设计记录表，完整代做就改变了学习活动。同样，有价值的困难也需要处在学生能够获得支持并逐步参与的范围内。教师可以先示范，再共同完成，再给一次更独立的机会，也可以根据具体情况采用其他路径。我们无需把学生承担工作的数量当成统一标准，而应当解释这项承担与发展目标之间的关系。下面转到证据：当下做得更好，后续会发生什么？</a:t>
+              <a:t>困难是否值得保留，要看它在教什么。比较证据的课，可以减轻排版负担；学习设计记录表的课，就需要让学生考虑记录哪些项目。同样，值得经历的思考也需要适当帮助。学生完全不知道怎样开始，可以先示范一部分，再让他处理一个差异。让学生承担更多步骤并不是统一目标，重要的是承担哪些步骤、从中学到什么。</a:t>
             </a:r>
           </a:p>
           <a:p xmlns:a="http://schemas.openxmlformats.org/drawingml/2006/main">
@@ -2717,7 +2717,7 @@
           </a:p>
           <a:p xmlns:a="http://schemas.openxmlformats.org/drawingml/2006/main">
             <a:r>
-              <a:t>讨论AI教学时，我们很容易只追问撤去AI以后还能不能做。这个问题对某些目标十分重要，例如学生是否理解控制变量的理由。但我们也可能希望学生学会借助工具与同伴开展更复杂的探究，这时AI在场的表现同样值得研究。关键在于明确评价对象。如果评价个人理解，需要能够辨认个人解释与选择的证据；如果评价合作探究，需要观察问题怎样提出、贡献怎样被检查和组织，以及最终判断怎样形成。两类能力可以彼此促进，但一种表现不能自动证明另一种已经形成。讲座的目标不是给所有课堂设定统一的终点，而是帮助教师说明自己追求哪一种发展，并选择与之相配的观察方式。</a:t>
+              <a:t>若目标是个人理解控制变量，就需要看学生自己的解释与新任务表现。若目标是借助AI和同伴完成复杂探究，就要看问题怎样提出、贡献怎样检查、最终决定怎样形成。两种目标都值得追求，也可能相互促进。但一份精彩的合作成果不能直接证明个人掌握；一次无AI测验也不能完整评价合作能力。评价前先说清自己要判断什么。</a:t>
             </a:r>
           </a:p>
           <a:p xmlns:a="http://schemas.openxmlformats.org/drawingml/2006/main">
@@ -2822,7 +2822,7 @@
           </a:p>
           <a:p xmlns:a="http://schemas.openxmlformats.org/drawingml/2006/main">
             <a:r>
-              <a:t>给听众30秒独立想一想，再请两位教师各用一句话回应。追问时不急于评价答案，可以问：你为什么需要这条信息？它会怎样改变你的判断？听众可能提出学生年龄、此前经验、教学目标、是否比较方案、能否解释选择、以后能否运用。把这些回答口头归到目标、起点、过程和后续证据四类。强调当前信息不足以断定成功或失败。我们正在练习把一个笼统立场转化为可以进一步查明的教学问题。</a:t>
+              <a:t>留30秒独立思考，请两位教师回应。每人说完后追问：如果补看这条信息，你的判断可能怎样改变？有人想听学生解释，有人想看最初的想法，也有人先问这节课教什么。把这些分歧留在现场。经验丰富的教师也会给出不同判断；接下来要讨论的，正是分歧背后的依据。</a:t>
             </a:r>
           </a:p>
           <a:p xmlns:a="http://schemas.openxmlformats.org/drawingml/2006/main">
@@ -2927,7 +2927,7 @@
           </a:p>
           <a:p xmlns:a="http://schemas.openxmlformats.org/drawingml/2006/main">
             <a:r>
-              <a:t>当我们尝试一种新安排，并看到更好的作品时，通常很想把它归因于这次改动。这是一条值得继续检验的解释，但还要留意其他变化。例如，第二次学生更熟悉任务，教师也许增加了口头指导，小组成员的分工或练习时间发生了变化。日常教研不必每次都做严格实验，却可以把这些条件记录下来，让结论与证据相称。反例也很有价值：同样的安排为何没有帮助某些学生？有时它提醒我们需要改变支持，有时说明原先预期的作用过程并没有发生。请大家特别留意时间尺度。当堂的成功、下周的运用和跨单元的迁移，分别提供不同信息。我们可以先做一个小而清楚的后续检查，再逐步积累判断。</a:t>
+              <a:t>第二次作品变好，可能与新安排有关，也可能因为学生更熟悉任务，教师多讲了一次，或同伴提供了更多帮助。先把这些变化记下来，结论才站得稳。再看没有进步的学生：他卡在同一处吗？新支持真的到达他了吗？最后加一次小规模后续检查，下周换个条件再问。这些做法能帮助教研查清有效的原因与适用条件。</a:t>
             </a:r>
           </a:p>
           <a:p xmlns:a="http://schemas.openxmlformats.org/drawingml/2006/main">
@@ -3032,7 +3032,7 @@
           </a:p>
           <a:p xmlns:a="http://schemas.openxmlformats.org/drawingml/2006/main">
             <a:r>
-              <a:t>这是使用平台数据时特别需要注意的一页。日志可以准确记录某些操作，却不会自动记录全部学习。学生没有在AI对话框里解释理由，可能是在纸上画图、与同伴讨论，或者已经得到教师的口头追问。另一方面，小组提交了很好的理由，也可能主要来自其中一位成员。我们需要同时避免两种跳跃：把记录里没有出现的活动判断为不存在，把集体产出归为每个人都已经掌握。可行的补充不一定很重，例如随机请不同成员解释一个决定，让学生独立标注方案中的一个问题，或者允许通过操作展示理解。尤其要给表达速度、语言背景不同的学生合适的表现机会。接下来，我们加入新材料，重新判断开场的课堂情境。</a:t>
+              <a:t>平台看得到输入与点击，看不到的还很多。学生可能在纸上画图、讨论，也可能听了教师一句关键追问。反过来，日志里的一段好解释也可能只出自一个成员。请不同学生分别解释一个决定，或用操作展示理解，往往就能补上重要信息。记录缺失和个人掌握，都不能靠小组产出直接推断。</a:t>
             </a:r>
           </a:p>
           <a:p xmlns:a="http://schemas.openxmlformats.org/drawingml/2006/main">
@@ -3137,7 +3137,7 @@
           </a:p>
           <a:p xmlns:a="http://schemas.openxmlformats.org/drawingml/2006/main">
             <a:r>
-              <a:t>请注意，这两条是为讨论构造的材料，不是我们的研究结果。它们故意提供不完整且不同层面的证据。第一条来自个人无AI新任务，可以支持学生识别某种设计问题的判断，但还不能说明他能够解释或独立修改。第二条来自小组与AI共同探究，显示一个值得继续观察的提问方向，但我们还不知道每位成员怎样理解，也不知道补测是否真的进入后续决定。请和身边同伴交流一分钟：现在，你会保留开场时的判断吗？下一课首先需要改变哪一项安排，或者补充哪一种观察？我们不要求所有人选同一个方案。请说明自己的依据，并提出一条可能让你再次改变决定的证据。</a:t>
+              <a:t>最后补两条假设材料。一名学生独立发现新实验同时改变了两个条件，但没有说明怎么改；一个小组提出温度也可能影响结果，要求补测，但两名成员理解不清。请与同伴交流一分钟：下一课先做什么？可以追问个人怎样修改，也可以请不同成员解释为什么要补测。已有材料分别支持了识别问题和小组提出疑问，还缺解释、落实和个人理解。选一个你认为最要紧的缺口，说出理由。</a:t>
             </a:r>
           </a:p>
           <a:p xmlns:a="http://schemas.openxmlformats.org/drawingml/2006/main">
@@ -3242,7 +3242,7 @@
           </a:p>
           <a:p xmlns:a="http://schemas.openxmlformats.org/drawingml/2006/main">
             <a:r>
-              <a:t>这四个入口分别对应讲座中的不同问题。UNESCO框架帮助我们理解教师需要发展的能力，Cukurova的讨论将注意力放在人类认知与发展的关系上，Sun等的框架把GenAI素养与课程设计、教学和评价连接起来，研究对象是大学教师，Bastani和同事的研究提示我们交代支持方式与测量条件。大家课后可以根据自己最关心的问题选择阅读。这些来源为讨论提供依据，也各自有适用范围。今天的五问卡是我们综合讨论形成的备课与教研工具，不是一套经过完整验证的测评量表，也不会直接给出课堂好坏的分数。接下来，我们把这些问题带回每个人熟悉的一节课，形成一个可以尝试的小改动。</a:t>
+              <a:t>课后可按问题选择阅读：想了解教师AI能力，读UNESCO；想追问自动化与人的发展，读Cukurova；关注大学教师课程与评价设计，读Sun等；想看练习成绩与后续学习的实证区别，读Bastani等。接下来的五问是备课讨论工具，尚未经过量表验证，不用于给教师打分。</a:t>
             </a:r>
           </a:p>
           <a:p xmlns:a="http://schemas.openxmlformats.org/drawingml/2006/main">
@@ -3397,7 +3397,7 @@
           </a:p>
           <a:p xmlns:a="http://schemas.openxmlformats.org/drawingml/2006/main">
             <a:r>
-              <a:t>这张卡可以单独保存，用于备课，也可以放在教研会议里。使用时不必写长篇回答，选一个关键环节就够了。第一问把目标说得具体，例如学生能够解释一个方案为什么能帮助比较，而不是只写“培养高阶思维”。第二问说明需要经历的活动。第三问追踪AI改变了什么，也容纳新的活动和目标。第四问提醒我们关注不同学生，不把小组平均表现当成所有人的经验。第五问让设计保持开放：我准备看见什么，如果没有发生，将怎样调整？教师之间最有价值的交流，往往出现在同一个目标下选择了不同安排的时候。五问卡可以让这些差异被说明，也帮助大家明确下一次共同观察什么。</a:t>
+              <a:t>选一个关键环节，每问只写一两句。第一问别只写高阶思维，可以写“解释为什么两瓶需要保持相同条件”。第二问安排学生实际要做的解释或比较。第三问写清AI承担什么。第四问想想谁可能一直没机会说理由。第五问预先约定：若学生会背原则却不会检查方案，我准备怎样改？教研时交换这五个回答，比单纯展示提示词更容易讨论教学。</a:t>
             </a:r>
           </a:p>
           <a:p xmlns:a="http://schemas.openxmlformats.org/drawingml/2006/main">
@@ -3502,7 +3502,7 @@
           </a:p>
           <a:p xmlns:a="http://schemas.openxmlformats.org/drawingml/2006/main">
             <a:r>
-              <a:t>现在请选一节近期真的要上的课。范围可以很小，例如实验方案讨论、作文修改或一段阅读比较。第一分钟只写两句话：希望学生能够做什么，为此需要经历什么活动。第二分钟明确AI介入的位置，以及学生和同伴还会怎样参与，然后选一处最值得调整的安排。第三分钟请和身边同伴交换想法，重点听对方准备用什么观察来判断，而不急着推荐工具。如果某位教师暂时没有使用AI的计划，也可以讨论一个假设的介入点。最后请在纸上圈出一个下一周能够尝试的小改动。主持时可报两次时间，让讨论按步推进；如果有余量，邀请一位教师用二十秒分享他的改动和修订依据。</a:t>
+              <a:t>给自己三分钟，选一节下周真的要上的课。第一分钟定一件要学会的事和必须经历的一步；第二分钟改一处分工或顺序；第三分钟与邻座核对准备观察什么。范围尽量小，比如比较两份实验方案时，先让每人独立标出一个差异，再讨论是否修改。把观察点写进教案，并约同事一起回看。有余量时请一位教师分享改动和判断依据。</a:t>
             </a:r>
           </a:p>
           <a:p xmlns:a="http://schemas.openxmlformats.org/drawingml/2006/main">
@@ -3607,7 +3607,7 @@
           </a:p>
           <a:p xmlns:a="http://schemas.openxmlformats.org/drawingml/2006/main">
             <a:r>
-              <a:t>回到我们的题目，这场讲座给出的是一个持续需要教师参与的问题。不同学科、学生和阶段，可以有不同的教育目标。我们共同追问的是，这些目标怎样进入真实的课堂安排，又怎样通过学生的活动和后续表现得到检验。AI提供了新的资源，也改变了谁提出问题、谁解释证据、谁决定下一步。教师的专业判断会在这些具体选择中发挥作用，并随着实践积累而发展。最后留一点时间，请大家提出一个仍然拿不准的问题，最好来自真实课堂。我们可以先讨论还需要知道哪些信息，再讨论采取什么行动。如果你只带走一个问题，我希望是：这项安排让学生获得了怎样的发展机会，我凭什么这样判断？谢谢大家。</a:t>
+              <a:t>我们从一份完整的AI方案出发，追问学生学到了什么。随着材料增加，判断也更具体：谁解释过，理由有没有改变方案，换了条件还能不能处理。教育要成就的，落在这些具体本领上。学生能够说明自己的想法，在新问题面前作出判断，也能够借助AI和同伴做成更复杂的事。教师要决定哪些帮助现在需要、哪些工作值得学生亲历，并在课堂里检查自己的判断。请大家回到刚写的那个改动：下一节课，你准备让学生亲自作出哪个有分量的判断？最后留时间交流。请从一处拿不准的课堂细节开始，我们一起讨论还缺什么信息、下一步可以怎样教。</a:t>
             </a:r>
           </a:p>
           <a:p xmlns:a="http://schemas.openxmlformats.org/drawingml/2006/main">
@@ -3712,7 +3712,7 @@
           </a:p>
           <a:p xmlns:a="http://schemas.openxmlformats.org/drawingml/2006/main">
             <a:r>
-              <a:t>展示三种教学用途，避免把它们排成从低到高的等级。第一种可能让初学者进入原本无法把握的活动；第二种要求特别留意AI进入后学生是否仍有机会练习目标工作；第三种可能让比较的范围扩大。每一种都只是设计意图，需要进一步看学生实际做了什么。教师会知道，好的示范有时比连续追问更能帮助学生，开放任务有时也会使学生迷失。AI使这种判断更需要被说清楚，因为同一个界面很容易承担不同性质的工作。</a:t>
+              <a:t>先问这节课教什么。如果学生第一次接触实验，完整方案可以让他们认识结构，教师逐步问清为什么需要对照。如果正在练习实验设计，变量和观察项目本来就该留给学生考虑。若学生已有基础，则可以用几份方案比较假设与限制。同一份材料，教学用途不同。备课写了“比较”，也要看课堂里是否真有比较：学生指出了哪处差异，这处差异怎样影响选择？</a:t>
             </a:r>
           </a:p>
           <a:p xmlns:a="http://schemas.openxmlformats.org/drawingml/2006/main">
@@ -3817,7 +3817,7 @@
           </a:p>
           <a:p xmlns:a="http://schemas.openxmlformats.org/drawingml/2006/main">
             <a:r>
-              <a:t>这三问是今天的主线。任务完成有实际价值，但人的理解和能力发生了什么，需要另行考察。Cukurova关于混合智能的概念论文已经提出这一层区分，因此我们把它作为思想基础，而不声称这是新的发现。我们进一步把它转成教师可以在具体课堂里运用的问题。人的发展包括独立理解、迁移，也可能包括借助AI提出更好的问题、开展原来难以完成的探究。接下来先讨论目标，再进入学习机会和具体人机安排。</a:t>
+              <a:t>任务做好和学生学会之间，需要有教学上的连接。AI展示方案后，学生有没有读懂设计理由？遇到不同条件，能不能改？这些连接不会因为用了AI就自然出现。Cukurova关于混合智能的讨论，已经强调任务自动化与人的认知发展的区别。今天把这个问题落到备课：确定要学的本领，安排形成这种本领的活动，再想好怎样检查。能够独立完成、能够借助AI开展更复杂的探究，都可以是目标，但要分别说清。</a:t>
             </a:r>
           </a:p>
           <a:p xmlns:a="http://schemas.openxmlformats.org/drawingml/2006/main">
@@ -3927,7 +3927,7 @@
           </a:p>
           <a:p xmlns:a="http://schemas.openxmlformats.org/drawingml/2006/main">
             <a:r>
-              <a:t>请教师选一项自己所在学科长期保留的任务：它为什么值得学生亲历？答案可以是形成概念、练习判断、获得某种经验，也可以是为更复杂的实践打基础。原有任务并不因为存在多年就自动需要原样保留，也不因为AI能完成就失去价值。例如整理资料可能帮助初学者看见分类差异，但在另一个单元里也可能只是耗时环节。我们需要讨论其在这一学习阶段的作用。三种选择经常会在同一节课中并存。</a:t>
+              <a:t>拿一项常布置的作业来想：为什么要学生做？整理资料有时是在学习分类，有时只是抄录。前者需要认真安排学生参与，后者可以考虑交给AI。AI还能提供多个解释，让学生去找分歧、设计检验。保留、调整和新增可以同时发生在一个单元里。教师要说清的是，每项任务究竟帮助学生建立哪一种理解。</a:t>
             </a:r>
           </a:p>
           <a:p xmlns:a="http://schemas.openxmlformats.org/drawingml/2006/main">
@@ -4032,7 +4032,7 @@
           </a:p>
           <a:p xmlns:a="http://schemas.openxmlformats.org/drawingml/2006/main">
             <a:r>
-              <a:t>这一页用三个层次帮助我们组织观察，而不是提供一条已经被验证的自动因果链。好作品可能来自学生的理解、AI的贡献、同伴的帮助，或几者的共同作用。看到学生解释，也还需要判断解释是否进入了实际决定。后续表现则帮助我们考察变化是否超出当下支持条件。把三层连起来，能够避免只拿一个结果为整次教学背书。教师并不需要每节课都做大型研究，但可以围绕一个关键目标，有意识地多收集一类证据。</a:t>
+              <a:t>一份好报告可以证明小组完成了任务。要知道学生学到什么，往前看它怎样产生，往后看学生还能怎样运用。比如报告解释了植物变化，理由是谁提出的？其他成员能不能说明？下周换一种条件，学生会不会改方案？这些问题不需要每节课全部检查。选一个本课最重要的判断，补看过程和一次后续表现，就比单看成品更有依据。</a:t>
             </a:r>
           </a:p>
           <a:p xmlns:a="http://schemas.openxmlformats.org/drawingml/2006/main">
@@ -4142,7 +4142,7 @@
           </a:p>
           <a:p xmlns:a="http://schemas.openxmlformats.org/drawingml/2006/main">
             <a:r>
-              <a:t>把支持理解为帮助学生进入活动。例如学生已经观察到生态瓶的变化，却难以整理连续记录。AI协助整理后，学生可能有机会比较不同时间的变化，并提出解释。我们仍然需要看他们是否读懂整理结果，是否依据记录作出判断。对于阅读、表达或身体操作存在障碍的学生，支持还可能打开参与机会。不要把借助帮助一概理解为能力不足；重点是帮助如何与目标活动连接，以及下一步学生能够怎样参与。</a:t>
+              <a:t>学生有连续观察记录，却看不出变化，可以让AI帮助整理。之后请学生自己指出差异，说说哪条记录支持哪个解释。如果学生读得懂表格、能据此提出新问题，这种帮助就与探究接上了。如果表格清楚了，学生仍说不出意义，下一步要教的就是怎样读记录。表达支持也一样：它能帮助原先说不出的学生开口，但还要听清他说的理由。</a:t>
             </a:r>
           </a:p>
           <a:p xmlns:a="http://schemas.openxmlformats.org/drawingml/2006/main">
@@ -4247,7 +4247,7 @@
           </a:p>
           <a:p xmlns:a="http://schemas.openxmlformats.org/drawingml/2006/main">
             <a:r>
-              <a:t>绕过本身不等于教育损失。学生不需要在每个任务中亲自完成每一种操作。关键是被绕过的活动与当前目标有什么关系。如果目标是学习怎样解释证据，自动整理版式可能合适；如果目标是从杂乱信息中形成分类，自动整理就可能承担了需要练习的工作。即使是目标活动，也可以通过示范和后续练习分阶段安排。教师需要追问的是机会是否以其他形式重新出现，而不是简单计算AI替学生做了几步。</a:t>
+              <a:t>省掉排版，可能腾出时间讨论证据；省掉选择变量，则可能省掉了本课正要练的工作。同一操作在不同课里也有不同用处：记录表的设计本身可以是学习目标，也可以只是为另一个探究服务。目标工作不必每次都从零开始，先示范、再让学生处理新条件也可行。要检查的是，学生有没有在整段教学中获得练习机会。</a:t>
             </a:r>
           </a:p>
           <a:p xmlns:a="http://schemas.openxmlformats.org/drawingml/2006/main">
@@ -4340,7 +4340,7 @@
   </p:cSld>
   <p:clrMap bg1="lt1" tx1="dk1" bg2="lt2" tx2="dk2" accent1="accent1" accent2="accent2" accent3="accent3" accent4="accent4" accent5="accent5" accent6="accent6" hlink="hlink" folHlink="folHlink"/>
   <p:sldLayoutIdLst>
-    <p:sldLayoutId xmlns:r="http://schemas.openxmlformats.org/officeDocument/2006/relationships" id="2147483649" r:id="Rb1c47985622e4949"/>
+    <p:sldLayoutId xmlns:r="http://schemas.openxmlformats.org/officeDocument/2006/relationships" id="2147483649" r:id="R69d8f05264cd4da7"/>
   </p:sldLayoutIdLst>
   <p:txStyles>
     <p:titleStyle>
@@ -4895,7 +4895,7 @@
           <p:nvPr/>
         </p:nvPicPr>
         <p:blipFill>
-          <a:blip xmlns:r="http://schemas.openxmlformats.org/officeDocument/2006/relationships" xmlns:a="http://schemas.openxmlformats.org/drawingml/2006/main" r:embed="R6435e457b05a4f14"/>
+          <a:blip xmlns:r="http://schemas.openxmlformats.org/officeDocument/2006/relationships" xmlns:a="http://schemas.openxmlformats.org/drawingml/2006/main" r:embed="R5e1b3c5f3aa54d59"/>
           <a:srcRect xmlns:a="http://schemas.openxmlformats.org/drawingml/2006/main" l="0" t="0" r="0" b="0"/>
           <a:stretch xmlns:a="http://schemas.openxmlformats.org/drawingml/2006/main">
             <a:fillRect l="0" t="0" r="0" b="0"/>
@@ -5116,7 +5116,7 @@
                 <a:ea typeface="Noto Sans CJK SC"/>
                 <a:cs typeface="Noto Sans CJK SC"/>
               </a:rPr>
-              <a:t>重新理解学习、教学与教师的专业判断</a:t>
+              <a:t>AI进入课堂后，教师如何判断学生是否学到了</a:t>
             </a:r>
           </a:p>
         </p:txBody>
@@ -5372,7 +5372,7 @@
           <p:nvPr/>
         </p:nvPicPr>
         <p:blipFill>
-          <a:blip xmlns:r="http://schemas.openxmlformats.org/officeDocument/2006/relationships" xmlns:a="http://schemas.openxmlformats.org/drawingml/2006/main" r:embed="R2d29d5f5dccd4411"/>
+          <a:blip xmlns:r="http://schemas.openxmlformats.org/officeDocument/2006/relationships" xmlns:a="http://schemas.openxmlformats.org/drawingml/2006/main" r:embed="R26ce5cffdbad463a"/>
           <a:srcRect xmlns:a="http://schemas.openxmlformats.org/drawingml/2006/main" l="0" t="0" r="0" b="0"/>
           <a:stretch xmlns:a="http://schemas.openxmlformats.org/drawingml/2006/main">
             <a:fillRect l="0" t="0" r="0" b="0"/>
@@ -5444,7 +5444,7 @@
                 <a:ea typeface="Noto Sans CJK SC"/>
                 <a:cs typeface="Noto Sans CJK SC"/>
               </a:rPr>
-              <a:t>AI也可能打开新的学习路径</a:t>
+              <a:t>有了AI，哪些问题现在可以研究了？</a:t>
             </a:r>
           </a:p>
         </p:txBody>
@@ -5505,7 +5505,7 @@
                 <a:ea typeface="Noto Sans CJK SC"/>
                 <a:cs typeface="Noto Sans CJK SC"/>
               </a:rPr>
-              <a:t>提出更多假设</a:t>
+              <a:t>让几个解释摆在一起</a:t>
             </a:r>
           </a:p>
           <a:p xmlns:a="http://schemas.openxmlformats.org/drawingml/2006/main">
@@ -5532,7 +5532,7 @@
                 <a:ea typeface="Noto Sans CJK SC"/>
                 <a:cs typeface="Noto Sans CJK SC"/>
               </a:rPr>
-              <a:t>比较原来难以获得的解释</a:t>
+              <a:t>找出它们分歧在哪里</a:t>
             </a:r>
           </a:p>
           <a:p xmlns:a="http://schemas.openxmlformats.org/drawingml/2006/main">
@@ -5559,7 +5559,7 @@
                 <a:ea typeface="Noto Sans CJK SC"/>
                 <a:cs typeface="Noto Sans CJK SC"/>
               </a:rPr>
-              <a:t>开展更复杂的探究与表达</a:t>
+              <a:t>设计观察，判断谁更站得住</a:t>
             </a:r>
           </a:p>
         </p:txBody>
@@ -5650,7 +5650,7 @@
                 <a:ea typeface="Noto Sans CJK SC"/>
                 <a:cs typeface="Noto Sans CJK SC"/>
               </a:rPr>
-              <a:t>新的可能，仍需要学生实际参与才能成为学习机会。</a:t>
+              <a:t>备选解释多了，学生是否更会提出和检验问题？</a:t>
             </a:r>
           </a:p>
         </p:txBody>
@@ -5876,7 +5876,7 @@
           <p:nvPr/>
         </p:nvPicPr>
         <p:blipFill>
-          <a:blip xmlns:r="http://schemas.openxmlformats.org/officeDocument/2006/relationships" xmlns:a="http://schemas.openxmlformats.org/drawingml/2006/main" r:embed="Rf5677011befd48b9"/>
+          <a:blip xmlns:r="http://schemas.openxmlformats.org/officeDocument/2006/relationships" xmlns:a="http://schemas.openxmlformats.org/drawingml/2006/main" r:embed="R3a35ac731a2b4c52"/>
           <a:srcRect xmlns:a="http://schemas.openxmlformats.org/drawingml/2006/main" l="0" t="0" r="0" b="0"/>
           <a:stretch xmlns:a="http://schemas.openxmlformats.org/drawingml/2006/main">
             <a:fillRect l="0" t="0" r="0" b="0"/>
@@ -5948,7 +5948,7 @@
                 <a:ea typeface="Noto Sans CJK SC"/>
                 <a:cs typeface="Noto Sans CJK SC"/>
               </a:rPr>
-              <a:t>同一种安排，机会可能分配不均</a:t>
+              <a:t>小组做得好，谁真正参与了？</a:t>
             </a:r>
           </a:p>
         </p:txBody>
@@ -6009,7 +6009,7 @@
                 <a:ea typeface="Noto Sans CJK SC"/>
                 <a:cs typeface="Noto Sans CJK SC"/>
               </a:rPr>
-              <a:t>请同时看见每个学生，而不只看小组作品。</a:t>
+              <a:t>同一份报告背后，组员经历的学习可能很不同。</a:t>
             </a:r>
           </a:p>
         </p:txBody>
@@ -6100,7 +6100,7 @@
                 <a:ea typeface="Noto Sans CJK SC"/>
                 <a:cs typeface="Noto Sans CJK SC"/>
               </a:rPr>
-              <a:t>有人更容易进入</a:t>
+              <a:t>开始说得出</a:t>
             </a:r>
           </a:p>
         </p:txBody>
@@ -6161,7 +6161,7 @@
                 <a:ea typeface="Noto Sans CJK SC"/>
                 <a:cs typeface="Noto Sans CJK SC"/>
               </a:rPr>
-              <a:t>借助语言和结构支持</a:t>
+              <a:t>借助表达支持</a:t>
             </a:r>
           </a:p>
           <a:p xmlns:a="http://schemas.openxmlformats.org/drawingml/2006/main">
@@ -6188,7 +6188,7 @@
                 <a:ea typeface="Noto Sans CJK SC"/>
                 <a:cs typeface="Noto Sans CJK SC"/>
               </a:rPr>
-              <a:t>第一次能够参与讨论</a:t>
+              <a:t>第一次讲清自己的观察</a:t>
             </a:r>
           </a:p>
         </p:txBody>
@@ -6279,7 +6279,7 @@
                 <a:ea typeface="Noto Sans CJK SC"/>
                 <a:cs typeface="Noto Sans CJK SC"/>
               </a:rPr>
-              <a:t>有人失去空间</a:t>
+              <a:t>想法被盖住</a:t>
             </a:r>
           </a:p>
         </p:txBody>
@@ -6340,7 +6340,7 @@
                 <a:ea typeface="Noto Sans CJK SC"/>
                 <a:cs typeface="Noto Sans CJK SC"/>
               </a:rPr>
-              <a:t>AI或同伴过早定下方案</a:t>
+              <a:t>AI或同伴先定了方案</a:t>
             </a:r>
           </a:p>
           <a:p xmlns:a="http://schemas.openxmlformats.org/drawingml/2006/main">
@@ -6367,7 +6367,7 @@
                 <a:ea typeface="Noto Sans CJK SC"/>
                 <a:cs typeface="Noto Sans CJK SC"/>
               </a:rPr>
-              <a:t>自己的问题没有被展开</a:t>
+              <a:t>自己的疑问没被讨论</a:t>
             </a:r>
           </a:p>
         </p:txBody>
@@ -6458,7 +6458,7 @@
                 <a:ea typeface="Noto Sans CJK SC"/>
                 <a:cs typeface="Noto Sans CJK SC"/>
               </a:rPr>
-              <a:t>有人始终在旁边</a:t>
+              <a:t>一直在旁边</a:t>
             </a:r>
           </a:p>
         </p:txBody>
@@ -6519,7 +6519,7 @@
                 <a:ea typeface="Noto Sans CJK SC"/>
                 <a:cs typeface="Noto Sans CJK SC"/>
               </a:rPr>
-              <a:t>小组交出了好作品</a:t>
+              <a:t>参与了搭建与记录</a:t>
             </a:r>
           </a:p>
           <a:p xmlns:a="http://schemas.openxmlformats.org/drawingml/2006/main">
@@ -6546,7 +6546,7 @@
                 <a:ea typeface="Noto Sans CJK SC"/>
                 <a:cs typeface="Noto Sans CJK SC"/>
               </a:rPr>
-              <a:t>个人参与仍然难以判断</a:t>
+              <a:t>却没有解释或决定的机会</a:t>
             </a:r>
           </a:p>
         </p:txBody>
@@ -6637,7 +6637,7 @@
                 <a:ea typeface="Noto Sans CJK SC"/>
                 <a:cs typeface="Noto Sans CJK SC"/>
               </a:rPr>
-              <a:t>谁获得了什么机会？谁还需要另一种支持？</a:t>
+              <a:t>下一次讨论，怎样让这些学生也能提出和检验想法？</a:t>
             </a:r>
           </a:p>
         </p:txBody>
@@ -6863,7 +6863,7 @@
           <p:nvPr/>
         </p:nvPicPr>
         <p:blipFill>
-          <a:blip xmlns:r="http://schemas.openxmlformats.org/officeDocument/2006/relationships" xmlns:a="http://schemas.openxmlformats.org/drawingml/2006/main" r:embed="R5cbbfeb694f648e7"/>
+          <a:blip xmlns:r="http://schemas.openxmlformats.org/officeDocument/2006/relationships" xmlns:a="http://schemas.openxmlformats.org/drawingml/2006/main" r:embed="R98820c0dff7d4e49"/>
           <a:srcRect xmlns:a="http://schemas.openxmlformats.org/drawingml/2006/main" l="0" t="0" r="0" b="0"/>
           <a:stretch xmlns:a="http://schemas.openxmlformats.org/drawingml/2006/main">
             <a:fillRect l="0" t="0" r="0" b="0"/>
@@ -6935,7 +6935,7 @@
                 <a:ea typeface="Noto Sans CJK SC"/>
                 <a:cs typeface="Noto Sans CJK SC"/>
               </a:rPr>
-              <a:t>能力框架，为具体判断提供基础</a:t>
+              <a:t>会用AI之后，还要会作教学取舍</a:t>
             </a:r>
           </a:p>
         </p:txBody>
@@ -7026,7 +7026,7 @@
                 <a:ea typeface="Noto Sans CJK SC"/>
                 <a:cs typeface="Noto Sans CJK SC"/>
               </a:rPr>
-              <a:t>UNESCO教师框架</a:t>
+              <a:t>UNESCO框架</a:t>
             </a:r>
           </a:p>
         </p:txBody>
@@ -7232,7 +7232,7 @@
                 <a:ea typeface="Noto Sans CJK SC"/>
                 <a:cs typeface="Noto Sans CJK SC"/>
               </a:rPr>
-              <a:t>GenAI响应性框架</a:t>
+              <a:t>大学教师GenAI框架</a:t>
             </a:r>
           </a:p>
         </p:txBody>
@@ -7438,7 +7438,7 @@
                 <a:ea typeface="Noto Sans CJK SC"/>
                 <a:cs typeface="Noto Sans CJK SC"/>
               </a:rPr>
-              <a:t>这些能力，怎样进入一次具体教学选择？</a:t>
+              <a:t>为什么在这节课、对这些学生，选择这种用法？</a:t>
             </a:r>
           </a:p>
         </p:txBody>
@@ -7664,7 +7664,7 @@
           <p:nvPr/>
         </p:nvPicPr>
         <p:blipFill>
-          <a:blip xmlns:r="http://schemas.openxmlformats.org/officeDocument/2006/relationships" xmlns:a="http://schemas.openxmlformats.org/drawingml/2006/main" r:embed="Rd9fdfc19ee2c420b"/>
+          <a:blip xmlns:r="http://schemas.openxmlformats.org/officeDocument/2006/relationships" xmlns:a="http://schemas.openxmlformats.org/drawingml/2006/main" r:embed="Rf7da6ae5f5334835"/>
           <a:srcRect xmlns:a="http://schemas.openxmlformats.org/drawingml/2006/main" l="0" t="0" r="0" b="0"/>
           <a:stretch xmlns:a="http://schemas.openxmlformats.org/drawingml/2006/main">
             <a:fillRect l="0" t="0" r="0" b="0"/>
@@ -7736,7 +7736,7 @@
                 <a:ea typeface="Noto Sans CJK SC"/>
                 <a:cs typeface="Noto Sans CJK SC"/>
               </a:rPr>
-              <a:t>课堂里的决定，正在由谁承担？</a:t>
+              <a:t>学生能决定什么？</a:t>
             </a:r>
           </a:p>
         </p:txBody>
@@ -7797,7 +7797,7 @@
                 <a:ea typeface="Noto Sans CJK SC"/>
                 <a:cs typeface="Noto Sans CJK SC"/>
               </a:rPr>
-              <a:t>谁提出值得研究的问题？</a:t>
+              <a:t>问题由谁提出？</a:t>
             </a:r>
           </a:p>
           <a:p xmlns:a="http://schemas.openxmlformats.org/drawingml/2006/main">
@@ -7824,7 +7824,7 @@
                 <a:ea typeface="Noto Sans CJK SC"/>
                 <a:cs typeface="Noto Sans CJK SC"/>
               </a:rPr>
-              <a:t>谁判断证据是否充分？</a:t>
+              <a:t>证据够不够，由谁判断？</a:t>
             </a:r>
           </a:p>
           <a:p xmlns:a="http://schemas.openxmlformats.org/drawingml/2006/main">
@@ -7851,7 +7851,7 @@
                 <a:ea typeface="Noto Sans CJK SC"/>
                 <a:cs typeface="Noto Sans CJK SC"/>
               </a:rPr>
-              <a:t>谁决定下一步与何时结束？</a:t>
+              <a:t>下一步怎么做，由谁决定？</a:t>
             </a:r>
           </a:p>
         </p:txBody>
@@ -7942,7 +7942,7 @@
                 <a:ea typeface="Noto Sans CJK SC"/>
                 <a:cs typeface="Noto Sans CJK SC"/>
               </a:rPr>
-              <a:t>请想一想：学生能改变其中哪些决定？</a:t>
+              <a:t>学生有不同想法时，能改变课堂的走向吗？</a:t>
             </a:r>
           </a:p>
         </p:txBody>
@@ -8168,7 +8168,7 @@
           <p:nvPr/>
         </p:nvPicPr>
         <p:blipFill>
-          <a:blip xmlns:r="http://schemas.openxmlformats.org/officeDocument/2006/relationships" xmlns:a="http://schemas.openxmlformats.org/drawingml/2006/main" r:embed="R884bbbd713c647fc"/>
+          <a:blip xmlns:r="http://schemas.openxmlformats.org/officeDocument/2006/relationships" xmlns:a="http://schemas.openxmlformats.org/drawingml/2006/main" r:embed="R2d3310f573224cbf"/>
           <a:srcRect xmlns:a="http://schemas.openxmlformats.org/drawingml/2006/main" l="0" t="0" r="0" b="0"/>
           <a:stretch xmlns:a="http://schemas.openxmlformats.org/drawingml/2006/main">
             <a:fillRect l="0" t="0" r="0" b="0"/>
@@ -8240,7 +8240,7 @@
                 <a:ea typeface="Noto Sans CJK SC"/>
                 <a:cs typeface="Noto Sans CJK SC"/>
               </a:rPr>
-              <a:t>把人机合作展开成具体的工作</a:t>
+              <a:t>“人机合作”要说清谁做哪一步</a:t>
             </a:r>
           </a:p>
         </p:txBody>
@@ -8301,7 +8301,7 @@
                 <a:ea typeface="Noto Sans CJK SC"/>
                 <a:cs typeface="Noto Sans CJK SC"/>
               </a:rPr>
-              <a:t>讨论示例：同一节课可以有不同承担方式。</a:t>
+              <a:t>以生态瓶探究为例，逐项检查分工。</a:t>
             </a:r>
           </a:p>
         </p:txBody>
@@ -9805,7 +9805,7 @@
           <p:nvPr/>
         </p:nvPicPr>
         <p:blipFill>
-          <a:blip xmlns:r="http://schemas.openxmlformats.org/officeDocument/2006/relationships" xmlns:a="http://schemas.openxmlformats.org/drawingml/2006/main" r:embed="R70cb6648ed81431e"/>
+          <a:blip xmlns:r="http://schemas.openxmlformats.org/officeDocument/2006/relationships" xmlns:a="http://schemas.openxmlformats.org/drawingml/2006/main" r:embed="R08c8f9c99edb4201"/>
           <a:srcRect xmlns:a="http://schemas.openxmlformats.org/drawingml/2006/main" l="0" t="0" r="0" b="0"/>
           <a:stretch xmlns:a="http://schemas.openxmlformats.org/drawingml/2006/main">
             <a:fillRect l="0" t="0" r="0" b="0"/>
@@ -9877,7 +9877,7 @@
                 <a:ea typeface="Noto Sans CJK SC"/>
                 <a:cs typeface="Noto Sans CJK SC"/>
               </a:rPr>
-              <a:t>一句提示词，无法决定整节课</a:t>
+              <a:t>提示词写好了，课堂还没安排好</a:t>
             </a:r>
           </a:p>
         </p:txBody>
@@ -9938,7 +9938,7 @@
                 <a:ea typeface="Noto Sans CJK SC"/>
                 <a:cs typeface="Noto Sans CJK SC"/>
               </a:rPr>
-              <a:t>学生实际遇到的支持，来自多个环节。</a:t>
+              <a:t>学生经历怎样的学习，还取决于流程、界面和课堂互动。</a:t>
             </a:r>
           </a:p>
         </p:txBody>
@@ -10485,7 +10485,7 @@
                 <a:ea typeface="Noto Sans CJK SC"/>
                 <a:cs typeface="Noto Sans CJK SC"/>
               </a:rPr>
-              <a:t>改变一个环节之后，还要查看实际互动是否改变。</a:t>
+              <a:t>学生实际上做了什么，要到课堂里看。</a:t>
             </a:r>
           </a:p>
         </p:txBody>
@@ -10711,7 +10711,7 @@
           <p:nvPr/>
         </p:nvPicPr>
         <p:blipFill>
-          <a:blip xmlns:r="http://schemas.openxmlformats.org/officeDocument/2006/relationships" xmlns:a="http://schemas.openxmlformats.org/drawingml/2006/main" r:embed="R2e3902c301714916"/>
+          <a:blip xmlns:r="http://schemas.openxmlformats.org/officeDocument/2006/relationships" xmlns:a="http://schemas.openxmlformats.org/drawingml/2006/main" r:embed="R902cc54256354139"/>
           <a:srcRect xmlns:a="http://schemas.openxmlformats.org/drawingml/2006/main" l="0" t="0" r="0" b="0"/>
           <a:stretch xmlns:a="http://schemas.openxmlformats.org/drawingml/2006/main">
             <a:fillRect l="0" t="0" r="0" b="0"/>
@@ -10783,7 +10783,7 @@
                 <a:ea typeface="Noto Sans CJK SC"/>
                 <a:cs typeface="Noto Sans CJK SC"/>
               </a:rPr>
-              <a:t>完整示范之后，学生接着做什么？</a:t>
+              <a:t>给出答案之后，还可以怎样教？</a:t>
             </a:r>
           </a:p>
         </p:txBody>
@@ -10844,7 +10844,7 @@
                 <a:ea typeface="Noto Sans CJK SC"/>
                 <a:cs typeface="Noto Sans CJK SC"/>
               </a:rPr>
-              <a:t>AI给出答案，可以成为进一步学习的材料。</a:t>
+              <a:t>完整方案可以用来学设计，关键在后续任务。</a:t>
             </a:r>
           </a:p>
         </p:txBody>
@@ -11472,7 +11472,7 @@
                 <a:ea typeface="Noto Sans CJK SC"/>
                 <a:cs typeface="Noto Sans CJK SC"/>
               </a:rPr>
-              <a:t>教学价值取决于整段活动怎样组织、实际怎样发生。</a:t>
+              <a:t>看过答案后，学生需要解释、比较或重新设计什么？</a:t>
             </a:r>
           </a:p>
         </p:txBody>
@@ -11698,7 +11698,7 @@
           <p:nvPr/>
         </p:nvPicPr>
         <p:blipFill>
-          <a:blip xmlns:r="http://schemas.openxmlformats.org/officeDocument/2006/relationships" xmlns:a="http://schemas.openxmlformats.org/drawingml/2006/main" r:embed="R62590751887e4ec7"/>
+          <a:blip xmlns:r="http://schemas.openxmlformats.org/officeDocument/2006/relationships" xmlns:a="http://schemas.openxmlformats.org/drawingml/2006/main" r:embed="Rc15e29e87b1c476d"/>
           <a:srcRect xmlns:a="http://schemas.openxmlformats.org/drawingml/2006/main" l="0" t="0" r="0" b="0"/>
           <a:stretch xmlns:a="http://schemas.openxmlformats.org/drawingml/2006/main">
             <a:fillRect l="0" t="0" r="0" b="0"/>
@@ -11770,7 +11770,7 @@
                 <a:ea typeface="Noto Sans CJK SC"/>
                 <a:cs typeface="Noto Sans CJK SC"/>
               </a:rPr>
-              <a:t>问得很多，学生可能仍在填空</a:t>
+              <a:t>AI问了十轮，学生可能仍在填空</a:t>
             </a:r>
           </a:p>
         </p:txBody>
@@ -11831,7 +11831,7 @@
                 <a:ea typeface="Noto Sans CJK SC"/>
                 <a:cs typeface="Noto Sans CJK SC"/>
               </a:rPr>
-              <a:t>如果问题、推理顺序和判断标准都由AI预先安排……</a:t>
+              <a:t>问题、步骤、标准都定好了，学生只需补上几个词。</a:t>
             </a:r>
           </a:p>
         </p:txBody>
@@ -11892,7 +11892,7 @@
                 <a:ea typeface="Noto Sans CJK SC"/>
                 <a:cs typeface="Noto Sans CJK SC"/>
               </a:rPr>
-              <a:t>可能出现</a:t>
+              <a:t>表面很热闹</a:t>
             </a:r>
           </a:p>
         </p:txBody>
@@ -11953,7 +11953,7 @@
                 <a:ea typeface="Noto Sans CJK SC"/>
                 <a:cs typeface="Noto Sans CJK SC"/>
               </a:rPr>
-              <a:t>学生回应频繁，却很少选择策略或提出问题</a:t>
+              <a:t>学生一直回答，却没有选择方法或提出新问题</a:t>
             </a:r>
           </a:p>
         </p:txBody>
@@ -12014,7 +12014,7 @@
                 <a:ea typeface="Noto Sans CJK SC"/>
                 <a:cs typeface="Noto Sans CJK SC"/>
               </a:rPr>
-              <a:t>需要检查</a:t>
+              <a:t>追问一处</a:t>
             </a:r>
           </a:p>
         </p:txBody>
@@ -12075,7 +12075,7 @@
                 <a:ea typeface="Noto Sans CJK SC"/>
                 <a:cs typeface="Noto Sans CJK SC"/>
               </a:rPr>
-              <a:t>学生能否解释推理、改变路线、提出新的疑问？</a:t>
+              <a:t>让学生解释整条思路，或换一个条件重新判断</a:t>
             </a:r>
           </a:p>
         </p:txBody>
@@ -12166,7 +12166,7 @@
                 <a:ea typeface="Noto Sans CJK SC"/>
                 <a:cs typeface="Noto Sans CJK SC"/>
               </a:rPr>
-              <a:t>一次回应，究竟承担了多大程度的思考与决定？</a:t>
+              <a:t>对话次数告诉我们说了多少，解释质量才帮助判断理解。</a:t>
             </a:r>
           </a:p>
         </p:txBody>
@@ -12392,7 +12392,7 @@
           <p:nvPr/>
         </p:nvPicPr>
         <p:blipFill>
-          <a:blip xmlns:r="http://schemas.openxmlformats.org/officeDocument/2006/relationships" xmlns:a="http://schemas.openxmlformats.org/drawingml/2006/main" r:embed="Rda26a5a9f3f94d58"/>
+          <a:blip xmlns:r="http://schemas.openxmlformats.org/officeDocument/2006/relationships" xmlns:a="http://schemas.openxmlformats.org/drawingml/2006/main" r:embed="R6ac0d67f9d2840a7"/>
           <a:srcRect xmlns:a="http://schemas.openxmlformats.org/drawingml/2006/main" l="0" t="0" r="0" b="0"/>
           <a:stretch xmlns:a="http://schemas.openxmlformats.org/drawingml/2006/main">
             <a:fillRect l="0" t="0" r="0" b="0"/>
@@ -12464,7 +12464,7 @@
                 <a:ea typeface="Noto Sans CJK SC"/>
                 <a:cs typeface="Noto Sans CJK SC"/>
               </a:rPr>
-              <a:t>同一项工作，可以分阶段承担</a:t>
+              <a:t>支持何时增减，要看学生表现</a:t>
             </a:r>
           </a:p>
         </p:txBody>
@@ -12525,7 +12525,7 @@
                 <a:ea typeface="Noto Sans CJK SC"/>
                 <a:cs typeface="Noto Sans CJK SC"/>
               </a:rPr>
-              <a:t>以实验设计为例：支持方式可以随学生表现调整。</a:t>
+              <a:t>实验设计可以这样安排，也可以根据困难退回一步。</a:t>
             </a:r>
           </a:p>
         </p:txBody>
@@ -13153,7 +13153,7 @@
                 <a:ea typeface="Noto Sans CJK SC"/>
                 <a:cs typeface="Noto Sans CJK SC"/>
               </a:rPr>
-              <a:t>是否改变支持，依据实际表现，而非固定走完三个阶段。</a:t>
+              <a:t>学生还卡在哪里？哪一步已经可以自己承担？</a:t>
             </a:r>
           </a:p>
         </p:txBody>
@@ -13379,7 +13379,7 @@
           <p:nvPr/>
         </p:nvPicPr>
         <p:blipFill>
-          <a:blip xmlns:r="http://schemas.openxmlformats.org/officeDocument/2006/relationships" xmlns:a="http://schemas.openxmlformats.org/drawingml/2006/main" r:embed="R3e03c9e7434c4e04"/>
+          <a:blip xmlns:r="http://schemas.openxmlformats.org/officeDocument/2006/relationships" xmlns:a="http://schemas.openxmlformats.org/drawingml/2006/main" r:embed="R1710ae56a9304bce"/>
           <a:srcRect xmlns:a="http://schemas.openxmlformats.org/drawingml/2006/main" l="0" t="0" r="0" b="0"/>
           <a:stretch xmlns:a="http://schemas.openxmlformats.org/drawingml/2006/main">
             <a:fillRect l="0" t="0" r="0" b="0"/>
@@ -13451,7 +13451,7 @@
                 <a:ea typeface="Noto Sans CJK SC"/>
                 <a:cs typeface="Noto Sans CJK SC"/>
               </a:rPr>
-              <a:t>三条路径，都需要教学依据</a:t>
+              <a:t>先示范还是先尝试？要看教谁、教什么</a:t>
             </a:r>
           </a:p>
         </p:txBody>
@@ -13512,7 +13512,7 @@
                 <a:ea typeface="Noto Sans CJK SC"/>
                 <a:cs typeface="Noto Sans CJK SC"/>
               </a:rPr>
-              <a:t>讨论情境：围绕同一个科学探究问题。</a:t>
+              <a:t>同一个探究问题，可以有不同的教学顺序。</a:t>
             </a:r>
           </a:p>
         </p:txBody>
@@ -14667,7 +14667,7 @@
                 <a:ea typeface="Noto Sans CJK SC"/>
                 <a:cs typeface="Noto Sans CJK SC"/>
               </a:rPr>
-              <a:t>讨论情境 · 第一次看见</a:t>
+              <a:t>假设课堂 · 生态瓶探究</a:t>
             </a:r>
           </a:p>
         </p:txBody>
@@ -14681,7 +14681,7 @@
           <p:nvPr/>
         </p:nvPicPr>
         <p:blipFill>
-          <a:blip xmlns:r="http://schemas.openxmlformats.org/officeDocument/2006/relationships" xmlns:a="http://schemas.openxmlformats.org/drawingml/2006/main" r:embed="R4bfa3e4836c9417c"/>
+          <a:blip xmlns:r="http://schemas.openxmlformats.org/officeDocument/2006/relationships" xmlns:a="http://schemas.openxmlformats.org/drawingml/2006/main" r:embed="Rbc4b30dedeb34799"/>
           <a:srcRect xmlns:a="http://schemas.openxmlformats.org/drawingml/2006/main" l="0" t="0" r="0" b="0"/>
           <a:stretch xmlns:a="http://schemas.openxmlformats.org/drawingml/2006/main">
             <a:fillRect l="0" t="0" r="0" b="0"/>
@@ -14753,7 +14753,7 @@
                 <a:ea typeface="Noto Sans CJK SC"/>
                 <a:cs typeface="Noto Sans CJK SC"/>
               </a:rPr>
-              <a:t>一份完整方案，学生直接采用</a:t>
+              <a:t>方案完成了，学生学到了什么？</a:t>
             </a:r>
           </a:p>
         </p:txBody>
@@ -15361,7 +15361,7 @@
                 <a:ea typeface="Noto Sans CJK SC"/>
                 <a:cs typeface="Noto Sans CJK SC"/>
               </a:rPr>
-              <a:t>第二次判断 · 讨论情境补充</a:t>
+              <a:t>第二次判断 · 假设课堂补充</a:t>
             </a:r>
           </a:p>
         </p:txBody>
@@ -15375,7 +15375,7 @@
           <p:nvPr/>
         </p:nvPicPr>
         <p:blipFill>
-          <a:blip xmlns:r="http://schemas.openxmlformats.org/officeDocument/2006/relationships" xmlns:a="http://schemas.openxmlformats.org/drawingml/2006/main" r:embed="Rff4a8b9cf1ba43ca"/>
+          <a:blip xmlns:r="http://schemas.openxmlformats.org/officeDocument/2006/relationships" xmlns:a="http://schemas.openxmlformats.org/drawingml/2006/main" r:embed="R8d96b8e77aa04e65"/>
           <a:srcRect xmlns:a="http://schemas.openxmlformats.org/drawingml/2006/main" l="0" t="0" r="0" b="0"/>
           <a:stretch xmlns:a="http://schemas.openxmlformats.org/drawingml/2006/main">
             <a:fillRect l="0" t="0" r="0" b="0"/>
@@ -15447,7 +15447,7 @@
                 <a:ea typeface="Noto Sans CJK SC"/>
                 <a:cs typeface="Noto Sans CJK SC"/>
               </a:rPr>
-              <a:t>现在，你会改变刚才的判断吗？</a:t>
+              <a:t>同样采用AI方案，两组学得一样吗？</a:t>
             </a:r>
           </a:p>
         </p:txBody>
@@ -15508,7 +15508,7 @@
                 <a:ea typeface="Noto Sans CJK SC"/>
                 <a:cs typeface="Noto Sans CJK SC"/>
               </a:rPr>
-              <a:t>一组照着完成，解释主要复述。</a:t>
+              <a:t>一组照着做，理由也照着说。</a:t>
             </a:r>
           </a:p>
           <a:p xmlns:a="http://schemas.openxmlformats.org/drawingml/2006/main">
@@ -15535,7 +15535,7 @@
                 <a:ea typeface="Noto Sans CJK SC"/>
                 <a:cs typeface="Noto Sans CJK SC"/>
               </a:rPr>
-              <a:t>另一组发现条件差异，</a:t>
+              <a:t>另一组发现两瓶条件不一致，</a:t>
             </a:r>
           </a:p>
           <a:p xmlns:a="http://schemas.openxmlformats.org/drawingml/2006/main">
@@ -15562,7 +15562,7 @@
                 <a:ea typeface="Noto Sans CJK SC"/>
                 <a:cs typeface="Noto Sans CJK SC"/>
               </a:rPr>
-              <a:t>修改方案并解释依据。</a:t>
+              <a:t>修改方案并说明了原因。</a:t>
             </a:r>
           </a:p>
         </p:txBody>
@@ -15653,7 +15653,7 @@
                 <a:ea typeface="Noto Sans CJK SC"/>
                 <a:cs typeface="Noto Sans CJK SC"/>
               </a:rPr>
-              <a:t>两组都直接采用AI方案。你还需要哪些信息？</a:t>
+              <a:t>新信息改变了什么判断？哪些学生的理解还不清楚？</a:t>
             </a:r>
           </a:p>
         </p:txBody>
@@ -15865,7 +15865,7 @@
                 <a:ea typeface="Noto Sans CJK SC"/>
                 <a:cs typeface="Noto Sans CJK SC"/>
               </a:rPr>
-              <a:t>从选择方式，走向说明理由</a:t>
+              <a:t>教学判断的依据</a:t>
             </a:r>
           </a:p>
         </p:txBody>
@@ -15879,7 +15879,7 @@
           <p:nvPr/>
         </p:nvPicPr>
         <p:blipFill>
-          <a:blip xmlns:r="http://schemas.openxmlformats.org/officeDocument/2006/relationships" xmlns:a="http://schemas.openxmlformats.org/drawingml/2006/main" r:embed="R08dc472935a043f5"/>
+          <a:blip xmlns:r="http://schemas.openxmlformats.org/officeDocument/2006/relationships" xmlns:a="http://schemas.openxmlformats.org/drawingml/2006/main" r:embed="Rbdb42da7f6d04e73"/>
           <a:srcRect xmlns:a="http://schemas.openxmlformats.org/drawingml/2006/main" l="0" t="0" r="0" b="0"/>
           <a:stretch xmlns:a="http://schemas.openxmlformats.org/drawingml/2006/main">
             <a:fillRect l="0" t="0" r="0" b="0"/>
@@ -15951,7 +15951,7 @@
                 <a:ea typeface="Noto Sans CJK SC"/>
                 <a:cs typeface="Noto Sans CJK SC"/>
               </a:rPr>
-              <a:t>一次教学选择，需要哪些依据？</a:t>
+              <a:t>教师的选择，要能说出理由</a:t>
             </a:r>
           </a:p>
         </p:txBody>
@@ -16042,7 +16042,7 @@
                 <a:ea typeface="Noto Sans CJK SC"/>
                 <a:cs typeface="Noto Sans CJK SC"/>
               </a:rPr>
-              <a:t>目标</a:t>
+              <a:t>教什么</a:t>
             </a:r>
           </a:p>
         </p:txBody>
@@ -16103,7 +16103,7 @@
                 <a:ea typeface="Noto Sans CJK SC"/>
                 <a:cs typeface="Noto Sans CJK SC"/>
               </a:rPr>
-              <a:t>希望学生发展什么？</a:t>
+              <a:t>希望学生学会什么？</a:t>
             </a:r>
           </a:p>
           <a:p xmlns:a="http://schemas.openxmlformats.org/drawingml/2006/main">
@@ -16130,7 +16130,7 @@
                 <a:ea typeface="Noto Sans CJK SC"/>
                 <a:cs typeface="Noto Sans CJK SC"/>
               </a:rPr>
-              <a:t>这项工作与目标</a:t>
+              <a:t>哪一步与这个目标</a:t>
             </a:r>
           </a:p>
           <a:p xmlns:a="http://schemas.openxmlformats.org/drawingml/2006/main">
@@ -16157,7 +16157,7 @@
                 <a:ea typeface="Noto Sans CJK SC"/>
                 <a:cs typeface="Noto Sans CJK SC"/>
               </a:rPr>
-              <a:t>有何关系？</a:t>
+              <a:t>直接相关？</a:t>
             </a:r>
           </a:p>
         </p:txBody>
@@ -16248,7 +16248,7 @@
                 <a:ea typeface="Noto Sans CJK SC"/>
                 <a:cs typeface="Noto Sans CJK SC"/>
               </a:rPr>
-              <a:t>起点</a:t>
+              <a:t>教谁</a:t>
             </a:r>
           </a:p>
         </p:txBody>
@@ -16309,7 +16309,7 @@
                 <a:ea typeface="Noto Sans CJK SC"/>
                 <a:cs typeface="Noto Sans CJK SC"/>
               </a:rPr>
-              <a:t>学生已有怎样的经验？</a:t>
+              <a:t>学生已经会什么？</a:t>
             </a:r>
           </a:p>
           <a:p xmlns:a="http://schemas.openxmlformats.org/drawingml/2006/main">
@@ -16336,7 +16336,7 @@
                 <a:ea typeface="Noto Sans CJK SC"/>
                 <a:cs typeface="Noto Sans CJK SC"/>
               </a:rPr>
-              <a:t>哪些困难需要支持？</a:t>
+              <a:t>眼下卡在哪里？</a:t>
             </a:r>
           </a:p>
         </p:txBody>
@@ -16427,7 +16427,7 @@
                 <a:ea typeface="Noto Sans CJK SC"/>
                 <a:cs typeface="Noto Sans CJK SC"/>
               </a:rPr>
-              <a:t>后果</a:t>
+              <a:t>怎么看</a:t>
             </a:r>
           </a:p>
         </p:txBody>
@@ -16488,7 +16488,7 @@
                 <a:ea typeface="Noto Sans CJK SC"/>
                 <a:cs typeface="Noto Sans CJK SC"/>
               </a:rPr>
-              <a:t>预计带来什么活动？</a:t>
+              <a:t>预计学生会怎样做？</a:t>
             </a:r>
           </a:p>
           <a:p xmlns:a="http://schemas.openxmlformats.org/drawingml/2006/main">
@@ -16515,7 +16515,7 @@
                 <a:ea typeface="Noto Sans CJK SC"/>
                 <a:cs typeface="Noto Sans CJK SC"/>
               </a:rPr>
-              <a:t>用什么证据检验？</a:t>
+              <a:t>准备观察哪一个表现？</a:t>
             </a:r>
           </a:p>
         </p:txBody>
@@ -16741,7 +16741,7 @@
           <p:nvPr/>
         </p:nvPicPr>
         <p:blipFill>
-          <a:blip xmlns:r="http://schemas.openxmlformats.org/officeDocument/2006/relationships" xmlns:a="http://schemas.openxmlformats.org/drawingml/2006/main" r:embed="Rdc268b93c07148a7"/>
+          <a:blip xmlns:r="http://schemas.openxmlformats.org/officeDocument/2006/relationships" xmlns:a="http://schemas.openxmlformats.org/drawingml/2006/main" r:embed="R11070fa7eaf246a7"/>
           <a:srcRect xmlns:a="http://schemas.openxmlformats.org/drawingml/2006/main" l="0" t="0" r="0" b="0"/>
           <a:stretch xmlns:a="http://schemas.openxmlformats.org/drawingml/2006/main">
             <a:fillRect l="0" t="0" r="0" b="0"/>
@@ -16813,7 +16813,7 @@
                 <a:ea typeface="Noto Sans CJK SC"/>
                 <a:cs typeface="Noto Sans CJK SC"/>
               </a:rPr>
-              <a:t>看见什么，才会改变安排？</a:t>
+              <a:t>学生会说“控制变量”，却不会检查方案</a:t>
             </a:r>
           </a:p>
         </p:txBody>
@@ -16904,7 +16904,7 @@
                 <a:ea typeface="Noto Sans CJK SC"/>
                 <a:cs typeface="Noto Sans CJK SC"/>
               </a:rPr>
-              <a:t>观察</a:t>
+              <a:t>先看见问题</a:t>
             </a:r>
           </a:p>
         </p:txBody>
@@ -16965,7 +16965,7 @@
                 <a:ea typeface="Noto Sans CJK SC"/>
                 <a:cs typeface="Noto Sans CJK SC"/>
               </a:rPr>
-              <a:t>学生能说出“保持其他条件相同”，</a:t>
+              <a:t>学生说要保持其他条件相同，</a:t>
             </a:r>
           </a:p>
           <a:p xmlns:a="http://schemas.openxmlformats.org/drawingml/2006/main">
@@ -16992,7 +16992,7 @@
                 <a:ea typeface="Noto Sans CJK SC"/>
                 <a:cs typeface="Noto Sans CJK SC"/>
               </a:rPr>
-              <a:t>却未检查两方案的差异。</a:t>
+              <a:t>却漏看了两瓶植物数量不同。</a:t>
             </a:r>
           </a:p>
         </p:txBody>
@@ -17083,7 +17083,7 @@
                 <a:ea typeface="Noto Sans CJK SC"/>
                 <a:cs typeface="Noto Sans CJK SC"/>
               </a:rPr>
-              <a:t>解释</a:t>
+              <a:t>再查明原因</a:t>
             </a:r>
           </a:p>
         </p:txBody>
@@ -17144,7 +17144,7 @@
                 <a:ea typeface="Noto Sans CJK SC"/>
                 <a:cs typeface="Noto Sans CJK SC"/>
               </a:rPr>
-              <a:t>可能尚未理解，也可能缺少表达机会，</a:t>
+              <a:t>是没理解数量差异的影响，</a:t>
             </a:r>
           </a:p>
           <a:p xmlns:a="http://schemas.openxmlformats.org/drawingml/2006/main">
@@ -17171,7 +17171,7 @@
                 <a:ea typeface="Noto Sans CJK SC"/>
                 <a:cs typeface="Noto Sans CJK SC"/>
               </a:rPr>
-              <a:t>或只由一名同伴处理。</a:t>
+              <a:t>还是只有一名组员检查过？</a:t>
             </a:r>
           </a:p>
         </p:txBody>
@@ -17262,7 +17262,7 @@
                 <a:ea typeface="Noto Sans CJK SC"/>
                 <a:cs typeface="Noto Sans CJK SC"/>
               </a:rPr>
-              <a:t>调整</a:t>
+              <a:t>据此介入</a:t>
             </a:r>
           </a:p>
         </p:txBody>
@@ -17323,7 +17323,7 @@
                 <a:ea typeface="Noto Sans CJK SC"/>
                 <a:cs typeface="Noto Sans CJK SC"/>
               </a:rPr>
-              <a:t>先请不同成员解释具体差异，</a:t>
+              <a:t>请不同成员指出差异、解释后果，</a:t>
             </a:r>
           </a:p>
           <a:p xmlns:a="http://schemas.openxmlformats.org/drawingml/2006/main">
@@ -17350,7 +17350,7 @@
                 <a:ea typeface="Noto Sans CJK SC"/>
                 <a:cs typeface="Noto Sans CJK SC"/>
               </a:rPr>
-              <a:t>再决定是否补充示范或调整任务。</a:t>
+              <a:t>再决定补讲什么、让谁继续尝试。</a:t>
             </a:r>
           </a:p>
         </p:txBody>
@@ -17576,7 +17576,7 @@
           <p:nvPr/>
         </p:nvPicPr>
         <p:blipFill>
-          <a:blip xmlns:r="http://schemas.openxmlformats.org/officeDocument/2006/relationships" xmlns:a="http://schemas.openxmlformats.org/drawingml/2006/main" r:embed="R1076bf1937ed45e7"/>
+          <a:blip xmlns:r="http://schemas.openxmlformats.org/officeDocument/2006/relationships" xmlns:a="http://schemas.openxmlformats.org/drawingml/2006/main" r:embed="Rd8122a79a67a4493"/>
           <a:srcRect xmlns:a="http://schemas.openxmlformats.org/drawingml/2006/main" l="0" t="0" r="0" b="0"/>
           <a:stretch xmlns:a="http://schemas.openxmlformats.org/drawingml/2006/main">
             <a:fillRect l="0" t="0" r="0" b="0"/>
@@ -17648,7 +17648,7 @@
                 <a:ea typeface="Noto Sans CJK SC"/>
                 <a:cs typeface="Noto Sans CJK SC"/>
               </a:rPr>
-              <a:t>句子完整了，理由形成了吗？</a:t>
+              <a:t>句子写完整了，理由可能还没讲清</a:t>
             </a:r>
           </a:p>
         </p:txBody>
@@ -17800,7 +17800,7 @@
                 <a:ea typeface="Noto Sans CJK SC"/>
                 <a:cs typeface="Noto Sans CJK SC"/>
               </a:rPr>
-              <a:t>可能打开表达</a:t>
+              <a:t>确实帮上了忙</a:t>
             </a:r>
           </a:p>
         </p:txBody>
@@ -17861,7 +17861,7 @@
                 <a:ea typeface="Noto Sans CJK SC"/>
                 <a:cs typeface="Noto Sans CJK SC"/>
               </a:rPr>
-              <a:t>学生借助句式，把自己的观</a:t>
+              <a:t>学生借句式说明，哪一次观</a:t>
             </a:r>
           </a:p>
           <a:p xmlns:a="http://schemas.openxmlformats.org/drawingml/2006/main">
@@ -17888,7 +17888,7 @@
                 <a:ea typeface="Noto Sans CJK SC"/>
                 <a:cs typeface="Noto Sans CJK SC"/>
               </a:rPr>
-              <a:t>察组织成理由。</a:t>
+              <a:t>察支持了自己的判断。</a:t>
             </a:r>
           </a:p>
         </p:txBody>
@@ -17979,7 +17979,7 @@
                 <a:ea typeface="Noto Sans CJK SC"/>
                 <a:cs typeface="Noto Sans CJK SC"/>
               </a:rPr>
-              <a:t>也可能只填满句子</a:t>
+              <a:t>只完成了填空</a:t>
             </a:r>
           </a:p>
         </p:txBody>
@@ -18040,7 +18040,7 @@
                 <a:ea typeface="Noto Sans CJK SC"/>
                 <a:cs typeface="Noto Sans CJK SC"/>
               </a:rPr>
-              <a:t>文字更完整，观察与结论之</a:t>
+              <a:t>“因为”后面有文字，却没</a:t>
             </a:r>
           </a:p>
           <a:p xmlns:a="http://schemas.openxmlformats.org/drawingml/2006/main">
@@ -18067,7 +18067,7 @@
                 <a:ea typeface="Noto Sans CJK SC"/>
                 <a:cs typeface="Noto Sans CJK SC"/>
               </a:rPr>
-              <a:t>间的关系仍未解释。</a:t>
+              <a:t>有解释观察与结论的关系。</a:t>
             </a:r>
           </a:p>
         </p:txBody>
@@ -18158,7 +18158,7 @@
                 <a:ea typeface="Noto Sans CJK SC"/>
                 <a:cs typeface="Noto Sans CJK SC"/>
               </a:rPr>
-              <a:t>继续追问</a:t>
+              <a:t>换材料再问</a:t>
             </a:r>
           </a:p>
         </p:txBody>
@@ -18219,7 +18219,7 @@
                 <a:ea typeface="Noto Sans CJK SC"/>
                 <a:cs typeface="Noto Sans CJK SC"/>
               </a:rPr>
-              <a:t>换一条观察，能否说明</a:t>
+              <a:t>给一条不同的观察：</a:t>
             </a:r>
           </a:p>
           <a:p xmlns:a="http://schemas.openxmlformats.org/drawingml/2006/main">
@@ -18246,7 +18246,7 @@
                 <a:ea typeface="Noto Sans CJK SC"/>
                 <a:cs typeface="Noto Sans CJK SC"/>
               </a:rPr>
-              <a:t>它支持什么、</a:t>
+              <a:t>原来的结论</a:t>
             </a:r>
           </a:p>
           <a:p xmlns:a="http://schemas.openxmlformats.org/drawingml/2006/main">
@@ -18273,7 +18273,7 @@
                 <a:ea typeface="Noto Sans CJK SC"/>
                 <a:cs typeface="Noto Sans CJK SC"/>
               </a:rPr>
-              <a:t>不能支持什么？</a:t>
+              <a:t>还站得住吗？</a:t>
             </a:r>
           </a:p>
         </p:txBody>
@@ -18499,7 +18499,7 @@
           <p:nvPr/>
         </p:nvPicPr>
         <p:blipFill>
-          <a:blip xmlns:r="http://schemas.openxmlformats.org/officeDocument/2006/relationships" xmlns:a="http://schemas.openxmlformats.org/drawingml/2006/main" r:embed="R4a5ae649fe534ff4"/>
+          <a:blip xmlns:r="http://schemas.openxmlformats.org/officeDocument/2006/relationships" xmlns:a="http://schemas.openxmlformats.org/drawingml/2006/main" r:embed="R3b23fa51e5bc41ef"/>
           <a:srcRect xmlns:a="http://schemas.openxmlformats.org/drawingml/2006/main" l="0" t="0" r="0" b="0"/>
           <a:stretch xmlns:a="http://schemas.openxmlformats.org/drawingml/2006/main">
             <a:fillRect l="0" t="0" r="0" b="0"/>
@@ -18571,7 +18571,7 @@
                 <a:ea typeface="Noto Sans CJK SC"/>
                 <a:cs typeface="Noto Sans CJK SC"/>
               </a:rPr>
-              <a:t>不同材料，回答不同问题</a:t>
+              <a:t>想判断什么，就补看哪一种材料</a:t>
             </a:r>
           </a:p>
         </p:txBody>
@@ -18845,7 +18845,7 @@
                 <a:ea typeface="Noto Sans CJK SC"/>
                 <a:cs typeface="Noto Sans CJK SC"/>
               </a:rPr>
-              <a:t>任务单与AI配置</a:t>
+              <a:t>任务单与配置</a:t>
             </a:r>
           </a:p>
         </p:txBody>
@@ -19058,7 +19058,7 @@
                 <a:ea typeface="Noto Sans CJK SC"/>
                 <a:cs typeface="Noto Sans CJK SC"/>
               </a:rPr>
-              <a:t>课堂互动与AI记录</a:t>
+              <a:t>互动与AI日志</a:t>
             </a:r>
           </a:p>
         </p:txBody>
@@ -19271,7 +19271,7 @@
                 <a:ea typeface="Noto Sans CJK SC"/>
                 <a:cs typeface="Noto Sans CJK SC"/>
               </a:rPr>
-              <a:t>方案与作品版本</a:t>
+              <a:t>作品版本</a:t>
             </a:r>
           </a:p>
         </p:txBody>
@@ -19484,7 +19484,7 @@
                 <a:ea typeface="Noto Sans CJK SC"/>
                 <a:cs typeface="Noto Sans CJK SC"/>
               </a:rPr>
-              <a:t>后续任务与解释</a:t>
+              <a:t>后续任务</a:t>
             </a:r>
           </a:p>
         </p:txBody>
@@ -19848,7 +19848,7 @@
                 <a:ea typeface="Noto Sans CJK SC"/>
                 <a:cs typeface="Noto Sans CJK SC"/>
               </a:rPr>
-              <a:t>讨论示例 · 积累探索经验</a:t>
+              <a:t>假设课堂 · 课后回看</a:t>
             </a:r>
           </a:p>
         </p:txBody>
@@ -19862,7 +19862,7 @@
           <p:nvPr/>
         </p:nvPicPr>
         <p:blipFill>
-          <a:blip xmlns:r="http://schemas.openxmlformats.org/officeDocument/2006/relationships" xmlns:a="http://schemas.openxmlformats.org/drawingml/2006/main" r:embed="Rf381ddeb138f4234"/>
+          <a:blip xmlns:r="http://schemas.openxmlformats.org/officeDocument/2006/relationships" xmlns:a="http://schemas.openxmlformats.org/drawingml/2006/main" r:embed="R69e6e474a1694f78"/>
           <a:srcRect xmlns:a="http://schemas.openxmlformats.org/drawingml/2006/main" l="0" t="0" r="0" b="0"/>
           <a:stretch xmlns:a="http://schemas.openxmlformats.org/drawingml/2006/main">
             <a:fillRect l="0" t="0" r="0" b="0"/>
@@ -19934,7 +19934,7 @@
                 <a:ea typeface="Noto Sans CJK SC"/>
                 <a:cs typeface="Noto Sans CJK SC"/>
               </a:rPr>
-              <a:t>试过之后，问题也会改变</a:t>
+              <a:t>提示改好了，课堂为什么没变？</a:t>
             </a:r>
           </a:p>
         </p:txBody>
@@ -20025,7 +20025,7 @@
                 <a:ea typeface="Noto Sans CJK SC"/>
                 <a:cs typeface="Noto Sans CJK SC"/>
               </a:rPr>
-              <a:t>原先的想法</a:t>
+              <a:t>原先以为</a:t>
             </a:r>
           </a:p>
         </p:txBody>
@@ -20086,7 +20086,7 @@
                 <a:ea typeface="Noto Sans CJK SC"/>
                 <a:cs typeface="Noto Sans CJK SC"/>
               </a:rPr>
-              <a:t>只要提供更好的提示，学生就会解释方案。</a:t>
+              <a:t>让AI多追问几句，学生就会解释方案。</a:t>
             </a:r>
           </a:p>
         </p:txBody>
@@ -20177,7 +20177,7 @@
                 <a:ea typeface="Noto Sans CJK SC"/>
                 <a:cs typeface="Noto Sans CJK SC"/>
               </a:rPr>
-              <a:t>遇到的疑问</a:t>
+              <a:t>回看才发现</a:t>
             </a:r>
           </a:p>
         </p:txBody>
@@ -20238,7 +20238,7 @@
                 <a:ea typeface="Noto Sans CJK SC"/>
                 <a:cs typeface="Noto Sans CJK SC"/>
               </a:rPr>
-              <a:t>提示出现了，学生有没有机会回应？回应是否进入小组决定？</a:t>
+              <a:t>学生没有停下来讨论，回答也没影响小组的决定。</a:t>
             </a:r>
           </a:p>
         </p:txBody>
@@ -20329,7 +20329,7 @@
                 <a:ea typeface="Noto Sans CJK SC"/>
                 <a:cs typeface="Noto Sans CJK SC"/>
               </a:rPr>
-              <a:t>下一次尝试</a:t>
+              <a:t>下次这样改</a:t>
             </a:r>
           </a:p>
         </p:txBody>
@@ -20390,7 +20390,7 @@
                 <a:ea typeface="Noto Sans CJK SC"/>
                 <a:cs typeface="Noto Sans CJK SC"/>
               </a:rPr>
-              <a:t>同时调整互动安排与观察方式，记录预期、实际和意外。</a:t>
+              <a:t>留出比较和回应的时间，追踪一条理由是否改变了方案。</a:t>
             </a:r>
           </a:p>
         </p:txBody>
@@ -20616,7 +20616,7 @@
           <p:nvPr/>
         </p:nvPicPr>
         <p:blipFill>
-          <a:blip xmlns:r="http://schemas.openxmlformats.org/officeDocument/2006/relationships" xmlns:a="http://schemas.openxmlformats.org/drawingml/2006/main" r:embed="R09d193b8120b4ce6"/>
+          <a:blip xmlns:r="http://schemas.openxmlformats.org/officeDocument/2006/relationships" xmlns:a="http://schemas.openxmlformats.org/drawingml/2006/main" r:embed="Rad682de3eb374d4d"/>
           <a:srcRect xmlns:a="http://schemas.openxmlformats.org/drawingml/2006/main" l="0" t="0" r="0" b="0"/>
           <a:stretch xmlns:a="http://schemas.openxmlformats.org/drawingml/2006/main">
             <a:fillRect l="0" t="0" r="0" b="0"/>
@@ -20688,7 +20688,7 @@
                 <a:ea typeface="Noto Sans CJK SC"/>
                 <a:cs typeface="Noto Sans CJK SC"/>
               </a:rPr>
-              <a:t>AI备课，也在改变教师学习</a:t>
+              <a:t>教案写得更快，教师想得更深了吗？</a:t>
             </a:r>
           </a:p>
         </p:txBody>
@@ -20749,7 +20749,7 @@
                 <a:ea typeface="Noto Sans CJK SC"/>
                 <a:cs typeface="Noto Sans CJK SC"/>
               </a:rPr>
-              <a:t>一份教案完成之后，我们对这节课多理解了什么？</a:t>
+              <a:t>用AI备完课，能否更清楚地解释自己的教学选择？</a:t>
             </a:r>
           </a:p>
         </p:txBody>
@@ -20840,7 +20840,7 @@
                 <a:ea typeface="Noto Sans CJK SC"/>
                 <a:cs typeface="Noto Sans CJK SC"/>
               </a:rPr>
-              <a:t>可能扩展</a:t>
+              <a:t>值得用AI做</a:t>
             </a:r>
           </a:p>
         </p:txBody>
@@ -20901,7 +20901,7 @@
                 <a:ea typeface="Noto Sans CJK SC"/>
                 <a:cs typeface="Noto Sans CJK SC"/>
               </a:rPr>
-              <a:t>比较不同教法</a:t>
+              <a:t>比较几种教法</a:t>
             </a:r>
           </a:p>
           <a:p xmlns:a="http://schemas.openxmlformats.org/drawingml/2006/main">
@@ -20928,7 +20928,7 @@
                 <a:ea typeface="Noto Sans CJK SC"/>
                 <a:cs typeface="Noto Sans CJK SC"/>
               </a:rPr>
-              <a:t>预想学生的解释</a:t>
+              <a:t>预想学生可能的解释</a:t>
             </a:r>
           </a:p>
           <a:p xmlns:a="http://schemas.openxmlformats.org/drawingml/2006/main">
@@ -20955,7 +20955,7 @@
                 <a:ea typeface="Noto Sans CJK SC"/>
                 <a:cs typeface="Noto Sans CJK SC"/>
               </a:rPr>
-              <a:t>发现遗漏的任务条件</a:t>
+              <a:t>查找任务遗漏的条件</a:t>
             </a:r>
           </a:p>
         </p:txBody>
@@ -21046,7 +21046,7 @@
                 <a:ea typeface="Noto Sans CJK SC"/>
                 <a:cs typeface="Noto Sans CJK SC"/>
               </a:rPr>
-              <a:t>可能遗漏</a:t>
+              <a:t>需要回去看</a:t>
             </a:r>
           </a:p>
         </p:txBody>
@@ -21107,7 +21107,7 @@
                 <a:ea typeface="Noto Sans CJK SC"/>
                 <a:cs typeface="Noto Sans CJK SC"/>
               </a:rPr>
-              <a:t>只接触整理后的摘要</a:t>
+              <a:t>学生原来的话</a:t>
             </a:r>
           </a:p>
           <a:p xmlns:a="http://schemas.openxmlformats.org/drawingml/2006/main">
@@ -21134,7 +21134,7 @@
                 <a:ea typeface="Noto Sans CJK SC"/>
                 <a:cs typeface="Noto Sans CJK SC"/>
               </a:rPr>
-              <a:t>逐渐远离学生原始表达</a:t>
+              <a:t>实际写过的作品</a:t>
             </a:r>
           </a:p>
           <a:p xmlns:a="http://schemas.openxmlformats.org/drawingml/2006/main">
@@ -21161,7 +21161,7 @@
                 <a:ea typeface="Noto Sans CJK SC"/>
                 <a:cs typeface="Noto Sans CJK SC"/>
               </a:rPr>
-              <a:t>与具体困难</a:t>
+              <a:t>课堂里具体卡住的地方</a:t>
             </a:r>
           </a:p>
         </p:txBody>
@@ -21252,7 +21252,7 @@
                 <a:ea typeface="Noto Sans CJK SC"/>
                 <a:cs typeface="Noto Sans CJK SC"/>
               </a:rPr>
-              <a:t>留下判断</a:t>
+              <a:t>留下一个理由</a:t>
             </a:r>
           </a:p>
         </p:txBody>
@@ -21313,7 +21313,7 @@
                 <a:ea typeface="Noto Sans CJK SC"/>
                 <a:cs typeface="Noto Sans CJK SC"/>
               </a:rPr>
-              <a:t>为什么采纳</a:t>
+              <a:t>这条建议为何采纳？</a:t>
             </a:r>
           </a:p>
           <a:p xmlns:a="http://schemas.openxmlformats.org/drawingml/2006/main">
@@ -21340,7 +21340,7 @@
                 <a:ea typeface="Noto Sans CJK SC"/>
                 <a:cs typeface="Noto Sans CJK SC"/>
               </a:rPr>
-              <a:t>怎样修改</a:t>
+              <a:t>针对哪个困难？</a:t>
             </a:r>
           </a:p>
           <a:p xmlns:a="http://schemas.openxmlformats.org/drawingml/2006/main">
@@ -21367,7 +21367,7 @@
                 <a:ea typeface="Noto Sans CJK SC"/>
                 <a:cs typeface="Noto Sans CJK SC"/>
               </a:rPr>
-              <a:t>课堂中需要验证什么</a:t>
+              <a:t>上课时怎样检查？</a:t>
             </a:r>
           </a:p>
         </p:txBody>
@@ -21593,7 +21593,7 @@
           <p:nvPr/>
         </p:nvPicPr>
         <p:blipFill>
-          <a:blip xmlns:r="http://schemas.openxmlformats.org/officeDocument/2006/relationships" xmlns:a="http://schemas.openxmlformats.org/drawingml/2006/main" r:embed="R615281ca422246ee"/>
+          <a:blip xmlns:r="http://schemas.openxmlformats.org/officeDocument/2006/relationships" xmlns:a="http://schemas.openxmlformats.org/drawingml/2006/main" r:embed="R33eba2adb5444282"/>
           <a:srcRect xmlns:a="http://schemas.openxmlformats.org/drawingml/2006/main" l="0" t="0" r="0" b="0"/>
           <a:stretch xmlns:a="http://schemas.openxmlformats.org/drawingml/2006/main">
             <a:fillRect l="0" t="0" r="0" b="0"/>
@@ -21665,7 +21665,7 @@
                 <a:ea typeface="Noto Sans CJK SC"/>
                 <a:cs typeface="Noto Sans CJK SC"/>
               </a:rPr>
-              <a:t>哪些困难值得保留？</a:t>
+              <a:t>哪一种困难，值得学生自己经历？</a:t>
             </a:r>
           </a:p>
         </p:txBody>
@@ -21726,7 +21726,7 @@
                 <a:ea typeface="Noto Sans CJK SC"/>
                 <a:cs typeface="Noto Sans CJK SC"/>
               </a:rPr>
-              <a:t>可以减轻</a:t>
+              <a:t>减轻负担</a:t>
             </a:r>
           </a:p>
         </p:txBody>
@@ -21787,7 +21787,7 @@
                 <a:ea typeface="Noto Sans CJK SC"/>
                 <a:cs typeface="Noto Sans CJK SC"/>
               </a:rPr>
-              <a:t>阻碍学生进入任务、却与本次目标关系较小的负担。</a:t>
+              <a:t>目标是比较证据时，可以借AI整理表格格式。</a:t>
             </a:r>
           </a:p>
         </p:txBody>
@@ -21848,7 +21848,7 @@
                 <a:ea typeface="Noto Sans CJK SC"/>
                 <a:cs typeface="Noto Sans CJK SC"/>
               </a:rPr>
-              <a:t>需要设计</a:t>
+              <a:t>保留思考</a:t>
             </a:r>
           </a:p>
         </p:txBody>
@@ -21909,7 +21909,7 @@
                 <a:ea typeface="Noto Sans CJK SC"/>
                 <a:cs typeface="Noto Sans CJK SC"/>
               </a:rPr>
-              <a:t>有助于形成理解的比较、解释、选择与验证。</a:t>
+              <a:t>哪些观察支持结论，需要学生解释并接受追问。</a:t>
             </a:r>
           </a:p>
         </p:txBody>
@@ -21970,7 +21970,7 @@
                 <a:ea typeface="Noto Sans CJK SC"/>
                 <a:cs typeface="Noto Sans CJK SC"/>
               </a:rPr>
-              <a:t>随人而变</a:t>
+              <a:t>安排帮助</a:t>
             </a:r>
           </a:p>
         </p:txBody>
@@ -22031,7 +22031,7 @@
                 <a:ea typeface="Noto Sans CJK SC"/>
                 <a:cs typeface="Noto Sans CJK SC"/>
               </a:rPr>
-              <a:t>同一困难，可能需要示范、共同完成或更独立的尝试。</a:t>
+              <a:t>暂时做不到，可以先看示范，再试着处理一处差异。</a:t>
             </a:r>
           </a:p>
         </p:txBody>
@@ -22122,7 +22122,7 @@
                 <a:ea typeface="Noto Sans CJK SC"/>
                 <a:cs typeface="Noto Sans CJK SC"/>
               </a:rPr>
-              <a:t>学生正在克服的困难，与这节课希望发展的能力有什么关系？</a:t>
+              <a:t>困难要与学习目标有关，也要让学生有条件克服。</a:t>
             </a:r>
           </a:p>
         </p:txBody>
@@ -22348,7 +22348,7 @@
           <p:nvPr/>
         </p:nvPicPr>
         <p:blipFill>
-          <a:blip xmlns:r="http://schemas.openxmlformats.org/officeDocument/2006/relationships" xmlns:a="http://schemas.openxmlformats.org/drawingml/2006/main" r:embed="R17dcb1aa7103471d"/>
+          <a:blip xmlns:r="http://schemas.openxmlformats.org/officeDocument/2006/relationships" xmlns:a="http://schemas.openxmlformats.org/drawingml/2006/main" r:embed="R562cd7e23e584ea4"/>
           <a:srcRect xmlns:a="http://schemas.openxmlformats.org/drawingml/2006/main" l="0" t="0" r="0" b="0"/>
           <a:stretch xmlns:a="http://schemas.openxmlformats.org/drawingml/2006/main">
             <a:fillRect l="0" t="0" r="0" b="0"/>
@@ -22420,7 +22420,7 @@
                 <a:ea typeface="Noto Sans CJK SC"/>
                 <a:cs typeface="Noto Sans CJK SC"/>
               </a:rPr>
-              <a:t>练习表现与后续学习要分别看</a:t>
+              <a:t>练习做得更好，测验未必更好</a:t>
             </a:r>
           </a:p>
         </p:txBody>
@@ -22481,7 +22481,7 @@
                 <a:ea typeface="Noto Sans CJK SC"/>
                 <a:cs typeface="Noto Sans CJK SC"/>
               </a:rPr>
-              <a:t>一项高中数学实验：练习收益与随后测验结果并不相同。</a:t>
+              <a:t>高中数学实验中，两种AI设计带来了不同后果。</a:t>
             </a:r>
           </a:p>
         </p:txBody>
@@ -22572,7 +22572,7 @@
                 <a:ea typeface="Noto Sans CJK SC"/>
                 <a:cs typeface="Noto Sans CJK SC"/>
               </a:rPr>
-              <a:t>有AI练习</a:t>
+              <a:t>有AI练习时</a:t>
             </a:r>
           </a:p>
         </p:txBody>
@@ -22660,7 +22660,7 @@
                 <a:ea typeface="Noto Sans CJK SC"/>
                 <a:cs typeface="Noto Sans CJK SC"/>
               </a:rPr>
-              <a:t>都提高了练习表现</a:t>
+              <a:t>都提高了练习成绩</a:t>
             </a:r>
           </a:p>
         </p:txBody>
@@ -22751,7 +22751,7 @@
                 <a:ea typeface="Noto Sans CJK SC"/>
                 <a:cs typeface="Noto Sans CJK SC"/>
               </a:rPr>
-              <a:t>随后无AI测验</a:t>
+              <a:t>撤去AI测验时</a:t>
             </a:r>
           </a:p>
         </p:txBody>
@@ -22812,7 +22812,7 @@
                 <a:ea typeface="Noto Sans CJK SC"/>
                 <a:cs typeface="Noto Sans CJK SC"/>
               </a:rPr>
-              <a:t>普通聊天界面组更低</a:t>
+              <a:t>普通聊天组低于对照组</a:t>
             </a:r>
           </a:p>
           <a:p xmlns:a="http://schemas.openxmlformats.org/drawingml/2006/main">
@@ -22839,7 +22839,7 @@
                 <a:ea typeface="Noto Sans CJK SC"/>
                 <a:cs typeface="Noto Sans CJK SC"/>
               </a:rPr>
-              <a:t>（相比无AI对照组）</a:t>
+              <a:t>加入教学保护后</a:t>
             </a:r>
           </a:p>
           <a:p xmlns:a="http://schemas.openxmlformats.org/drawingml/2006/main">
@@ -22866,7 +22866,7 @@
                 <a:ea typeface="Noto Sans CJK SC"/>
                 <a:cs typeface="Noto Sans CJK SC"/>
               </a:rPr>
-              <a:t>教学保护减轻负面影响</a:t>
+              <a:t>这一负面影响减轻</a:t>
             </a:r>
           </a:p>
         </p:txBody>
@@ -22957,7 +22957,7 @@
                 <a:ea typeface="Noto Sans CJK SC"/>
                 <a:cs typeface="Noto Sans CJK SC"/>
               </a:rPr>
-              <a:t>结论的范围</a:t>
+              <a:t>能说明什么</a:t>
             </a:r>
           </a:p>
         </p:txBody>
@@ -23018,7 +23018,7 @@
                 <a:ea typeface="Noto Sans CJK SC"/>
                 <a:cs typeface="Noto Sans CJK SC"/>
               </a:rPr>
-              <a:t>特定高中数学、短期研究</a:t>
+              <a:t>支持方式会影响结果</a:t>
             </a:r>
           </a:p>
           <a:p xmlns:a="http://schemas.openxmlformats.org/drawingml/2006/main">
@@ -23045,7 +23045,34 @@
                 <a:ea typeface="Noto Sans CJK SC"/>
                 <a:cs typeface="Noto Sans CJK SC"/>
               </a:rPr>
-              <a:t>尚不能据此推断长期发展</a:t>
+              <a:t>短期测验尚不能回答</a:t>
+            </a:r>
+          </a:p>
+          <a:p xmlns:a="http://schemas.openxmlformats.org/drawingml/2006/main">
+            <a:pPr algn="l">
+              <a:lnSpc>
+                <a:spcPct val="135000"/>
+              </a:lnSpc>
+              <a:buNone/>
+              <a:defRPr sz="2100" b="0">
+                <a:solidFill>
+                  <a:srgbClr val="111820"/>
+                </a:solidFill>
+                <a:latin typeface="Noto Sans CJK SC"/>
+                <a:ea typeface="Noto Sans CJK SC"/>
+                <a:cs typeface="Noto Sans CJK SC"/>
+              </a:defRPr>
+            </a:pPr>
+            <a:r>
+              <a:rPr sz="2100" b="0">
+                <a:solidFill>
+                  <a:srgbClr val="111820"/>
+                </a:solidFill>
+                <a:latin typeface="Noto Sans CJK SC"/>
+                <a:ea typeface="Noto Sans CJK SC"/>
+                <a:cs typeface="Noto Sans CJK SC"/>
+              </a:rPr>
+              <a:t>长期学得怎样</a:t>
             </a:r>
           </a:p>
         </p:txBody>
@@ -23271,7 +23298,7 @@
           <p:nvPr/>
         </p:nvPicPr>
         <p:blipFill>
-          <a:blip xmlns:r="http://schemas.openxmlformats.org/officeDocument/2006/relationships" xmlns:a="http://schemas.openxmlformats.org/drawingml/2006/main" r:embed="Rc64d419209664d66"/>
+          <a:blip xmlns:r="http://schemas.openxmlformats.org/officeDocument/2006/relationships" xmlns:a="http://schemas.openxmlformats.org/drawingml/2006/main" r:embed="Re7e2b608709542f7"/>
           <a:srcRect xmlns:a="http://schemas.openxmlformats.org/drawingml/2006/main" l="0" t="0" r="0" b="0"/>
           <a:stretch xmlns:a="http://schemas.openxmlformats.org/drawingml/2006/main">
             <a:fillRect l="0" t="0" r="0" b="0"/>
@@ -23343,7 +23370,7 @@
                 <a:ea typeface="Noto Sans CJK SC"/>
                 <a:cs typeface="Noto Sans CJK SC"/>
               </a:rPr>
-              <a:t>发展可以沿着不同路径发生</a:t>
+              <a:t>独立理解与借AI合作，都要有证据</a:t>
             </a:r>
           </a:p>
         </p:txBody>
@@ -23404,7 +23431,7 @@
                 <a:ea typeface="Noto Sans CJK SC"/>
                 <a:cs typeface="Noto Sans CJK SC"/>
               </a:rPr>
-              <a:t>两类证据分别回答问题；选择怎样评价，需要回到教育目标。</a:t>
+              <a:t>评价个人掌握和合作能力，要安排不同的观察。</a:t>
             </a:r>
           </a:p>
         </p:txBody>
@@ -23495,7 +23522,7 @@
                 <a:ea typeface="Noto Sans CJK SC"/>
                 <a:cs typeface="Noto Sans CJK SC"/>
               </a:rPr>
-              <a:t>更能独立运用</a:t>
+              <a:t>个人理解</a:t>
             </a:r>
           </a:p>
         </p:txBody>
@@ -23556,7 +23583,7 @@
                 <a:ea typeface="Noto Sans CJK SC"/>
                 <a:cs typeface="Noto Sans CJK SC"/>
               </a:rPr>
-              <a:t>支持减少或任务变化后，仍能解释、选择方</a:t>
+              <a:t>换条件、减提示后，</a:t>
             </a:r>
           </a:p>
           <a:p xmlns:a="http://schemas.openxmlformats.org/drawingml/2006/main">
@@ -23583,7 +23610,34 @@
                 <a:ea typeface="Noto Sans CJK SC"/>
                 <a:cs typeface="Noto Sans CJK SC"/>
               </a:rPr>
-              <a:t>法并调整方案。</a:t>
+              <a:t>能解释理由，</a:t>
+            </a:r>
+          </a:p>
+          <a:p xmlns:a="http://schemas.openxmlformats.org/drawingml/2006/main">
+            <a:pPr algn="l">
+              <a:lnSpc>
+                <a:spcPct val="135000"/>
+              </a:lnSpc>
+              <a:buNone/>
+              <a:defRPr sz="2100" b="0">
+                <a:solidFill>
+                  <a:srgbClr val="111820"/>
+                </a:solidFill>
+                <a:latin typeface="Noto Sans CJK SC"/>
+                <a:ea typeface="Noto Sans CJK SC"/>
+                <a:cs typeface="Noto Sans CJK SC"/>
+              </a:defRPr>
+            </a:pPr>
+            <a:r>
+              <a:rPr sz="2100" b="0">
+                <a:solidFill>
+                  <a:srgbClr val="111820"/>
+                </a:solidFill>
+                <a:latin typeface="Noto Sans CJK SC"/>
+                <a:ea typeface="Noto Sans CJK SC"/>
+                <a:cs typeface="Noto Sans CJK SC"/>
+              </a:rPr>
+              <a:t>也能修改方案。</a:t>
             </a:r>
           </a:p>
         </p:txBody>
@@ -23674,7 +23728,7 @@
                 <a:ea typeface="Noto Sans CJK SC"/>
                 <a:cs typeface="Noto Sans CJK SC"/>
               </a:rPr>
-              <a:t>更能借助AI合作</a:t>
+              <a:t>借AI合作</a:t>
             </a:r>
           </a:p>
         </p:txBody>
@@ -23735,7 +23789,7 @@
                 <a:ea typeface="Noto Sans CJK SC"/>
                 <a:cs typeface="Noto Sans CJK SC"/>
               </a:rPr>
-              <a:t>能够提出值得探究的问题，组织人与AI的贡</a:t>
+              <a:t>能提出问题、检查贡献，</a:t>
             </a:r>
           </a:p>
           <a:p xmlns:a="http://schemas.openxmlformats.org/drawingml/2006/main">
@@ -23762,7 +23816,34 @@
                 <a:ea typeface="Noto Sans CJK SC"/>
                 <a:cs typeface="Noto Sans CJK SC"/>
               </a:rPr>
-              <a:t>献，并形成有依据的判断。</a:t>
+              <a:t>发现不同解释的分歧，</a:t>
+            </a:r>
+          </a:p>
+          <a:p xmlns:a="http://schemas.openxmlformats.org/drawingml/2006/main">
+            <a:pPr algn="l">
+              <a:lnSpc>
+                <a:spcPct val="135000"/>
+              </a:lnSpc>
+              <a:buNone/>
+              <a:defRPr sz="2100" b="0">
+                <a:solidFill>
+                  <a:srgbClr val="111820"/>
+                </a:solidFill>
+                <a:latin typeface="Noto Sans CJK SC"/>
+                <a:ea typeface="Noto Sans CJK SC"/>
+                <a:cs typeface="Noto Sans CJK SC"/>
+              </a:defRPr>
+            </a:pPr>
+            <a:r>
+              <a:rPr sz="2100" b="0">
+                <a:solidFill>
+                  <a:srgbClr val="111820"/>
+                </a:solidFill>
+                <a:latin typeface="Noto Sans CJK SC"/>
+                <a:ea typeface="Noto Sans CJK SC"/>
+                <a:cs typeface="Noto Sans CJK SC"/>
+              </a:rPr>
+              <a:t>据此决定下一步。</a:t>
             </a:r>
           </a:p>
         </p:txBody>
@@ -23988,7 +24069,7 @@
           <p:nvPr/>
         </p:nvPicPr>
         <p:blipFill>
-          <a:blip xmlns:r="http://schemas.openxmlformats.org/officeDocument/2006/relationships" xmlns:a="http://schemas.openxmlformats.org/drawingml/2006/main" r:embed="R6d7375447d3e4283"/>
+          <a:blip xmlns:r="http://schemas.openxmlformats.org/officeDocument/2006/relationships" xmlns:a="http://schemas.openxmlformats.org/drawingml/2006/main" r:embed="R66683a32429a47df"/>
           <a:srcRect xmlns:a="http://schemas.openxmlformats.org/drawingml/2006/main" l="0" t="0" r="0" b="0"/>
           <a:stretch xmlns:a="http://schemas.openxmlformats.org/drawingml/2006/main">
             <a:fillRect l="0" t="0" r="0" b="0"/>
@@ -24121,7 +24202,7 @@
                 <a:ea typeface="Noto Sans CJK SC"/>
                 <a:cs typeface="Noto Sans CJK SC"/>
               </a:rPr>
-              <a:t>这是在帮助学习，</a:t>
+              <a:t>你凭什么判断</a:t>
             </a:r>
           </a:p>
           <a:p xmlns:a="http://schemas.openxmlformats.org/drawingml/2006/main">
@@ -24148,7 +24229,7 @@
                 <a:ea typeface="Noto Sans CJK SC"/>
                 <a:cs typeface="Noto Sans CJK SC"/>
               </a:rPr>
-              <a:t>还是绕过了有价值的活动？</a:t>
+              <a:t>学生学到了，或没有学到？</a:t>
             </a:r>
           </a:p>
         </p:txBody>
@@ -24239,7 +24320,7 @@
                 <a:ea typeface="Noto Sans CJK SC"/>
                 <a:cs typeface="Noto Sans CJK SC"/>
               </a:rPr>
-              <a:t>先写下判断，再补上一条你需要的证据。</a:t>
+              <a:t>写下你的判断，以及最想补看的一条证据。</a:t>
             </a:r>
           </a:p>
         </p:txBody>
@@ -24465,7 +24546,7 @@
           <p:nvPr/>
         </p:nvPicPr>
         <p:blipFill>
-          <a:blip xmlns:r="http://schemas.openxmlformats.org/officeDocument/2006/relationships" xmlns:a="http://schemas.openxmlformats.org/drawingml/2006/main" r:embed="R0ee110b6397b465c"/>
+          <a:blip xmlns:r="http://schemas.openxmlformats.org/officeDocument/2006/relationships" xmlns:a="http://schemas.openxmlformats.org/drawingml/2006/main" r:embed="R7fb6215b6d2f4f98"/>
           <a:srcRect xmlns:a="http://schemas.openxmlformats.org/drawingml/2006/main" l="0" t="0" r="0" b="0"/>
           <a:stretch xmlns:a="http://schemas.openxmlformats.org/drawingml/2006/main">
             <a:fillRect l="0" t="0" r="0" b="0"/>
@@ -24537,7 +24618,7 @@
                 <a:ea typeface="Noto Sans CJK SC"/>
                 <a:cs typeface="Noto Sans CJK SC"/>
               </a:rPr>
-              <a:t>一个好结果，还需要怎样理解？</a:t>
+              <a:t>效果变好了，还要查清为什么</a:t>
             </a:r>
           </a:p>
         </p:txBody>
@@ -24628,7 +24709,7 @@
                 <a:ea typeface="Noto Sans CJK SC"/>
                 <a:cs typeface="Noto Sans CJK SC"/>
               </a:rPr>
-              <a:t>时间</a:t>
+              <a:t>隔一段时间</a:t>
             </a:r>
           </a:p>
         </p:txBody>
@@ -24689,7 +24770,7 @@
                 <a:ea typeface="Noto Sans CJK SC"/>
                 <a:cs typeface="Noto Sans CJK SC"/>
               </a:rPr>
-              <a:t>当堂能够完成，过一段时间或换个任务，</a:t>
+              <a:t>下周再做，或换一个任务，</a:t>
             </a:r>
           </a:p>
           <a:p xmlns:a="http://schemas.openxmlformats.org/drawingml/2006/main">
@@ -24716,7 +24797,7 @@
                 <a:ea typeface="Noto Sans CJK SC"/>
                 <a:cs typeface="Noto Sans CJK SC"/>
               </a:rPr>
-              <a:t>是否仍然成立？</a:t>
+              <a:t>还能解释和运用吗？</a:t>
             </a:r>
           </a:p>
         </p:txBody>
@@ -24807,7 +24888,7 @@
                 <a:ea typeface="Noto Sans CJK SC"/>
                 <a:cs typeface="Noto Sans CJK SC"/>
               </a:rPr>
-              <a:t>反例</a:t>
+              <a:t>看看没成功的</a:t>
             </a:r>
           </a:p>
         </p:txBody>
@@ -24868,7 +24949,7 @@
                 <a:ea typeface="Noto Sans CJK SC"/>
                 <a:cs typeface="Noto Sans CJK SC"/>
               </a:rPr>
-              <a:t>哪些学生没有出现预期变化？</a:t>
+              <a:t>同样的安排，谁没有学会？</a:t>
             </a:r>
           </a:p>
           <a:p xmlns:a="http://schemas.openxmlformats.org/drawingml/2006/main">
@@ -24895,7 +24976,7 @@
                 <a:ea typeface="Noto Sans CJK SC"/>
                 <a:cs typeface="Noto Sans CJK SC"/>
               </a:rPr>
-              <a:t>哪些片段挑战了我们的解释？</a:t>
+              <a:t>他卡在哪一步？</a:t>
             </a:r>
           </a:p>
         </p:txBody>
@@ -24986,7 +25067,7 @@
                 <a:ea typeface="Noto Sans CJK SC"/>
                 <a:cs typeface="Noto Sans CJK SC"/>
               </a:rPr>
-              <a:t>其他解释</a:t>
+              <a:t>查其他变化</a:t>
             </a:r>
           </a:p>
         </p:txBody>
@@ -25047,7 +25128,7 @@
                 <a:ea typeface="Noto Sans CJK SC"/>
                 <a:cs typeface="Noto Sans CJK SC"/>
               </a:rPr>
-              <a:t>也可能来自任务熟悉、追加指导、</a:t>
+              <a:t>是否多了教师指导、同伴帮助，</a:t>
             </a:r>
           </a:p>
           <a:p xmlns:a="http://schemas.openxmlformats.org/drawingml/2006/main">
@@ -25074,7 +25155,7 @@
                 <a:ea typeface="Noto Sans CJK SC"/>
                 <a:cs typeface="Noto Sans CJK SC"/>
               </a:rPr>
-              <a:t>同伴帮助或额外练习。</a:t>
+              <a:t>或者只是更熟悉任务了？</a:t>
             </a:r>
           </a:p>
         </p:txBody>
@@ -25300,7 +25381,7 @@
           <p:nvPr/>
         </p:nvPicPr>
         <p:blipFill>
-          <a:blip xmlns:r="http://schemas.openxmlformats.org/officeDocument/2006/relationships" xmlns:a="http://schemas.openxmlformats.org/drawingml/2006/main" r:embed="R0b5c51af1af74937"/>
+          <a:blip xmlns:r="http://schemas.openxmlformats.org/officeDocument/2006/relationships" xmlns:a="http://schemas.openxmlformats.org/drawingml/2006/main" r:embed="Rc841700169ab4748"/>
           <a:srcRect xmlns:a="http://schemas.openxmlformats.org/drawingml/2006/main" l="0" t="0" r="0" b="0"/>
           <a:stretch xmlns:a="http://schemas.openxmlformats.org/drawingml/2006/main">
             <a:fillRect l="0" t="0" r="0" b="0"/>
@@ -25372,7 +25453,7 @@
                 <a:ea typeface="Noto Sans CJK SC"/>
                 <a:cs typeface="Noto Sans CJK SC"/>
               </a:rPr>
-              <a:t>看不到的，不能直接判作没有</a:t>
+              <a:t>日志没记到，不代表学生没思考</a:t>
             </a:r>
           </a:p>
         </p:txBody>
@@ -25463,7 +25544,7 @@
                 <a:ea typeface="Noto Sans CJK SC"/>
                 <a:cs typeface="Noto Sans CJK SC"/>
               </a:rPr>
-              <a:t>记录的边界</a:t>
+              <a:t>看记录之外</a:t>
             </a:r>
           </a:p>
         </p:txBody>
@@ -25524,7 +25605,7 @@
                 <a:ea typeface="Noto Sans CJK SC"/>
                 <a:cs typeface="Noto Sans CJK SC"/>
               </a:rPr>
-              <a:t>AI日志之外，</a:t>
+              <a:t>纸笔、操作、</a:t>
             </a:r>
           </a:p>
           <a:p xmlns:a="http://schemas.openxmlformats.org/drawingml/2006/main">
@@ -25551,7 +25632,7 @@
                 <a:ea typeface="Noto Sans CJK SC"/>
                 <a:cs typeface="Noto Sans CJK SC"/>
               </a:rPr>
-              <a:t>还可能有纸笔、操作、</a:t>
+              <a:t>同伴讨论和教师追问</a:t>
             </a:r>
           </a:p>
           <a:p xmlns:a="http://schemas.openxmlformats.org/drawingml/2006/main">
@@ -25578,7 +25659,7 @@
                 <a:ea typeface="Noto Sans CJK SC"/>
                 <a:cs typeface="Noto Sans CJK SC"/>
               </a:rPr>
-              <a:t>同伴讨论与口头支持。</a:t>
+              <a:t>也可能承载了思考。</a:t>
             </a:r>
           </a:p>
         </p:txBody>
@@ -25669,7 +25750,7 @@
                 <a:ea typeface="Noto Sans CJK SC"/>
                 <a:cs typeface="Noto Sans CJK SC"/>
               </a:rPr>
-              <a:t>归因的边界</a:t>
+              <a:t>分清个人与小组</a:t>
             </a:r>
           </a:p>
         </p:txBody>
@@ -25730,7 +25811,7 @@
                 <a:ea typeface="Noto Sans CJK SC"/>
                 <a:cs typeface="Noto Sans CJK SC"/>
               </a:rPr>
-              <a:t>小组产出不等于</a:t>
+              <a:t>报告由谁写、理由谁懂，</a:t>
             </a:r>
           </a:p>
           <a:p xmlns:a="http://schemas.openxmlformats.org/drawingml/2006/main">
@@ -25757,7 +25838,7 @@
                 <a:ea typeface="Noto Sans CJK SC"/>
                 <a:cs typeface="Noto Sans CJK SC"/>
               </a:rPr>
-              <a:t>每个成员都理解；</a:t>
+              <a:t>要分别了解；</a:t>
             </a:r>
           </a:p>
           <a:p xmlns:a="http://schemas.openxmlformats.org/drawingml/2006/main">
@@ -25784,7 +25865,7 @@
                 <a:ea typeface="Noto Sans CJK SC"/>
                 <a:cs typeface="Noto Sans CJK SC"/>
               </a:rPr>
-              <a:t>没有发言不等于没思考。</a:t>
+              <a:t>安静也不等于没想法。</a:t>
             </a:r>
           </a:p>
         </p:txBody>
@@ -25875,7 +25956,7 @@
                 <a:ea typeface="Noto Sans CJK SC"/>
                 <a:cs typeface="Noto Sans CJK SC"/>
               </a:rPr>
-              <a:t>补充观察</a:t>
+              <a:t>补一个小检查</a:t>
             </a:r>
           </a:p>
         </p:txBody>
@@ -25936,7 +26017,7 @@
                 <a:ea typeface="Noto Sans CJK SC"/>
                 <a:cs typeface="Noto Sans CJK SC"/>
               </a:rPr>
-              <a:t>通过短解释、</a:t>
+              <a:t>请不同成员解释一处，</a:t>
             </a:r>
           </a:p>
           <a:p xmlns:a="http://schemas.openxmlformats.org/drawingml/2006/main">
@@ -25963,7 +26044,7 @@
                 <a:ea typeface="Noto Sans CJK SC"/>
                 <a:cs typeface="Noto Sans CJK SC"/>
               </a:rPr>
-              <a:t>个别追问或新任务，</a:t>
+              <a:t>画出来或操作给你看，</a:t>
             </a:r>
           </a:p>
           <a:p xmlns:a="http://schemas.openxmlformats.org/drawingml/2006/main">
@@ -25990,7 +26071,7 @@
                 <a:ea typeface="Noto Sans CJK SC"/>
                 <a:cs typeface="Noto Sans CJK SC"/>
               </a:rPr>
-              <a:t>了解不同学生的理解。</a:t>
+              <a:t>再判断理解到哪里。</a:t>
             </a:r>
           </a:p>
         </p:txBody>
@@ -26202,7 +26283,7 @@
                 <a:ea typeface="Noto Sans CJK SC"/>
                 <a:cs typeface="Noto Sans CJK SC"/>
               </a:rPr>
-              <a:t>讨论情境 · 以下均为假设新增材料</a:t>
+              <a:t>假设课堂 · 再补两条材料</a:t>
             </a:r>
           </a:p>
         </p:txBody>
@@ -26216,7 +26297,7 @@
           <p:nvPr/>
         </p:nvPicPr>
         <p:blipFill>
-          <a:blip xmlns:r="http://schemas.openxmlformats.org/officeDocument/2006/relationships" xmlns:a="http://schemas.openxmlformats.org/drawingml/2006/main" r:embed="Re9f4463f887543a3"/>
+          <a:blip xmlns:r="http://schemas.openxmlformats.org/officeDocument/2006/relationships" xmlns:a="http://schemas.openxmlformats.org/drawingml/2006/main" r:embed="R7cdb2e04a8a64b98"/>
           <a:srcRect xmlns:a="http://schemas.openxmlformats.org/drawingml/2006/main" l="0" t="0" r="0" b="0"/>
           <a:stretch xmlns:a="http://schemas.openxmlformats.org/drawingml/2006/main">
             <a:fillRect l="0" t="0" r="0" b="0"/>
@@ -26288,7 +26369,7 @@
                 <a:ea typeface="Noto Sans CJK SC"/>
                 <a:cs typeface="Noto Sans CJK SC"/>
               </a:rPr>
-              <a:t>第三次判断：下一课怎样安排？</a:t>
+              <a:t>第三次判断：下一课先做什么？</a:t>
             </a:r>
           </a:p>
         </p:txBody>
@@ -26677,7 +26758,7 @@
                 <a:ea typeface="Noto Sans CJK SC"/>
                 <a:cs typeface="Noto Sans CJK SC"/>
               </a:rPr>
-              <a:t>哪些判断获得支持？还缺什么？你会先改变哪一处安排？</a:t>
+              <a:t>你会先补问谁、追问什么，或改动哪一个教学环节？</a:t>
             </a:r>
           </a:p>
         </p:txBody>
@@ -26903,7 +26984,7 @@
           <p:nvPr/>
         </p:nvPicPr>
         <p:blipFill>
-          <a:blip xmlns:r="http://schemas.openxmlformats.org/officeDocument/2006/relationships" xmlns:a="http://schemas.openxmlformats.org/drawingml/2006/main" r:embed="R8b6b585e7d884f76"/>
+          <a:blip xmlns:r="http://schemas.openxmlformats.org/officeDocument/2006/relationships" xmlns:a="http://schemas.openxmlformats.org/drawingml/2006/main" r:embed="Rb65b770a6fb34fb2"/>
           <a:srcRect xmlns:a="http://schemas.openxmlformats.org/drawingml/2006/main" l="0" t="0" r="0" b="0"/>
           <a:stretch xmlns:a="http://schemas.openxmlformats.org/drawingml/2006/main">
             <a:fillRect l="0" t="0" r="0" b="0"/>
@@ -26975,7 +27056,7 @@
                 <a:ea typeface="Noto Sans CJK SC"/>
                 <a:cs typeface="Noto Sans CJK SC"/>
               </a:rPr>
-              <a:t>继续阅读的四个入口</a:t>
+              <a:t>四份值得继续读的材料</a:t>
             </a:r>
           </a:p>
         </p:txBody>
@@ -27890,7 +27971,7 @@
           <p:nvPr/>
         </p:nvPicPr>
         <p:blipFill>
-          <a:blip xmlns:r="http://schemas.openxmlformats.org/officeDocument/2006/relationships" xmlns:a="http://schemas.openxmlformats.org/drawingml/2006/main" r:embed="Rb0e1b5644ab242ad"/>
+          <a:blip xmlns:r="http://schemas.openxmlformats.org/officeDocument/2006/relationships" xmlns:a="http://schemas.openxmlformats.org/drawingml/2006/main" r:embed="R0ffa7826a6854375"/>
           <a:srcRect xmlns:a="http://schemas.openxmlformats.org/drawingml/2006/main" l="0" t="0" r="0" b="0"/>
           <a:stretch xmlns:a="http://schemas.openxmlformats.org/drawingml/2006/main">
             <a:fillRect l="0" t="0" r="0" b="0"/>
@@ -27962,7 +28043,7 @@
                 <a:ea typeface="Noto Sans CJK SC"/>
                 <a:cs typeface="Noto Sans CJK SC"/>
               </a:rPr>
-              <a:t>备课与教研的五问卡</a:t>
+              <a:t>下一次备课，写下这五个回答</a:t>
             </a:r>
           </a:p>
         </p:txBody>
@@ -28053,7 +28134,7 @@
                 <a:ea typeface="Noto Sans CJK SC"/>
                 <a:cs typeface="Noto Sans CJK SC"/>
               </a:rPr>
-              <a:t>01 目标</a:t>
+              <a:t>01 学什么</a:t>
             </a:r>
           </a:p>
         </p:txBody>
@@ -28114,7 +28195,7 @@
                 <a:ea typeface="Noto Sans CJK SC"/>
                 <a:cs typeface="Noto Sans CJK SC"/>
               </a:rPr>
-              <a:t>希望学生获得什么发展？</a:t>
+              <a:t>学生这次要学会什么？</a:t>
             </a:r>
           </a:p>
         </p:txBody>
@@ -28205,7 +28286,7 @@
                 <a:ea typeface="Noto Sans CJK SC"/>
                 <a:cs typeface="Noto Sans CJK SC"/>
               </a:rPr>
-              <a:t>02 活动</a:t>
+              <a:t>02 怎么学</a:t>
             </a:r>
           </a:p>
         </p:txBody>
@@ -28266,7 +28347,7 @@
                 <a:ea typeface="Noto Sans CJK SC"/>
                 <a:cs typeface="Noto Sans CJK SC"/>
               </a:rPr>
-              <a:t>为此，需要经历哪些有价值的活动？</a:t>
+              <a:t>哪一步需要他们亲自想、亲自做？</a:t>
             </a:r>
           </a:p>
         </p:txBody>
@@ -28357,7 +28438,7 @@
                 <a:ea typeface="Noto Sans CJK SC"/>
                 <a:cs typeface="Noto Sans CJK SC"/>
               </a:rPr>
-              <a:t>03 AI</a:t>
+              <a:t>03 AI做什么</a:t>
             </a:r>
           </a:p>
         </p:txBody>
@@ -28418,7 +28499,7 @@
                 <a:ea typeface="Noto Sans CJK SC"/>
                 <a:cs typeface="Noto Sans CJK SC"/>
               </a:rPr>
-              <a:t>AI怎样支持、改变或拓展这些活动？</a:t>
+              <a:t>交给AI哪些工作，会怎样改变学习？</a:t>
             </a:r>
           </a:p>
         </p:txBody>
@@ -28509,7 +28590,7 @@
                 <a:ea typeface="Noto Sans CJK SC"/>
                 <a:cs typeface="Noto Sans CJK SC"/>
               </a:rPr>
-              <a:t>04 机会</a:t>
+              <a:t>04 看谁</a:t>
             </a:r>
           </a:p>
         </p:txBody>
@@ -28570,7 +28651,7 @@
                 <a:ea typeface="Noto Sans CJK SC"/>
                 <a:cs typeface="Noto Sans CJK SC"/>
               </a:rPr>
-              <a:t>谁获得了机会，谁还需要不同的支持？</a:t>
+              <a:t>谁有机会解释和决定？谁还没参与？</a:t>
             </a:r>
           </a:p>
         </p:txBody>
@@ -28661,7 +28742,7 @@
                 <a:ea typeface="Noto Sans CJK SC"/>
                 <a:cs typeface="Noto Sans CJK SC"/>
               </a:rPr>
-              <a:t>05 修订</a:t>
+              <a:t>05 怎样改</a:t>
             </a:r>
           </a:p>
         </p:txBody>
@@ -28722,7 +28803,7 @@
                 <a:ea typeface="Noto Sans CJK SC"/>
                 <a:cs typeface="Noto Sans CJK SC"/>
               </a:rPr>
-              <a:t>什么证据会让我改变现在的安排？</a:t>
+              <a:t>看到什么表现，我会调整这次安排？</a:t>
             </a:r>
           </a:p>
         </p:txBody>
@@ -28948,7 +29029,7 @@
           <p:nvPr/>
         </p:nvPicPr>
         <p:blipFill>
-          <a:blip xmlns:r="http://schemas.openxmlformats.org/officeDocument/2006/relationships" xmlns:a="http://schemas.openxmlformats.org/drawingml/2006/main" r:embed="R8d708ef885ac42f1"/>
+          <a:blip xmlns:r="http://schemas.openxmlformats.org/officeDocument/2006/relationships" xmlns:a="http://schemas.openxmlformats.org/drawingml/2006/main" r:embed="Rd3c88959d8da4b7b"/>
           <a:srcRect xmlns:a="http://schemas.openxmlformats.org/drawingml/2006/main" l="0" t="0" r="0" b="0"/>
           <a:stretch xmlns:a="http://schemas.openxmlformats.org/drawingml/2006/main">
             <a:fillRect l="0" t="0" r="0" b="0"/>
@@ -29020,7 +29101,7 @@
                 <a:ea typeface="Noto Sans CJK SC"/>
                 <a:cs typeface="Noto Sans CJK SC"/>
               </a:rPr>
-              <a:t>用三分钟，重设计一个环节</a:t>
+              <a:t>选一节课，只改一个环节</a:t>
             </a:r>
           </a:p>
         </p:txBody>
@@ -29081,7 +29162,7 @@
                 <a:ea typeface="Noto Sans CJK SC"/>
                 <a:cs typeface="Noto Sans CJK SC"/>
               </a:rPr>
-              <a:t>第1分钟</a:t>
+              <a:t>先定目标</a:t>
             </a:r>
           </a:p>
         </p:txBody>
@@ -29142,7 +29223,7 @@
                 <a:ea typeface="Noto Sans CJK SC"/>
                 <a:cs typeface="Noto Sans CJK SC"/>
               </a:rPr>
-              <a:t>明确一个发展目标，以及学生需要经历的关键活动。</a:t>
+              <a:t>写出学生要学会的一件事，以及需要亲历的一步。</a:t>
             </a:r>
           </a:p>
         </p:txBody>
@@ -29203,7 +29284,7 @@
                 <a:ea typeface="Noto Sans CJK SC"/>
                 <a:cs typeface="Noto Sans CJK SC"/>
               </a:rPr>
-              <a:t>第2分钟</a:t>
+              <a:t>再改安排</a:t>
             </a:r>
           </a:p>
         </p:txBody>
@@ -29264,7 +29345,7 @@
                 <a:ea typeface="Noto Sans CJK SC"/>
                 <a:cs typeface="Noto Sans CJK SC"/>
               </a:rPr>
-              <a:t>决定AI、学生和同伴怎样参与，选一处调整。</a:t>
+              <a:t>明确AI做什么、学生做什么，调整一处分工或顺序。</a:t>
             </a:r>
           </a:p>
         </p:txBody>
@@ -29325,7 +29406,7 @@
                 <a:ea typeface="Noto Sans CJK SC"/>
                 <a:cs typeface="Noto Sans CJK SC"/>
               </a:rPr>
-              <a:t>第3分钟</a:t>
+              <a:t>与同伴核对</a:t>
             </a:r>
           </a:p>
         </p:txBody>
@@ -29386,7 +29467,7 @@
                 <a:ea typeface="Noto Sans CJK SC"/>
                 <a:cs typeface="Noto Sans CJK SC"/>
               </a:rPr>
-              <a:t>与同伴交流：准备观察什么？什么情况会让你再次修改？</a:t>
+              <a:t>你准备看什么？如果没有发生，下一步怎么办？</a:t>
             </a:r>
           </a:p>
         </p:txBody>
@@ -29477,7 +29558,7 @@
                 <a:ea typeface="Noto Sans CJK SC"/>
                 <a:cs typeface="Noto Sans CJK SC"/>
               </a:rPr>
-              <a:t>选择你近期要上的一节课，写下一个可以尝试的改动。</a:t>
+              <a:t>把改动写到下周的教案里，并约同伴一起看效果。</a:t>
             </a:r>
           </a:p>
         </p:txBody>
@@ -29642,7 +29723,7 @@
           <p:nvPr/>
         </p:nvPicPr>
         <p:blipFill>
-          <a:blip xmlns:r="http://schemas.openxmlformats.org/officeDocument/2006/relationships" xmlns:a="http://schemas.openxmlformats.org/drawingml/2006/main" r:embed="Rc44c969915ae414f"/>
+          <a:blip xmlns:r="http://schemas.openxmlformats.org/officeDocument/2006/relationships" xmlns:a="http://schemas.openxmlformats.org/drawingml/2006/main" r:embed="R0a11df271eda45cb"/>
           <a:srcRect xmlns:a="http://schemas.openxmlformats.org/drawingml/2006/main" l="0" t="0" r="0" b="0"/>
           <a:stretch xmlns:a="http://schemas.openxmlformats.org/drawingml/2006/main">
             <a:fillRect l="0" t="0" r="0" b="0"/>
@@ -29797,7 +29878,7 @@
         <p:spPr>
           <a:xfrm xmlns:a="http://schemas.openxmlformats.org/drawingml/2006/main">
             <a:off x="685800" y="3590925"/>
-            <a:ext cx="9810750" cy="542925"/>
+            <a:ext cx="9810750" cy="1028700"/>
           </a:xfrm>
           <a:prstGeom xmlns:a="http://schemas.openxmlformats.org/drawingml/2006/main" prst="rect">
             <a:avLst/>
@@ -29836,7 +29917,34 @@
                 <a:ea typeface="Noto Sans CJK SC"/>
                 <a:cs typeface="Noto Sans CJK SC"/>
               </a:rPr>
-              <a:t>让人更有能力理解、判断、创造，并与他人共同开展有意义的活动。</a:t>
+              <a:t>让学生能解释自己的想法，</a:t>
+            </a:r>
+          </a:p>
+          <a:p xmlns:a="http://schemas.openxmlformats.org/drawingml/2006/main">
+            <a:pPr algn="l">
+              <a:lnSpc>
+                <a:spcPct val="150000"/>
+              </a:lnSpc>
+              <a:buNone/>
+              <a:defRPr sz="2550" b="0">
+                <a:solidFill>
+                  <a:srgbClr val="53616C"/>
+                </a:solidFill>
+                <a:latin typeface="Noto Sans CJK SC"/>
+                <a:ea typeface="Noto Sans CJK SC"/>
+                <a:cs typeface="Noto Sans CJK SC"/>
+              </a:defRPr>
+            </a:pPr>
+            <a:r>
+              <a:rPr sz="2550" b="0">
+                <a:solidFill>
+                  <a:srgbClr val="53616C"/>
+                </a:solidFill>
+                <a:latin typeface="Noto Sans CJK SC"/>
+                <a:ea typeface="Noto Sans CJK SC"/>
+                <a:cs typeface="Noto Sans CJK SC"/>
+              </a:rPr>
+              <a:t>在新问题面前作出判断，与他人一起把事情做成。</a:t>
             </a:r>
           </a:p>
         </p:txBody>
@@ -29927,7 +30035,7 @@
                 <a:ea typeface="Noto Sans CJK SC"/>
                 <a:cs typeface="Noto Sans CJK SC"/>
               </a:rPr>
-              <a:t>回到你的课堂：你最希望学生获得什么发展，又准备为此创造怎样的机会？</a:t>
+              <a:t>下一节课，你准备让学生亲自作出哪个有分量的判断？</a:t>
             </a:r>
           </a:p>
         </p:txBody>
@@ -30153,7 +30261,7 @@
           <p:nvPr/>
         </p:nvPicPr>
         <p:blipFill>
-          <a:blip xmlns:r="http://schemas.openxmlformats.org/officeDocument/2006/relationships" xmlns:a="http://schemas.openxmlformats.org/drawingml/2006/main" r:embed="Red67761e1c964a6e"/>
+          <a:blip xmlns:r="http://schemas.openxmlformats.org/officeDocument/2006/relationships" xmlns:a="http://schemas.openxmlformats.org/drawingml/2006/main" r:embed="Rd5644472372f402f"/>
           <a:srcRect xmlns:a="http://schemas.openxmlformats.org/drawingml/2006/main" l="0" t="0" r="0" b="0"/>
           <a:stretch xmlns:a="http://schemas.openxmlformats.org/drawingml/2006/main">
             <a:fillRect l="0" t="0" r="0" b="0"/>
@@ -30225,7 +30333,7 @@
                 <a:ea typeface="Noto Sans CJK SC"/>
                 <a:cs typeface="Noto Sans CJK SC"/>
               </a:rPr>
-              <a:t>同一份方案，可以进入不同的课</a:t>
+              <a:t>先说清这节课要教什么</a:t>
             </a:r>
           </a:p>
         </p:txBody>
@@ -30286,7 +30394,7 @@
                 <a:ea typeface="Noto Sans CJK SC"/>
                 <a:cs typeface="Noto Sans CJK SC"/>
               </a:rPr>
-              <a:t>目标和学生起点，会改变我们期待的学习活动。</a:t>
+              <a:t>同一份AI方案，放在三种课里，用途不同。</a:t>
             </a:r>
           </a:p>
         </p:txBody>
@@ -30914,7 +31022,7 @@
                 <a:ea typeface="Noto Sans CJK SC"/>
                 <a:cs typeface="Noto Sans CJK SC"/>
               </a:rPr>
-              <a:t>还要继续看：这些活动实际发生了吗？</a:t>
+              <a:t>备课时选定的用途，在课堂上发生了吗？</a:t>
             </a:r>
           </a:p>
         </p:txBody>
@@ -31140,7 +31248,7 @@
           <p:nvPr/>
         </p:nvPicPr>
         <p:blipFill>
-          <a:blip xmlns:r="http://schemas.openxmlformats.org/officeDocument/2006/relationships" xmlns:a="http://schemas.openxmlformats.org/drawingml/2006/main" r:embed="R04158cc3d524437a"/>
+          <a:blip xmlns:r="http://schemas.openxmlformats.org/officeDocument/2006/relationships" xmlns:a="http://schemas.openxmlformats.org/drawingml/2006/main" r:embed="Rfdf4713cab81408d"/>
           <a:srcRect xmlns:a="http://schemas.openxmlformats.org/drawingml/2006/main" l="0" t="0" r="0" b="0"/>
           <a:stretch xmlns:a="http://schemas.openxmlformats.org/drawingml/2006/main">
             <a:fillRect l="0" t="0" r="0" b="0"/>
@@ -31212,7 +31320,7 @@
                 <a:ea typeface="Noto Sans CJK SC"/>
                 <a:cs typeface="Noto Sans CJK SC"/>
               </a:rPr>
-              <a:t>教学价值需要沿着学习过程判断</a:t>
+              <a:t>AI做完的工作，怎样成为学生的本领？</a:t>
             </a:r>
           </a:p>
         </p:txBody>
@@ -31273,7 +31381,7 @@
                 <a:ea typeface="Noto Sans CJK SC"/>
                 <a:cs typeface="Noto Sans CJK SC"/>
               </a:rPr>
-              <a:t>希望人获得什么发展？</a:t>
+              <a:t>学生要学会什么？</a:t>
             </a:r>
           </a:p>
           <a:p xmlns:a="http://schemas.openxmlformats.org/drawingml/2006/main">
@@ -31300,7 +31408,7 @@
                 <a:ea typeface="Noto Sans CJK SC"/>
                 <a:cs typeface="Noto Sans CJK SC"/>
               </a:rPr>
-              <a:t>怎样为这种发展创造机会？</a:t>
+              <a:t>哪一步需要亲自想、亲自做？</a:t>
             </a:r>
           </a:p>
           <a:p xmlns:a="http://schemas.openxmlformats.org/drawingml/2006/main">
@@ -31327,7 +31435,7 @@
                 <a:ea typeface="Noto Sans CJK SC"/>
                 <a:cs typeface="Noto Sans CJK SC"/>
               </a:rPr>
-              <a:t>依据什么证据调整安排？</a:t>
+              <a:t>学会没有，怎样看出来？</a:t>
             </a:r>
           </a:p>
         </p:txBody>
@@ -31418,7 +31526,7 @@
                 <a:ea typeface="Noto Sans CJK SC"/>
                 <a:cs typeface="Noto Sans CJK SC"/>
               </a:rPr>
-              <a:t>AI承担了多少工作，仍需要放回这些问题中理解。</a:t>
+              <a:t>判断AI用得好不好，先回答这三个问题。</a:t>
             </a:r>
           </a:p>
         </p:txBody>
@@ -31644,7 +31752,7 @@
           <p:nvPr/>
         </p:nvPicPr>
         <p:blipFill>
-          <a:blip xmlns:r="http://schemas.openxmlformats.org/officeDocument/2006/relationships" xmlns:a="http://schemas.openxmlformats.org/drawingml/2006/main" r:embed="R5ed6461dc6704e3c"/>
+          <a:blip xmlns:r="http://schemas.openxmlformats.org/officeDocument/2006/relationships" xmlns:a="http://schemas.openxmlformats.org/drawingml/2006/main" r:embed="R1177c984ea6f46cc"/>
           <a:srcRect xmlns:a="http://schemas.openxmlformats.org/drawingml/2006/main" l="0" t="0" r="0" b="0"/>
           <a:stretch xmlns:a="http://schemas.openxmlformats.org/drawingml/2006/main">
             <a:fillRect l="0" t="0" r="0" b="0"/>
@@ -31716,7 +31824,7 @@
                 <a:ea typeface="Noto Sans CJK SC"/>
                 <a:cs typeface="Noto Sans CJK SC"/>
               </a:rPr>
-              <a:t>学习目标本身，也值得重新审视</a:t>
+              <a:t>有些任务要保留，有些值得重做</a:t>
             </a:r>
           </a:p>
         </p:txBody>
@@ -31777,7 +31885,7 @@
                 <a:ea typeface="Noto Sans CJK SC"/>
                 <a:cs typeface="Noto Sans CJK SC"/>
               </a:rPr>
-              <a:t>AI进入课堂后，三类教学选择都值得讨论。</a:t>
+              <a:t>先检查旧任务的教学用处，再决定AI怎样介入。</a:t>
             </a:r>
           </a:p>
         </p:txBody>
@@ -31929,7 +32037,7 @@
                 <a:ea typeface="Noto Sans CJK SC"/>
                 <a:cs typeface="Noto Sans CJK SC"/>
               </a:rPr>
-              <a:t>为理解与判断打基础</a:t>
+              <a:t>解释证据、检验结论</a:t>
             </a:r>
           </a:p>
           <a:p xmlns:a="http://schemas.openxmlformats.org/drawingml/2006/main">
@@ -31956,7 +32064,7 @@
                 <a:ea typeface="Noto Sans CJK SC"/>
                 <a:cs typeface="Noto Sans CJK SC"/>
               </a:rPr>
-              <a:t>例如解释证据的含义</a:t>
+              <a:t>这些理解仍须建立</a:t>
             </a:r>
           </a:p>
         </p:txBody>
@@ -32108,7 +32216,7 @@
                 <a:ea typeface="Noto Sans CJK SC"/>
                 <a:cs typeface="Noto Sans CJK SC"/>
               </a:rPr>
-              <a:t>改变原任务的重心</a:t>
+              <a:t>AI先整理资料</a:t>
             </a:r>
           </a:p>
           <a:p xmlns:a="http://schemas.openxmlformats.org/drawingml/2006/main">
@@ -32135,7 +32243,7 @@
                 <a:ea typeface="Noto Sans CJK SC"/>
                 <a:cs typeface="Noto Sans CJK SC"/>
               </a:rPr>
-              <a:t>例如从整理转向比较</a:t>
+              <a:t>学生集中比较分歧</a:t>
             </a:r>
           </a:p>
         </p:txBody>
@@ -32226,7 +32334,7 @@
                 <a:ea typeface="Noto Sans CJK SC"/>
                 <a:cs typeface="Noto Sans CJK SC"/>
               </a:rPr>
-              <a:t>创造</a:t>
+              <a:t>新增</a:t>
             </a:r>
           </a:p>
         </p:txBody>
@@ -32287,7 +32395,7 @@
                 <a:ea typeface="Noto Sans CJK SC"/>
                 <a:cs typeface="Noto Sans CJK SC"/>
               </a:rPr>
-              <a:t>提出原来难以开展的任务</a:t>
+              <a:t>借助多个备选解释</a:t>
             </a:r>
           </a:p>
           <a:p xmlns:a="http://schemas.openxmlformats.org/drawingml/2006/main">
@@ -32314,7 +32422,7 @@
                 <a:ea typeface="Noto Sans CJK SC"/>
                 <a:cs typeface="Noto Sans CJK SC"/>
               </a:rPr>
-              <a:t>例如检验多个竞争解释</a:t>
+              <a:t>研究原先难以处理的问题</a:t>
             </a:r>
           </a:p>
         </p:txBody>
@@ -32405,7 +32513,7 @@
                 <a:ea typeface="Noto Sans CJK SC"/>
                 <a:cs typeface="Noto Sans CJK SC"/>
               </a:rPr>
-              <a:t>具体保留什么，应当说明它对学生发展的意义。</a:t>
+              <a:t>这项工作为什么值得学生花时间？</a:t>
             </a:r>
           </a:p>
         </p:txBody>
@@ -32631,7 +32739,7 @@
           <p:nvPr/>
         </p:nvPicPr>
         <p:blipFill>
-          <a:blip xmlns:r="http://schemas.openxmlformats.org/officeDocument/2006/relationships" xmlns:a="http://schemas.openxmlformats.org/drawingml/2006/main" r:embed="Rae399868b1b64864"/>
+          <a:blip xmlns:r="http://schemas.openxmlformats.org/officeDocument/2006/relationships" xmlns:a="http://schemas.openxmlformats.org/drawingml/2006/main" r:embed="R7e0038f5351841b1"/>
           <a:srcRect xmlns:a="http://schemas.openxmlformats.org/drawingml/2006/main" l="0" t="0" r="0" b="0"/>
           <a:stretch xmlns:a="http://schemas.openxmlformats.org/drawingml/2006/main">
             <a:fillRect l="0" t="0" r="0" b="0"/>
@@ -32703,7 +32811,7 @@
                 <a:ea typeface="Noto Sans CJK SC"/>
                 <a:cs typeface="Noto Sans CJK SC"/>
               </a:rPr>
-              <a:t>作品、活动与发展，需要连起来看</a:t>
+              <a:t>好作品只是判断学习的起点</a:t>
             </a:r>
           </a:p>
         </p:txBody>
@@ -33433,7 +33541,7 @@
                 <a:ea typeface="Noto Sans CJK SC"/>
                 <a:cs typeface="Noto Sans CJK SC"/>
               </a:rPr>
-              <a:t>三者之间的联系，需要过程与后续证据支持。</a:t>
+              <a:t>顺着作品追问：怎么做出来的？下次还能怎样做？</a:t>
             </a:r>
           </a:p>
         </p:txBody>
@@ -33659,7 +33767,7 @@
           <p:nvPr/>
         </p:nvPicPr>
         <p:blipFill>
-          <a:blip xmlns:r="http://schemas.openxmlformats.org/officeDocument/2006/relationships" xmlns:a="http://schemas.openxmlformats.org/drawingml/2006/main" r:embed="R6202162da6804e5e"/>
+          <a:blip xmlns:r="http://schemas.openxmlformats.org/officeDocument/2006/relationships" xmlns:a="http://schemas.openxmlformats.org/drawingml/2006/main" r:embed="R9c0033dcef8f46ec"/>
           <a:srcRect xmlns:a="http://schemas.openxmlformats.org/drawingml/2006/main" l="0" t="0" r="0" b="0"/>
           <a:stretch xmlns:a="http://schemas.openxmlformats.org/drawingml/2006/main">
             <a:fillRect l="0" t="0" r="0" b="0"/>
@@ -33731,7 +33839,7 @@
                 <a:ea typeface="Noto Sans CJK SC"/>
                 <a:cs typeface="Noto Sans CJK SC"/>
               </a:rPr>
-              <a:t>支持：让学生进入有价值的活动</a:t>
+              <a:t>AI的帮助，要让学生接得上</a:t>
             </a:r>
           </a:p>
         </p:txBody>
@@ -33792,7 +33900,7 @@
                 <a:ea typeface="Noto Sans CJK SC"/>
                 <a:cs typeface="Noto Sans CJK SC"/>
               </a:rPr>
-              <a:t>AI帮助读懂材料、整理记录或比较方案。</a:t>
+              <a:t>AI整理观察记录后，学生能否读出其中的差异？</a:t>
             </a:r>
           </a:p>
         </p:txBody>
@@ -33853,7 +33961,7 @@
                 <a:ea typeface="Noto Sans CJK SC"/>
                 <a:cs typeface="Noto Sans CJK SC"/>
               </a:rPr>
-              <a:t>获得的机会</a:t>
+              <a:t>接得上</a:t>
             </a:r>
           </a:p>
         </p:txBody>
@@ -33914,7 +34022,7 @@
                 <a:ea typeface="Noto Sans CJK SC"/>
                 <a:cs typeface="Noto Sans CJK SC"/>
               </a:rPr>
-              <a:t>学生有条件解释差异、提出问题、检验想法</a:t>
+              <a:t>指出变化，提出解释，再用记录检验自己的想法</a:t>
             </a:r>
           </a:p>
         </p:txBody>
@@ -33975,7 +34083,7 @@
                 <a:ea typeface="Noto Sans CJK SC"/>
                 <a:cs typeface="Noto Sans CJK SC"/>
               </a:rPr>
-              <a:t>需要观察</a:t>
+              <a:t>接不上</a:t>
             </a:r>
           </a:p>
         </p:txBody>
@@ -34036,7 +34144,7 @@
                 <a:ea typeface="Noto Sans CJK SC"/>
                 <a:cs typeface="Noto Sans CJK SC"/>
               </a:rPr>
-              <a:t>这些支持是否真正进入学生的推理和决定？</a:t>
+              <a:t>表格更清楚了，却说不出哪条记录支持结论</a:t>
             </a:r>
           </a:p>
         </p:txBody>
@@ -34127,7 +34235,7 @@
                 <a:ea typeface="Noto Sans CJK SC"/>
                 <a:cs typeface="Noto Sans CJK SC"/>
               </a:rPr>
-              <a:t>支持的价值，要看学生因此能够参与什么。</a:t>
+              <a:t>帮助之后，学生多做了哪一步思考？</a:t>
             </a:r>
           </a:p>
         </p:txBody>
@@ -34353,7 +34461,7 @@
           <p:nvPr/>
         </p:nvPicPr>
         <p:blipFill>
-          <a:blip xmlns:r="http://schemas.openxmlformats.org/officeDocument/2006/relationships" xmlns:a="http://schemas.openxmlformats.org/drawingml/2006/main" r:embed="R1ab3358c3eae405f"/>
+          <a:blip xmlns:r="http://schemas.openxmlformats.org/officeDocument/2006/relationships" xmlns:a="http://schemas.openxmlformats.org/drawingml/2006/main" r:embed="R676d6a47d6d5460d"/>
           <a:srcRect xmlns:a="http://schemas.openxmlformats.org/drawingml/2006/main" l="0" t="0" r="0" b="0"/>
           <a:stretch xmlns:a="http://schemas.openxmlformats.org/drawingml/2006/main">
             <a:fillRect l="0" t="0" r="0" b="0"/>
@@ -34425,7 +34533,7 @@
                 <a:ea typeface="Noto Sans CJK SC"/>
                 <a:cs typeface="Noto Sans CJK SC"/>
               </a:rPr>
-              <a:t>绕过了哪一步，才是关键</a:t>
+              <a:t>省下的是杂务，还是学习的关键一步？</a:t>
             </a:r>
           </a:p>
         </p:txBody>
@@ -34874,7 +34982,7 @@
                 <a:ea typeface="Noto Sans CJK SC"/>
                 <a:cs typeface="Noto Sans CJK SC"/>
               </a:rPr>
-              <a:t>同一步工作，对不同目标可能有不同意义。</a:t>
+              <a:t>同一步工作，要结合这节课的目标来判断。</a:t>
             </a:r>
           </a:p>
         </p:txBody>

</xml_diff>